<commit_message>
Minor changes to W3-4.
</commit_message>
<xml_diff>
--- a/W3/1. W3S1 final/W3S1.pptx
+++ b/W3/1. W3S1 final/W3S1.pptx
@@ -261,2040 +261,56 @@
 <file path=ppt/changesInfos/changesInfo1.xml><?xml version="1.0" encoding="utf-8"?>
 <pc:chgInfo xmlns:a="http://schemas.openxmlformats.org/drawingml/2006/main" xmlns:r="http://schemas.openxmlformats.org/officeDocument/2006/relationships" xmlns:ac="http://schemas.microsoft.com/office/drawing/2013/main/command" xmlns:pc="http://schemas.microsoft.com/office/powerpoint/2013/main/command">
   <pc:docChgLst>
-    <pc:chgData name="Matthieu De Mari" userId="dfb708c9-d8dc-439f-9a3b-c772bf4a311c" providerId="ADAL" clId="{D2FDBEB2-E663-41FC-8A3C-AC79657DF6AB}"/>
-    <pc:docChg chg="undo custSel addSld delSld modSld sldOrd addSection delSection modSection">
-      <pc:chgData name="Matthieu De Mari" userId="dfb708c9-d8dc-439f-9a3b-c772bf4a311c" providerId="ADAL" clId="{D2FDBEB2-E663-41FC-8A3C-AC79657DF6AB}" dt="2023-02-03T09:13:37.539" v="8349" actId="22"/>
+    <pc:chgData name="Matthieu De Mari" userId="dfb708c9-d8dc-439f-9a3b-c772bf4a311c" providerId="ADAL" clId="{81E9B007-0C2C-493E-9B93-55A62C9C1F12}"/>
+    <pc:docChg chg="modSld">
+      <pc:chgData name="Matthieu De Mari" userId="dfb708c9-d8dc-439f-9a3b-c772bf4a311c" providerId="ADAL" clId="{81E9B007-0C2C-493E-9B93-55A62C9C1F12}" dt="2025-12-18T22:20:21.245" v="2" actId="20577"/>
       <pc:docMkLst>
         <pc:docMk/>
       </pc:docMkLst>
       <pc:sldChg chg="modSp mod">
-        <pc:chgData name="Matthieu De Mari" userId="dfb708c9-d8dc-439f-9a3b-c772bf4a311c" providerId="ADAL" clId="{D2FDBEB2-E663-41FC-8A3C-AC79657DF6AB}" dt="2023-01-31T09:38:27.909" v="1" actId="20577"/>
-        <pc:sldMkLst>
-          <pc:docMk/>
-          <pc:sldMk cId="3442501962" sldId="257"/>
-        </pc:sldMkLst>
-      </pc:sldChg>
-      <pc:sldChg chg="modSp mod">
-        <pc:chgData name="Matthieu De Mari" userId="dfb708c9-d8dc-439f-9a3b-c772bf4a311c" providerId="ADAL" clId="{D2FDBEB2-E663-41FC-8A3C-AC79657DF6AB}" dt="2023-01-31T09:38:33.645" v="7" actId="20577"/>
-        <pc:sldMkLst>
-          <pc:docMk/>
-          <pc:sldMk cId="1036081419" sldId="346"/>
-        </pc:sldMkLst>
-      </pc:sldChg>
-      <pc:sldChg chg="modSp mod">
-        <pc:chgData name="Matthieu De Mari" userId="dfb708c9-d8dc-439f-9a3b-c772bf4a311c" providerId="ADAL" clId="{D2FDBEB2-E663-41FC-8A3C-AC79657DF6AB}" dt="2023-01-31T09:39:03.009" v="70" actId="20577"/>
-        <pc:sldMkLst>
-          <pc:docMk/>
-          <pc:sldMk cId="1040156172" sldId="377"/>
-        </pc:sldMkLst>
-      </pc:sldChg>
-      <pc:sldChg chg="addSp delSp modSp new mod modClrScheme chgLayout">
-        <pc:chgData name="Matthieu De Mari" userId="dfb708c9-d8dc-439f-9a3b-c772bf4a311c" providerId="ADAL" clId="{D2FDBEB2-E663-41FC-8A3C-AC79657DF6AB}" dt="2023-02-03T06:08:42.324" v="707" actId="20577"/>
+        <pc:chgData name="Matthieu De Mari" userId="dfb708c9-d8dc-439f-9a3b-c772bf4a311c" providerId="ADAL" clId="{81E9B007-0C2C-493E-9B93-55A62C9C1F12}" dt="2025-12-18T22:17:52.423" v="0" actId="20577"/>
         <pc:sldMkLst>
           <pc:docMk/>
           <pc:sldMk cId="380766058" sldId="378"/>
         </pc:sldMkLst>
+        <pc:spChg chg="mod">
+          <ac:chgData name="Matthieu De Mari" userId="dfb708c9-d8dc-439f-9a3b-c772bf4a311c" providerId="ADAL" clId="{81E9B007-0C2C-493E-9B93-55A62C9C1F12}" dt="2025-12-18T22:17:52.423" v="0" actId="20577"/>
+          <ac:spMkLst>
+            <pc:docMk/>
+            <pc:sldMk cId="380766058" sldId="378"/>
+            <ac:spMk id="3" creationId="{65399E50-9E84-8D67-B55F-073C06C3D10E}"/>
+          </ac:spMkLst>
+        </pc:spChg>
       </pc:sldChg>
-      <pc:sldChg chg="addSp delSp modSp new mod modClrScheme chgLayout">
-        <pc:chgData name="Matthieu De Mari" userId="dfb708c9-d8dc-439f-9a3b-c772bf4a311c" providerId="ADAL" clId="{D2FDBEB2-E663-41FC-8A3C-AC79657DF6AB}" dt="2023-02-03T06:12:18.186" v="801" actId="1076"/>
-        <pc:sldMkLst>
-          <pc:docMk/>
-          <pc:sldMk cId="1970187575" sldId="379"/>
-        </pc:sldMkLst>
-      </pc:sldChg>
-      <pc:sldChg chg="addSp delSp modSp new mod modClrScheme chgLayout">
-        <pc:chgData name="Matthieu De Mari" userId="dfb708c9-d8dc-439f-9a3b-c772bf4a311c" providerId="ADAL" clId="{D2FDBEB2-E663-41FC-8A3C-AC79657DF6AB}" dt="2023-02-03T06:39:40.751" v="2139" actId="207"/>
-        <pc:sldMkLst>
-          <pc:docMk/>
-          <pc:sldMk cId="2100436947" sldId="380"/>
-        </pc:sldMkLst>
-      </pc:sldChg>
-      <pc:sldChg chg="addSp modSp new mod modClrScheme chgLayout">
-        <pc:chgData name="Matthieu De Mari" userId="dfb708c9-d8dc-439f-9a3b-c772bf4a311c" providerId="ADAL" clId="{D2FDBEB2-E663-41FC-8A3C-AC79657DF6AB}" dt="2023-02-03T06:43:16.501" v="2260" actId="20577"/>
-        <pc:sldMkLst>
-          <pc:docMk/>
-          <pc:sldMk cId="3251402422" sldId="381"/>
-        </pc:sldMkLst>
-      </pc:sldChg>
-      <pc:sldChg chg="addSp delSp modSp new mod modClrScheme chgLayout">
-        <pc:chgData name="Matthieu De Mari" userId="dfb708c9-d8dc-439f-9a3b-c772bf4a311c" providerId="ADAL" clId="{D2FDBEB2-E663-41FC-8A3C-AC79657DF6AB}" dt="2023-02-03T06:48:14.770" v="2345" actId="14100"/>
-        <pc:sldMkLst>
-          <pc:docMk/>
-          <pc:sldMk cId="1017635827" sldId="382"/>
-        </pc:sldMkLst>
-      </pc:sldChg>
-      <pc:sldChg chg="modSp new mod">
-        <pc:chgData name="Matthieu De Mari" userId="dfb708c9-d8dc-439f-9a3b-c772bf4a311c" providerId="ADAL" clId="{D2FDBEB2-E663-41FC-8A3C-AC79657DF6AB}" dt="2023-02-03T07:03:32.616" v="2650" actId="20577"/>
-        <pc:sldMkLst>
-          <pc:docMk/>
-          <pc:sldMk cId="1921397945" sldId="383"/>
-        </pc:sldMkLst>
-      </pc:sldChg>
-      <pc:sldChg chg="addSp delSp modSp new mod modClrScheme chgLayout">
-        <pc:chgData name="Matthieu De Mari" userId="dfb708c9-d8dc-439f-9a3b-c772bf4a311c" providerId="ADAL" clId="{D2FDBEB2-E663-41FC-8A3C-AC79657DF6AB}" dt="2023-02-03T08:27:26.197" v="6114" actId="20577"/>
-        <pc:sldMkLst>
-          <pc:docMk/>
-          <pc:sldMk cId="1420298135" sldId="384"/>
-        </pc:sldMkLst>
-      </pc:sldChg>
-      <pc:sldChg chg="addSp modSp new mod">
-        <pc:chgData name="Matthieu De Mari" userId="dfb708c9-d8dc-439f-9a3b-c772bf4a311c" providerId="ADAL" clId="{D2FDBEB2-E663-41FC-8A3C-AC79657DF6AB}" dt="2023-02-03T08:27:48.202" v="6121" actId="20577"/>
-        <pc:sldMkLst>
-          <pc:docMk/>
-          <pc:sldMk cId="2560511070" sldId="385"/>
-        </pc:sldMkLst>
-      </pc:sldChg>
-      <pc:sldChg chg="addSp delSp modSp new mod modClrScheme chgLayout">
-        <pc:chgData name="Matthieu De Mari" userId="dfb708c9-d8dc-439f-9a3b-c772bf4a311c" providerId="ADAL" clId="{D2FDBEB2-E663-41FC-8A3C-AC79657DF6AB}" dt="2023-02-03T07:24:21.886" v="3777" actId="20577"/>
-        <pc:sldMkLst>
-          <pc:docMk/>
-          <pc:sldMk cId="1116470923" sldId="386"/>
-        </pc:sldMkLst>
-      </pc:sldChg>
-      <pc:sldChg chg="modSp new mod">
-        <pc:chgData name="Matthieu De Mari" userId="dfb708c9-d8dc-439f-9a3b-c772bf4a311c" providerId="ADAL" clId="{D2FDBEB2-E663-41FC-8A3C-AC79657DF6AB}" dt="2023-02-03T07:51:47.934" v="3926" actId="20577"/>
-        <pc:sldMkLst>
-          <pc:docMk/>
-          <pc:sldMk cId="2474697269" sldId="387"/>
-        </pc:sldMkLst>
-      </pc:sldChg>
-      <pc:sldChg chg="modSp new mod">
-        <pc:chgData name="Matthieu De Mari" userId="dfb708c9-d8dc-439f-9a3b-c772bf4a311c" providerId="ADAL" clId="{D2FDBEB2-E663-41FC-8A3C-AC79657DF6AB}" dt="2023-02-03T08:05:19.527" v="4929" actId="113"/>
-        <pc:sldMkLst>
-          <pc:docMk/>
-          <pc:sldMk cId="4198773114" sldId="388"/>
-        </pc:sldMkLst>
-      </pc:sldChg>
-      <pc:sldChg chg="modSp new mod">
-        <pc:chgData name="Matthieu De Mari" userId="dfb708c9-d8dc-439f-9a3b-c772bf4a311c" providerId="ADAL" clId="{D2FDBEB2-E663-41FC-8A3C-AC79657DF6AB}" dt="2023-02-03T08:15:34.322" v="5775" actId="20577"/>
-        <pc:sldMkLst>
-          <pc:docMk/>
-          <pc:sldMk cId="481628505" sldId="389"/>
-        </pc:sldMkLst>
-      </pc:sldChg>
-      <pc:sldChg chg="addSp delSp modSp new mod">
-        <pc:chgData name="Matthieu De Mari" userId="dfb708c9-d8dc-439f-9a3b-c772bf4a311c" providerId="ADAL" clId="{D2FDBEB2-E663-41FC-8A3C-AC79657DF6AB}" dt="2023-02-03T08:16:23.090" v="5808" actId="1076"/>
-        <pc:sldMkLst>
-          <pc:docMk/>
-          <pc:sldMk cId="2128707751" sldId="390"/>
-        </pc:sldMkLst>
-      </pc:sldChg>
-      <pc:sldChg chg="addSp delSp modSp new mod modClrScheme chgLayout">
-        <pc:chgData name="Matthieu De Mari" userId="dfb708c9-d8dc-439f-9a3b-c772bf4a311c" providerId="ADAL" clId="{D2FDBEB2-E663-41FC-8A3C-AC79657DF6AB}" dt="2023-02-03T08:36:24.788" v="6692" actId="20577"/>
-        <pc:sldMkLst>
-          <pc:docMk/>
-          <pc:sldMk cId="1283478655" sldId="391"/>
-        </pc:sldMkLst>
-      </pc:sldChg>
-      <pc:sldChg chg="addSp delSp new mod ord">
-        <pc:chgData name="Matthieu De Mari" userId="dfb708c9-d8dc-439f-9a3b-c772bf4a311c" providerId="ADAL" clId="{D2FDBEB2-E663-41FC-8A3C-AC79657DF6AB}" dt="2023-02-03T08:51:08.222" v="7382"/>
-        <pc:sldMkLst>
-          <pc:docMk/>
-          <pc:sldMk cId="1341638402" sldId="392"/>
-        </pc:sldMkLst>
-      </pc:sldChg>
-      <pc:sldChg chg="new del">
-        <pc:chgData name="Matthieu De Mari" userId="dfb708c9-d8dc-439f-9a3b-c772bf4a311c" providerId="ADAL" clId="{D2FDBEB2-E663-41FC-8A3C-AC79657DF6AB}" dt="2023-02-03T08:51:09.735" v="7383" actId="47"/>
-        <pc:sldMkLst>
-          <pc:docMk/>
-          <pc:sldMk cId="949620911" sldId="393"/>
-        </pc:sldMkLst>
-      </pc:sldChg>
-      <pc:sldChg chg="addSp delSp modSp new mod modClrScheme chgLayout">
-        <pc:chgData name="Matthieu De Mari" userId="dfb708c9-d8dc-439f-9a3b-c772bf4a311c" providerId="ADAL" clId="{D2FDBEB2-E663-41FC-8A3C-AC79657DF6AB}" dt="2023-02-03T08:53:43.343" v="7567" actId="14100"/>
-        <pc:sldMkLst>
-          <pc:docMk/>
-          <pc:sldMk cId="164097668" sldId="394"/>
-        </pc:sldMkLst>
-      </pc:sldChg>
-      <pc:sldChg chg="addSp delSp modSp new mod modClrScheme chgLayout">
-        <pc:chgData name="Matthieu De Mari" userId="dfb708c9-d8dc-439f-9a3b-c772bf4a311c" providerId="ADAL" clId="{D2FDBEB2-E663-41FC-8A3C-AC79657DF6AB}" dt="2023-02-03T09:08:43.040" v="8236" actId="14100"/>
-        <pc:sldMkLst>
-          <pc:docMk/>
-          <pc:sldMk cId="3048177291" sldId="395"/>
-        </pc:sldMkLst>
-      </pc:sldChg>
-      <pc:sldChg chg="new">
-        <pc:chgData name="Matthieu De Mari" userId="dfb708c9-d8dc-439f-9a3b-c772bf4a311c" providerId="ADAL" clId="{D2FDBEB2-E663-41FC-8A3C-AC79657DF6AB}" dt="2023-02-03T02:58:04.050" v="175" actId="680"/>
-        <pc:sldMkLst>
-          <pc:docMk/>
-          <pc:sldMk cId="1458730680" sldId="396"/>
-        </pc:sldMkLst>
-      </pc:sldChg>
-      <pc:sldChg chg="new">
-        <pc:chgData name="Matthieu De Mari" userId="dfb708c9-d8dc-439f-9a3b-c772bf4a311c" providerId="ADAL" clId="{D2FDBEB2-E663-41FC-8A3C-AC79657DF6AB}" dt="2023-02-03T02:58:18.676" v="178" actId="680"/>
-        <pc:sldMkLst>
-          <pc:docMk/>
-          <pc:sldMk cId="1451434589" sldId="397"/>
-        </pc:sldMkLst>
-      </pc:sldChg>
-      <pc:sldChg chg="new">
-        <pc:chgData name="Matthieu De Mari" userId="dfb708c9-d8dc-439f-9a3b-c772bf4a311c" providerId="ADAL" clId="{D2FDBEB2-E663-41FC-8A3C-AC79657DF6AB}" dt="2023-02-03T02:58:36.414" v="181" actId="680"/>
-        <pc:sldMkLst>
-          <pc:docMk/>
-          <pc:sldMk cId="2867637474" sldId="398"/>
-        </pc:sldMkLst>
-      </pc:sldChg>
-      <pc:sldChg chg="modSp new mod">
-        <pc:chgData name="Matthieu De Mari" userId="dfb708c9-d8dc-439f-9a3b-c772bf4a311c" providerId="ADAL" clId="{D2FDBEB2-E663-41FC-8A3C-AC79657DF6AB}" dt="2023-02-03T02:59:22.033" v="235" actId="20577"/>
-        <pc:sldMkLst>
-          <pc:docMk/>
-          <pc:sldMk cId="122423608" sldId="399"/>
-        </pc:sldMkLst>
-      </pc:sldChg>
-      <pc:sldChg chg="new">
-        <pc:chgData name="Matthieu De Mari" userId="dfb708c9-d8dc-439f-9a3b-c772bf4a311c" providerId="ADAL" clId="{D2FDBEB2-E663-41FC-8A3C-AC79657DF6AB}" dt="2023-02-03T02:59:37.988" v="238" actId="680"/>
-        <pc:sldMkLst>
-          <pc:docMk/>
-          <pc:sldMk cId="2642959288" sldId="400"/>
-        </pc:sldMkLst>
-      </pc:sldChg>
-      <pc:sldChg chg="new">
-        <pc:chgData name="Matthieu De Mari" userId="dfb708c9-d8dc-439f-9a3b-c772bf4a311c" providerId="ADAL" clId="{D2FDBEB2-E663-41FC-8A3C-AC79657DF6AB}" dt="2023-02-03T03:00:18.961" v="243" actId="680"/>
-        <pc:sldMkLst>
-          <pc:docMk/>
-          <pc:sldMk cId="4039171501" sldId="401"/>
-        </pc:sldMkLst>
-      </pc:sldChg>
-      <pc:sldChg chg="new">
-        <pc:chgData name="Matthieu De Mari" userId="dfb708c9-d8dc-439f-9a3b-c772bf4a311c" providerId="ADAL" clId="{D2FDBEB2-E663-41FC-8A3C-AC79657DF6AB}" dt="2023-02-03T03:00:44.919" v="246" actId="680"/>
-        <pc:sldMkLst>
-          <pc:docMk/>
-          <pc:sldMk cId="3163596145" sldId="402"/>
-        </pc:sldMkLst>
-      </pc:sldChg>
-      <pc:sldChg chg="new">
-        <pc:chgData name="Matthieu De Mari" userId="dfb708c9-d8dc-439f-9a3b-c772bf4a311c" providerId="ADAL" clId="{D2FDBEB2-E663-41FC-8A3C-AC79657DF6AB}" dt="2023-02-03T03:01:15.486" v="251" actId="680"/>
-        <pc:sldMkLst>
-          <pc:docMk/>
-          <pc:sldMk cId="101927766" sldId="403"/>
-        </pc:sldMkLst>
-      </pc:sldChg>
-      <pc:sldChg chg="modSp new mod">
-        <pc:chgData name="Matthieu De Mari" userId="dfb708c9-d8dc-439f-9a3b-c772bf4a311c" providerId="ADAL" clId="{D2FDBEB2-E663-41FC-8A3C-AC79657DF6AB}" dt="2023-02-03T06:54:09.367" v="2541" actId="20577"/>
-        <pc:sldMkLst>
-          <pc:docMk/>
-          <pc:sldMk cId="3140288791" sldId="404"/>
-        </pc:sldMkLst>
-      </pc:sldChg>
-      <pc:sldChg chg="add">
-        <pc:chgData name="Matthieu De Mari" userId="dfb708c9-d8dc-439f-9a3b-c772bf4a311c" providerId="ADAL" clId="{D2FDBEB2-E663-41FC-8A3C-AC79657DF6AB}" dt="2023-02-03T06:03:02.893" v="259"/>
-        <pc:sldMkLst>
-          <pc:docMk/>
-          <pc:sldMk cId="3843402283" sldId="405"/>
-        </pc:sldMkLst>
-      </pc:sldChg>
-      <pc:sldChg chg="addSp delSp modSp add mod ord modClrScheme chgLayout">
-        <pc:chgData name="Matthieu De Mari" userId="dfb708c9-d8dc-439f-9a3b-c772bf4a311c" providerId="ADAL" clId="{D2FDBEB2-E663-41FC-8A3C-AC79657DF6AB}" dt="2023-02-03T06:09:42.334" v="720" actId="1076"/>
-        <pc:sldMkLst>
-          <pc:docMk/>
-          <pc:sldMk cId="3358927626" sldId="406"/>
-        </pc:sldMkLst>
-      </pc:sldChg>
-      <pc:sldChg chg="addSp delSp modSp new mod">
-        <pc:chgData name="Matthieu De Mari" userId="dfb708c9-d8dc-439f-9a3b-c772bf4a311c" providerId="ADAL" clId="{D2FDBEB2-E663-41FC-8A3C-AC79657DF6AB}" dt="2023-02-03T06:15:37.685" v="1099" actId="12"/>
-        <pc:sldMkLst>
-          <pc:docMk/>
-          <pc:sldMk cId="1925028509" sldId="407"/>
-        </pc:sldMkLst>
-      </pc:sldChg>
-      <pc:sldChg chg="addSp delSp modSp new mod">
-        <pc:chgData name="Matthieu De Mari" userId="dfb708c9-d8dc-439f-9a3b-c772bf4a311c" providerId="ADAL" clId="{D2FDBEB2-E663-41FC-8A3C-AC79657DF6AB}" dt="2023-02-03T06:27:00.107" v="1534" actId="20577"/>
-        <pc:sldMkLst>
-          <pc:docMk/>
-          <pc:sldMk cId="3458396453" sldId="408"/>
-        </pc:sldMkLst>
-      </pc:sldChg>
-      <pc:sldChg chg="modSp add mod">
-        <pc:chgData name="Matthieu De Mari" userId="dfb708c9-d8dc-439f-9a3b-c772bf4a311c" providerId="ADAL" clId="{D2FDBEB2-E663-41FC-8A3C-AC79657DF6AB}" dt="2023-02-03T06:27:25.758" v="1541" actId="20577"/>
-        <pc:sldMkLst>
-          <pc:docMk/>
-          <pc:sldMk cId="1339110510" sldId="409"/>
-        </pc:sldMkLst>
-      </pc:sldChg>
-      <pc:sldChg chg="addSp delSp modSp add mod chgLayout">
-        <pc:chgData name="Matthieu De Mari" userId="dfb708c9-d8dc-439f-9a3b-c772bf4a311c" providerId="ADAL" clId="{D2FDBEB2-E663-41FC-8A3C-AC79657DF6AB}" dt="2023-02-03T06:29:45.592" v="1649" actId="1076"/>
-        <pc:sldMkLst>
-          <pc:docMk/>
-          <pc:sldMk cId="1178350440" sldId="410"/>
-        </pc:sldMkLst>
-      </pc:sldChg>
-      <pc:sldChg chg="addSp delSp modSp add mod">
-        <pc:chgData name="Matthieu De Mari" userId="dfb708c9-d8dc-439f-9a3b-c772bf4a311c" providerId="ADAL" clId="{D2FDBEB2-E663-41FC-8A3C-AC79657DF6AB}" dt="2023-02-03T06:30:43.564" v="1656" actId="1076"/>
-        <pc:sldMkLst>
-          <pc:docMk/>
-          <pc:sldMk cId="2149409242" sldId="411"/>
-        </pc:sldMkLst>
-      </pc:sldChg>
-      <pc:sldChg chg="addSp delSp modSp new mod modClrScheme chgLayout">
-        <pc:chgData name="Matthieu De Mari" userId="dfb708c9-d8dc-439f-9a3b-c772bf4a311c" providerId="ADAL" clId="{D2FDBEB2-E663-41FC-8A3C-AC79657DF6AB}" dt="2023-02-03T06:32:52.063" v="1839" actId="1076"/>
-        <pc:sldMkLst>
-          <pc:docMk/>
-          <pc:sldMk cId="1857929555" sldId="412"/>
-        </pc:sldMkLst>
-      </pc:sldChg>
-      <pc:sldChg chg="delSp modSp add mod">
-        <pc:chgData name="Matthieu De Mari" userId="dfb708c9-d8dc-439f-9a3b-c772bf4a311c" providerId="ADAL" clId="{D2FDBEB2-E663-41FC-8A3C-AC79657DF6AB}" dt="2023-02-03T06:32:48.411" v="1837" actId="1076"/>
-        <pc:sldMkLst>
-          <pc:docMk/>
-          <pc:sldMk cId="3179138343" sldId="413"/>
-        </pc:sldMkLst>
-      </pc:sldChg>
-      <pc:sldChg chg="addSp delSp modSp new mod ord modClrScheme chgLayout">
-        <pc:chgData name="Matthieu De Mari" userId="dfb708c9-d8dc-439f-9a3b-c772bf4a311c" providerId="ADAL" clId="{D2FDBEB2-E663-41FC-8A3C-AC79657DF6AB}" dt="2023-02-03T06:35:33.161" v="1926" actId="207"/>
-        <pc:sldMkLst>
-          <pc:docMk/>
-          <pc:sldMk cId="1324969895" sldId="414"/>
-        </pc:sldMkLst>
-      </pc:sldChg>
-      <pc:sldChg chg="addSp delSp modSp add mod">
-        <pc:chgData name="Matthieu De Mari" userId="dfb708c9-d8dc-439f-9a3b-c772bf4a311c" providerId="ADAL" clId="{D2FDBEB2-E663-41FC-8A3C-AC79657DF6AB}" dt="2023-02-03T06:35:36.345" v="1927" actId="207"/>
-        <pc:sldMkLst>
-          <pc:docMk/>
-          <pc:sldMk cId="481166971" sldId="415"/>
-        </pc:sldMkLst>
-      </pc:sldChg>
-      <pc:sldChg chg="addSp delSp modSp add mod">
-        <pc:chgData name="Matthieu De Mari" userId="dfb708c9-d8dc-439f-9a3b-c772bf4a311c" providerId="ADAL" clId="{D2FDBEB2-E663-41FC-8A3C-AC79657DF6AB}" dt="2023-02-03T06:35:57.022" v="1933" actId="14100"/>
-        <pc:sldMkLst>
-          <pc:docMk/>
-          <pc:sldMk cId="4050702309" sldId="416"/>
-        </pc:sldMkLst>
-      </pc:sldChg>
-      <pc:sldChg chg="addSp delSp modSp add mod">
-        <pc:chgData name="Matthieu De Mari" userId="dfb708c9-d8dc-439f-9a3b-c772bf4a311c" providerId="ADAL" clId="{D2FDBEB2-E663-41FC-8A3C-AC79657DF6AB}" dt="2023-02-03T06:36:16.380" v="1937" actId="1076"/>
-        <pc:sldMkLst>
-          <pc:docMk/>
-          <pc:sldMk cId="4249457938" sldId="417"/>
-        </pc:sldMkLst>
-      </pc:sldChg>
-      <pc:sldChg chg="addSp delSp modSp add mod">
-        <pc:chgData name="Matthieu De Mari" userId="dfb708c9-d8dc-439f-9a3b-c772bf4a311c" providerId="ADAL" clId="{D2FDBEB2-E663-41FC-8A3C-AC79657DF6AB}" dt="2023-02-03T06:40:11.228" v="2148" actId="1076"/>
-        <pc:sldMkLst>
-          <pc:docMk/>
-          <pc:sldMk cId="3310153579" sldId="418"/>
-        </pc:sldMkLst>
-      </pc:sldChg>
-      <pc:sldChg chg="addSp delSp modSp add mod">
-        <pc:chgData name="Matthieu De Mari" userId="dfb708c9-d8dc-439f-9a3b-c772bf4a311c" providerId="ADAL" clId="{D2FDBEB2-E663-41FC-8A3C-AC79657DF6AB}" dt="2023-02-03T06:40:35.066" v="2150" actId="1076"/>
-        <pc:sldMkLst>
-          <pc:docMk/>
-          <pc:sldMk cId="1163891923" sldId="419"/>
-        </pc:sldMkLst>
-      </pc:sldChg>
-      <pc:sldChg chg="addSp delSp modSp add mod">
-        <pc:chgData name="Matthieu De Mari" userId="dfb708c9-d8dc-439f-9a3b-c772bf4a311c" providerId="ADAL" clId="{D2FDBEB2-E663-41FC-8A3C-AC79657DF6AB}" dt="2023-02-03T06:42:16.251" v="2202" actId="1037"/>
-        <pc:sldMkLst>
-          <pc:docMk/>
-          <pc:sldMk cId="1773283043" sldId="420"/>
-        </pc:sldMkLst>
-      </pc:sldChg>
-      <pc:sldChg chg="addSp delSp modSp add mod">
-        <pc:chgData name="Matthieu De Mari" userId="dfb708c9-d8dc-439f-9a3b-c772bf4a311c" providerId="ADAL" clId="{D2FDBEB2-E663-41FC-8A3C-AC79657DF6AB}" dt="2023-02-03T06:44:22.777" v="2273" actId="1076"/>
-        <pc:sldMkLst>
-          <pc:docMk/>
-          <pc:sldMk cId="346749718" sldId="421"/>
-        </pc:sldMkLst>
-      </pc:sldChg>
-      <pc:sldChg chg="addSp delSp modSp add mod">
-        <pc:chgData name="Matthieu De Mari" userId="dfb708c9-d8dc-439f-9a3b-c772bf4a311c" providerId="ADAL" clId="{D2FDBEB2-E663-41FC-8A3C-AC79657DF6AB}" dt="2023-02-03T06:44:28.223" v="2274" actId="1076"/>
-        <pc:sldMkLst>
-          <pc:docMk/>
-          <pc:sldMk cId="2747530419" sldId="422"/>
-        </pc:sldMkLst>
-      </pc:sldChg>
-      <pc:sldChg chg="addSp delSp modSp add mod chgLayout">
-        <pc:chgData name="Matthieu De Mari" userId="dfb708c9-d8dc-439f-9a3b-c772bf4a311c" providerId="ADAL" clId="{D2FDBEB2-E663-41FC-8A3C-AC79657DF6AB}" dt="2023-02-03T06:50:11.938" v="2380" actId="14100"/>
-        <pc:sldMkLst>
-          <pc:docMk/>
-          <pc:sldMk cId="4145254973" sldId="423"/>
-        </pc:sldMkLst>
-      </pc:sldChg>
-      <pc:sldChg chg="addSp delSp modSp add mod">
-        <pc:chgData name="Matthieu De Mari" userId="dfb708c9-d8dc-439f-9a3b-c772bf4a311c" providerId="ADAL" clId="{D2FDBEB2-E663-41FC-8A3C-AC79657DF6AB}" dt="2023-02-03T06:51:22.484" v="2410" actId="20577"/>
-        <pc:sldMkLst>
-          <pc:docMk/>
-          <pc:sldMk cId="1513778887" sldId="424"/>
-        </pc:sldMkLst>
-      </pc:sldChg>
-      <pc:sldChg chg="addSp delSp modSp add mod">
-        <pc:chgData name="Matthieu De Mari" userId="dfb708c9-d8dc-439f-9a3b-c772bf4a311c" providerId="ADAL" clId="{D2FDBEB2-E663-41FC-8A3C-AC79657DF6AB}" dt="2023-02-03T06:50:07.197" v="2378" actId="1076"/>
-        <pc:sldMkLst>
-          <pc:docMk/>
-          <pc:sldMk cId="548772636" sldId="425"/>
-        </pc:sldMkLst>
-      </pc:sldChg>
-      <pc:sldChg chg="addSp delSp modSp add mod modClrScheme chgLayout">
-        <pc:chgData name="Matthieu De Mari" userId="dfb708c9-d8dc-439f-9a3b-c772bf4a311c" providerId="ADAL" clId="{D2FDBEB2-E663-41FC-8A3C-AC79657DF6AB}" dt="2023-02-03T06:52:56.286" v="2468" actId="20577"/>
-        <pc:sldMkLst>
-          <pc:docMk/>
-          <pc:sldMk cId="995336806" sldId="426"/>
-        </pc:sldMkLst>
-      </pc:sldChg>
-      <pc:sldChg chg="add">
-        <pc:chgData name="Matthieu De Mari" userId="dfb708c9-d8dc-439f-9a3b-c772bf4a311c" providerId="ADAL" clId="{D2FDBEB2-E663-41FC-8A3C-AC79657DF6AB}" dt="2023-02-03T07:27:21.109" v="3778"/>
-        <pc:sldMkLst>
-          <pc:docMk/>
-          <pc:sldMk cId="1567954153" sldId="608"/>
-        </pc:sldMkLst>
-      </pc:sldChg>
-      <pc:sldChg chg="modSp add mod">
-        <pc:chgData name="Matthieu De Mari" userId="dfb708c9-d8dc-439f-9a3b-c772bf4a311c" providerId="ADAL" clId="{D2FDBEB2-E663-41FC-8A3C-AC79657DF6AB}" dt="2023-02-03T07:04:16.986" v="2681" actId="20577"/>
-        <pc:sldMkLst>
-          <pc:docMk/>
-          <pc:sldMk cId="1098360026" sldId="646"/>
-        </pc:sldMkLst>
-      </pc:sldChg>
-      <pc:sldChg chg="modSp new mod">
-        <pc:chgData name="Matthieu De Mari" userId="dfb708c9-d8dc-439f-9a3b-c772bf4a311c" providerId="ADAL" clId="{D2FDBEB2-E663-41FC-8A3C-AC79657DF6AB}" dt="2023-02-03T07:07:22.338" v="2871" actId="207"/>
-        <pc:sldMkLst>
-          <pc:docMk/>
-          <pc:sldMk cId="3471904534" sldId="647"/>
-        </pc:sldMkLst>
-      </pc:sldChg>
-      <pc:sldChg chg="addSp delSp modSp add mod">
-        <pc:chgData name="Matthieu De Mari" userId="dfb708c9-d8dc-439f-9a3b-c772bf4a311c" providerId="ADAL" clId="{D2FDBEB2-E663-41FC-8A3C-AC79657DF6AB}" dt="2023-02-03T08:26:52.576" v="6104" actId="14100"/>
-        <pc:sldMkLst>
-          <pc:docMk/>
-          <pc:sldMk cId="1172112343" sldId="648"/>
-        </pc:sldMkLst>
-      </pc:sldChg>
-      <pc:sldChg chg="addSp delSp modSp add mod ord">
-        <pc:chgData name="Matthieu De Mari" userId="dfb708c9-d8dc-439f-9a3b-c772bf4a311c" providerId="ADAL" clId="{D2FDBEB2-E663-41FC-8A3C-AC79657DF6AB}" dt="2023-02-03T07:12:02.061" v="3217" actId="20577"/>
+      <pc:sldChg chg="modSp mod">
+        <pc:chgData name="Matthieu De Mari" userId="dfb708c9-d8dc-439f-9a3b-c772bf4a311c" providerId="ADAL" clId="{81E9B007-0C2C-493E-9B93-55A62C9C1F12}" dt="2025-12-18T22:19:40.157" v="1" actId="207"/>
         <pc:sldMkLst>
           <pc:docMk/>
           <pc:sldMk cId="1146881653" sldId="649"/>
         </pc:sldMkLst>
-      </pc:sldChg>
-      <pc:sldChg chg="addSp delSp modSp add mod">
-        <pc:chgData name="Matthieu De Mari" userId="dfb708c9-d8dc-439f-9a3b-c772bf4a311c" providerId="ADAL" clId="{D2FDBEB2-E663-41FC-8A3C-AC79657DF6AB}" dt="2023-02-03T07:18:45.380" v="3575" actId="22"/>
-        <pc:sldMkLst>
-          <pc:docMk/>
-          <pc:sldMk cId="2437975891" sldId="650"/>
-        </pc:sldMkLst>
-      </pc:sldChg>
-      <pc:sldChg chg="addSp delSp modSp add mod chgLayout">
-        <pc:chgData name="Matthieu De Mari" userId="dfb708c9-d8dc-439f-9a3b-c772bf4a311c" providerId="ADAL" clId="{D2FDBEB2-E663-41FC-8A3C-AC79657DF6AB}" dt="2023-02-03T08:28:04.146" v="6124" actId="14100"/>
-        <pc:sldMkLst>
-          <pc:docMk/>
-          <pc:sldMk cId="2710721176" sldId="651"/>
-        </pc:sldMkLst>
-      </pc:sldChg>
-      <pc:sldChg chg="addSp delSp modSp add mod">
-        <pc:chgData name="Matthieu De Mari" userId="dfb708c9-d8dc-439f-9a3b-c772bf4a311c" providerId="ADAL" clId="{D2FDBEB2-E663-41FC-8A3C-AC79657DF6AB}" dt="2023-02-03T07:22:56.178" v="3713" actId="1076"/>
-        <pc:sldMkLst>
-          <pc:docMk/>
-          <pc:sldMk cId="2596538432" sldId="652"/>
-        </pc:sldMkLst>
-      </pc:sldChg>
-      <pc:sldChg chg="add del">
-        <pc:chgData name="Matthieu De Mari" userId="dfb708c9-d8dc-439f-9a3b-c772bf4a311c" providerId="ADAL" clId="{D2FDBEB2-E663-41FC-8A3C-AC79657DF6AB}" dt="2023-02-03T07:20:41.487" v="3632" actId="47"/>
-        <pc:sldMkLst>
-          <pc:docMk/>
-          <pc:sldMk cId="4100639751" sldId="652"/>
-        </pc:sldMkLst>
-      </pc:sldChg>
-      <pc:sldChg chg="add">
-        <pc:chgData name="Matthieu De Mari" userId="dfb708c9-d8dc-439f-9a3b-c772bf4a311c" providerId="ADAL" clId="{D2FDBEB2-E663-41FC-8A3C-AC79657DF6AB}" dt="2023-02-03T07:27:21.109" v="3778"/>
-        <pc:sldMkLst>
-          <pc:docMk/>
-          <pc:sldMk cId="2525469962" sldId="757"/>
-        </pc:sldMkLst>
-      </pc:sldChg>
-      <pc:sldChg chg="add">
-        <pc:chgData name="Matthieu De Mari" userId="dfb708c9-d8dc-439f-9a3b-c772bf4a311c" providerId="ADAL" clId="{D2FDBEB2-E663-41FC-8A3C-AC79657DF6AB}" dt="2023-02-03T07:27:21.109" v="3778"/>
-        <pc:sldMkLst>
-          <pc:docMk/>
-          <pc:sldMk cId="571242276" sldId="758"/>
-        </pc:sldMkLst>
-      </pc:sldChg>
-      <pc:sldChg chg="add">
-        <pc:chgData name="Matthieu De Mari" userId="dfb708c9-d8dc-439f-9a3b-c772bf4a311c" providerId="ADAL" clId="{D2FDBEB2-E663-41FC-8A3C-AC79657DF6AB}" dt="2023-02-03T07:27:21.109" v="3778"/>
-        <pc:sldMkLst>
-          <pc:docMk/>
-          <pc:sldMk cId="1598131875" sldId="759"/>
-        </pc:sldMkLst>
-      </pc:sldChg>
-      <pc:sldChg chg="new">
-        <pc:chgData name="Matthieu De Mari" userId="dfb708c9-d8dc-439f-9a3b-c772bf4a311c" providerId="ADAL" clId="{D2FDBEB2-E663-41FC-8A3C-AC79657DF6AB}" dt="2023-02-03T07:27:29.638" v="3780" actId="680"/>
-        <pc:sldMkLst>
-          <pc:docMk/>
-          <pc:sldMk cId="2917324732" sldId="760"/>
-        </pc:sldMkLst>
-      </pc:sldChg>
-      <pc:sldChg chg="addSp delSp modSp add mod modClrScheme chgLayout">
-        <pc:chgData name="Matthieu De Mari" userId="dfb708c9-d8dc-439f-9a3b-c772bf4a311c" providerId="ADAL" clId="{D2FDBEB2-E663-41FC-8A3C-AC79657DF6AB}" dt="2023-02-03T07:55:26.347" v="4284" actId="20577"/>
-        <pc:sldMkLst>
-          <pc:docMk/>
-          <pc:sldMk cId="3339699406" sldId="761"/>
-        </pc:sldMkLst>
-      </pc:sldChg>
-      <pc:sldChg chg="addSp delSp modSp add mod">
-        <pc:chgData name="Matthieu De Mari" userId="dfb708c9-d8dc-439f-9a3b-c772bf4a311c" providerId="ADAL" clId="{D2FDBEB2-E663-41FC-8A3C-AC79657DF6AB}" dt="2023-02-03T07:57:48.123" v="4393" actId="1076"/>
-        <pc:sldMkLst>
-          <pc:docMk/>
-          <pc:sldMk cId="1546007078" sldId="762"/>
-        </pc:sldMkLst>
-      </pc:sldChg>
-      <pc:sldChg chg="addSp delSp modSp new mod modClrScheme chgLayout">
-        <pc:chgData name="Matthieu De Mari" userId="dfb708c9-d8dc-439f-9a3b-c772bf4a311c" providerId="ADAL" clId="{D2FDBEB2-E663-41FC-8A3C-AC79657DF6AB}" dt="2023-02-03T07:59:23.778" v="4443" actId="20577"/>
-        <pc:sldMkLst>
-          <pc:docMk/>
-          <pc:sldMk cId="2580175991" sldId="763"/>
-        </pc:sldMkLst>
-      </pc:sldChg>
-      <pc:sldChg chg="addSp modSp add mod">
-        <pc:chgData name="Matthieu De Mari" userId="dfb708c9-d8dc-439f-9a3b-c772bf4a311c" providerId="ADAL" clId="{D2FDBEB2-E663-41FC-8A3C-AC79657DF6AB}" dt="2023-02-03T08:30:06.264" v="6207"/>
-        <pc:sldMkLst>
-          <pc:docMk/>
-          <pc:sldMk cId="1879463264" sldId="764"/>
-        </pc:sldMkLst>
-      </pc:sldChg>
-      <pc:sldChg chg="addSp delSp modSp add mod modClrScheme chgLayout">
-        <pc:chgData name="Matthieu De Mari" userId="dfb708c9-d8dc-439f-9a3b-c772bf4a311c" providerId="ADAL" clId="{D2FDBEB2-E663-41FC-8A3C-AC79657DF6AB}" dt="2023-02-03T08:07:21.637" v="4960" actId="115"/>
-        <pc:sldMkLst>
-          <pc:docMk/>
-          <pc:sldMk cId="1996337912" sldId="765"/>
-        </pc:sldMkLst>
-      </pc:sldChg>
-      <pc:sldChg chg="addSp delSp modSp add mod modClrScheme chgLayout">
-        <pc:chgData name="Matthieu De Mari" userId="dfb708c9-d8dc-439f-9a3b-c772bf4a311c" providerId="ADAL" clId="{D2FDBEB2-E663-41FC-8A3C-AC79657DF6AB}" dt="2023-02-03T08:15:31.961" v="5774" actId="20577"/>
-        <pc:sldMkLst>
-          <pc:docMk/>
-          <pc:sldMk cId="1554669076" sldId="766"/>
-        </pc:sldMkLst>
-      </pc:sldChg>
-      <pc:sldChg chg="modSp add mod">
-        <pc:chgData name="Matthieu De Mari" userId="dfb708c9-d8dc-439f-9a3b-c772bf4a311c" providerId="ADAL" clId="{D2FDBEB2-E663-41FC-8A3C-AC79657DF6AB}" dt="2023-02-03T08:14:24.478" v="5655" actId="113"/>
-        <pc:sldMkLst>
-          <pc:docMk/>
-          <pc:sldMk cId="887698529" sldId="767"/>
-        </pc:sldMkLst>
-      </pc:sldChg>
-      <pc:sldChg chg="modSp add mod">
-        <pc:chgData name="Matthieu De Mari" userId="dfb708c9-d8dc-439f-9a3b-c772bf4a311c" providerId="ADAL" clId="{D2FDBEB2-E663-41FC-8A3C-AC79657DF6AB}" dt="2023-02-03T08:15:19.361" v="5773" actId="20577"/>
-        <pc:sldMkLst>
-          <pc:docMk/>
-          <pc:sldMk cId="3101493777" sldId="768"/>
-        </pc:sldMkLst>
-      </pc:sldChg>
-      <pc:sldChg chg="modSp new mod">
-        <pc:chgData name="Matthieu De Mari" userId="dfb708c9-d8dc-439f-9a3b-c772bf4a311c" providerId="ADAL" clId="{D2FDBEB2-E663-41FC-8A3C-AC79657DF6AB}" dt="2023-02-03T08:22:57.233" v="6026" actId="20577"/>
-        <pc:sldMkLst>
-          <pc:docMk/>
-          <pc:sldMk cId="2909899754" sldId="769"/>
-        </pc:sldMkLst>
-      </pc:sldChg>
-      <pc:sldChg chg="add del">
-        <pc:chgData name="Matthieu De Mari" userId="dfb708c9-d8dc-439f-9a3b-c772bf4a311c" providerId="ADAL" clId="{D2FDBEB2-E663-41FC-8A3C-AC79657DF6AB}" dt="2023-02-03T08:14:32.531" v="5657" actId="47"/>
-        <pc:sldMkLst>
-          <pc:docMk/>
-          <pc:sldMk cId="2993869992" sldId="769"/>
-        </pc:sldMkLst>
-      </pc:sldChg>
-      <pc:sldChg chg="addSp delSp modSp add mod">
-        <pc:chgData name="Matthieu De Mari" userId="dfb708c9-d8dc-439f-9a3b-c772bf4a311c" providerId="ADAL" clId="{D2FDBEB2-E663-41FC-8A3C-AC79657DF6AB}" dt="2023-02-03T08:16:53.633" v="5816" actId="1076"/>
-        <pc:sldMkLst>
-          <pc:docMk/>
-          <pc:sldMk cId="581091786" sldId="770"/>
-        </pc:sldMkLst>
-      </pc:sldChg>
-      <pc:sldChg chg="addSp delSp modSp add mod">
-        <pc:chgData name="Matthieu De Mari" userId="dfb708c9-d8dc-439f-9a3b-c772bf4a311c" providerId="ADAL" clId="{D2FDBEB2-E663-41FC-8A3C-AC79657DF6AB}" dt="2023-02-03T08:17:21.113" v="5822" actId="1076"/>
-        <pc:sldMkLst>
-          <pc:docMk/>
-          <pc:sldMk cId="2768410648" sldId="771"/>
-        </pc:sldMkLst>
-      </pc:sldChg>
-      <pc:sldChg chg="addSp delSp modSp add mod">
-        <pc:chgData name="Matthieu De Mari" userId="dfb708c9-d8dc-439f-9a3b-c772bf4a311c" providerId="ADAL" clId="{D2FDBEB2-E663-41FC-8A3C-AC79657DF6AB}" dt="2023-02-03T08:24:00.796" v="6040" actId="693"/>
-        <pc:sldMkLst>
-          <pc:docMk/>
-          <pc:sldMk cId="2791462929" sldId="772"/>
-        </pc:sldMkLst>
-      </pc:sldChg>
-      <pc:sldChg chg="addSp delSp modSp add mod">
-        <pc:chgData name="Matthieu De Mari" userId="dfb708c9-d8dc-439f-9a3b-c772bf4a311c" providerId="ADAL" clId="{D2FDBEB2-E663-41FC-8A3C-AC79657DF6AB}" dt="2023-02-03T08:25:06.211" v="6051" actId="14100"/>
-        <pc:sldMkLst>
-          <pc:docMk/>
-          <pc:sldMk cId="3544439591" sldId="773"/>
-        </pc:sldMkLst>
-      </pc:sldChg>
-      <pc:sldChg chg="addSp delSp modSp add mod">
-        <pc:chgData name="Matthieu De Mari" userId="dfb708c9-d8dc-439f-9a3b-c772bf4a311c" providerId="ADAL" clId="{D2FDBEB2-E663-41FC-8A3C-AC79657DF6AB}" dt="2023-02-03T08:25:30.434" v="6061" actId="478"/>
-        <pc:sldMkLst>
-          <pc:docMk/>
-          <pc:sldMk cId="2831341972" sldId="774"/>
-        </pc:sldMkLst>
-      </pc:sldChg>
-      <pc:sldChg chg="addSp delSp modSp add mod">
-        <pc:chgData name="Matthieu De Mari" userId="dfb708c9-d8dc-439f-9a3b-c772bf4a311c" providerId="ADAL" clId="{D2FDBEB2-E663-41FC-8A3C-AC79657DF6AB}" dt="2023-02-03T08:35:42.751" v="6590" actId="20577"/>
-        <pc:sldMkLst>
-          <pc:docMk/>
-          <pc:sldMk cId="743119883" sldId="775"/>
-        </pc:sldMkLst>
-      </pc:sldChg>
-      <pc:sldChg chg="addSp delSp modSp add mod modClrScheme chgLayout">
-        <pc:chgData name="Matthieu De Mari" userId="dfb708c9-d8dc-439f-9a3b-c772bf4a311c" providerId="ADAL" clId="{D2FDBEB2-E663-41FC-8A3C-AC79657DF6AB}" dt="2023-02-03T08:38:18.521" v="6716" actId="14100"/>
-        <pc:sldMkLst>
-          <pc:docMk/>
-          <pc:sldMk cId="1966383991" sldId="776"/>
-        </pc:sldMkLst>
-      </pc:sldChg>
-      <pc:sldChg chg="modSp add mod">
-        <pc:chgData name="Matthieu De Mari" userId="dfb708c9-d8dc-439f-9a3b-c772bf4a311c" providerId="ADAL" clId="{D2FDBEB2-E663-41FC-8A3C-AC79657DF6AB}" dt="2023-02-03T08:44:33.674" v="7137" actId="14100"/>
-        <pc:sldMkLst>
-          <pc:docMk/>
-          <pc:sldMk cId="3349972987" sldId="777"/>
-        </pc:sldMkLst>
-      </pc:sldChg>
-      <pc:sldChg chg="modSp new mod ord">
-        <pc:chgData name="Matthieu De Mari" userId="dfb708c9-d8dc-439f-9a3b-c772bf4a311c" providerId="ADAL" clId="{D2FDBEB2-E663-41FC-8A3C-AC79657DF6AB}" dt="2023-02-03T08:51:08.222" v="7382"/>
-        <pc:sldMkLst>
-          <pc:docMk/>
-          <pc:sldMk cId="4008937125" sldId="778"/>
-        </pc:sldMkLst>
-      </pc:sldChg>
-      <pc:sldChg chg="addSp delSp modSp add mod ord modClrScheme chgLayout">
-        <pc:chgData name="Matthieu De Mari" userId="dfb708c9-d8dc-439f-9a3b-c772bf4a311c" providerId="ADAL" clId="{D2FDBEB2-E663-41FC-8A3C-AC79657DF6AB}" dt="2023-02-03T08:51:08.222" v="7382"/>
-        <pc:sldMkLst>
-          <pc:docMk/>
-          <pc:sldMk cId="1689794110" sldId="779"/>
-        </pc:sldMkLst>
-      </pc:sldChg>
-      <pc:sldChg chg="addSp delSp modSp add mod">
-        <pc:chgData name="Matthieu De Mari" userId="dfb708c9-d8dc-439f-9a3b-c772bf4a311c" providerId="ADAL" clId="{D2FDBEB2-E663-41FC-8A3C-AC79657DF6AB}" dt="2023-02-03T08:55:14.765" v="7629" actId="20577"/>
-        <pc:sldMkLst>
-          <pc:docMk/>
-          <pc:sldMk cId="2678238830" sldId="780"/>
-        </pc:sldMkLst>
-      </pc:sldChg>
-      <pc:sldChg chg="addSp delSp new mod">
-        <pc:chgData name="Matthieu De Mari" userId="dfb708c9-d8dc-439f-9a3b-c772bf4a311c" providerId="ADAL" clId="{D2FDBEB2-E663-41FC-8A3C-AC79657DF6AB}" dt="2023-02-03T09:13:37.539" v="8349" actId="22"/>
-        <pc:sldMkLst>
-          <pc:docMk/>
-          <pc:sldMk cId="3029045816" sldId="781"/>
-        </pc:sldMkLst>
-      </pc:sldChg>
-      <pc:sldChg chg="addSp delSp modSp new mod modClrScheme chgLayout">
-        <pc:chgData name="Matthieu De Mari" userId="dfb708c9-d8dc-439f-9a3b-c772bf4a311c" providerId="ADAL" clId="{D2FDBEB2-E663-41FC-8A3C-AC79657DF6AB}" dt="2023-02-03T09:09:53.026" v="8345" actId="20577"/>
-        <pc:sldMkLst>
-          <pc:docMk/>
-          <pc:sldMk cId="278531271" sldId="782"/>
-        </pc:sldMkLst>
-      </pc:sldChg>
-    </pc:docChg>
-  </pc:docChgLst>
-  <pc:docChgLst>
-    <pc:chgData name="Matthieu De Mari" userId="dfb708c9-d8dc-439f-9a3b-c772bf4a311c" providerId="ADAL" clId="{9F6B3B9D-AADD-4622-81D6-CCF135E845F6}"/>
-    <pc:docChg chg="custSel addSld delSld modSld delSection modSection">
-      <pc:chgData name="Matthieu De Mari" userId="dfb708c9-d8dc-439f-9a3b-c772bf4a311c" providerId="ADAL" clId="{9F6B3B9D-AADD-4622-81D6-CCF135E845F6}" dt="2023-02-06T02:58:58.368" v="1850" actId="47"/>
-      <pc:docMkLst>
-        <pc:docMk/>
-      </pc:docMkLst>
-      <pc:sldChg chg="del">
-        <pc:chgData name="Matthieu De Mari" userId="dfb708c9-d8dc-439f-9a3b-c772bf4a311c" providerId="ADAL" clId="{9F6B3B9D-AADD-4622-81D6-CCF135E845F6}" dt="2023-02-06T02:58:58.368" v="1850" actId="47"/>
-        <pc:sldMkLst>
-          <pc:docMk/>
-          <pc:sldMk cId="3442501962" sldId="257"/>
-        </pc:sldMkLst>
-      </pc:sldChg>
-      <pc:sldChg chg="del">
-        <pc:chgData name="Matthieu De Mari" userId="dfb708c9-d8dc-439f-9a3b-c772bf4a311c" providerId="ADAL" clId="{9F6B3B9D-AADD-4622-81D6-CCF135E845F6}" dt="2023-02-06T02:27:25.777" v="1849" actId="47"/>
-        <pc:sldMkLst>
-          <pc:docMk/>
-          <pc:sldMk cId="1893873068" sldId="266"/>
-        </pc:sldMkLst>
-      </pc:sldChg>
-      <pc:sldChg chg="del">
-        <pc:chgData name="Matthieu De Mari" userId="dfb708c9-d8dc-439f-9a3b-c772bf4a311c" providerId="ADAL" clId="{9F6B3B9D-AADD-4622-81D6-CCF135E845F6}" dt="2023-02-06T02:27:25.777" v="1849" actId="47"/>
-        <pc:sldMkLst>
-          <pc:docMk/>
-          <pc:sldMk cId="3880949074" sldId="267"/>
-        </pc:sldMkLst>
-      </pc:sldChg>
-      <pc:sldChg chg="del">
-        <pc:chgData name="Matthieu De Mari" userId="dfb708c9-d8dc-439f-9a3b-c772bf4a311c" providerId="ADAL" clId="{9F6B3B9D-AADD-4622-81D6-CCF135E845F6}" dt="2023-02-06T02:27:24.564" v="1848" actId="47"/>
-        <pc:sldMkLst>
-          <pc:docMk/>
-          <pc:sldMk cId="1036081419" sldId="346"/>
-        </pc:sldMkLst>
-      </pc:sldChg>
-      <pc:sldChg chg="del">
-        <pc:chgData name="Matthieu De Mari" userId="dfb708c9-d8dc-439f-9a3b-c772bf4a311c" providerId="ADAL" clId="{9F6B3B9D-AADD-4622-81D6-CCF135E845F6}" dt="2023-02-06T02:27:15.094" v="1832" actId="47"/>
-        <pc:sldMkLst>
-          <pc:docMk/>
-          <pc:sldMk cId="2474697269" sldId="387"/>
-        </pc:sldMkLst>
-      </pc:sldChg>
-      <pc:sldChg chg="del">
-        <pc:chgData name="Matthieu De Mari" userId="dfb708c9-d8dc-439f-9a3b-c772bf4a311c" providerId="ADAL" clId="{9F6B3B9D-AADD-4622-81D6-CCF135E845F6}" dt="2023-02-06T02:27:15.959" v="1833" actId="47"/>
-        <pc:sldMkLst>
-          <pc:docMk/>
-          <pc:sldMk cId="4198773114" sldId="388"/>
-        </pc:sldMkLst>
-      </pc:sldChg>
-      <pc:sldChg chg="del">
-        <pc:chgData name="Matthieu De Mari" userId="dfb708c9-d8dc-439f-9a3b-c772bf4a311c" providerId="ADAL" clId="{9F6B3B9D-AADD-4622-81D6-CCF135E845F6}" dt="2023-02-06T02:27:16.550" v="1834" actId="47"/>
-        <pc:sldMkLst>
-          <pc:docMk/>
-          <pc:sldMk cId="481628505" sldId="389"/>
-        </pc:sldMkLst>
-      </pc:sldChg>
-      <pc:sldChg chg="del">
-        <pc:chgData name="Matthieu De Mari" userId="dfb708c9-d8dc-439f-9a3b-c772bf4a311c" providerId="ADAL" clId="{9F6B3B9D-AADD-4622-81D6-CCF135E845F6}" dt="2023-02-06T02:27:17.182" v="1835" actId="47"/>
-        <pc:sldMkLst>
-          <pc:docMk/>
-          <pc:sldMk cId="2128707751" sldId="390"/>
-        </pc:sldMkLst>
-      </pc:sldChg>
-      <pc:sldChg chg="del">
-        <pc:chgData name="Matthieu De Mari" userId="dfb708c9-d8dc-439f-9a3b-c772bf4a311c" providerId="ADAL" clId="{9F6B3B9D-AADD-4622-81D6-CCF135E845F6}" dt="2023-02-06T02:27:17.812" v="1836" actId="47"/>
-        <pc:sldMkLst>
-          <pc:docMk/>
-          <pc:sldMk cId="1283478655" sldId="391"/>
-        </pc:sldMkLst>
-      </pc:sldChg>
-      <pc:sldChg chg="del">
-        <pc:chgData name="Matthieu De Mari" userId="dfb708c9-d8dc-439f-9a3b-c772bf4a311c" providerId="ADAL" clId="{9F6B3B9D-AADD-4622-81D6-CCF135E845F6}" dt="2023-02-06T02:27:18.418" v="1837" actId="47"/>
-        <pc:sldMkLst>
-          <pc:docMk/>
-          <pc:sldMk cId="1341638402" sldId="392"/>
-        </pc:sldMkLst>
-      </pc:sldChg>
-      <pc:sldChg chg="del">
-        <pc:chgData name="Matthieu De Mari" userId="dfb708c9-d8dc-439f-9a3b-c772bf4a311c" providerId="ADAL" clId="{9F6B3B9D-AADD-4622-81D6-CCF135E845F6}" dt="2023-02-06T02:27:19.035" v="1838" actId="47"/>
-        <pc:sldMkLst>
-          <pc:docMk/>
-          <pc:sldMk cId="164097668" sldId="394"/>
-        </pc:sldMkLst>
-      </pc:sldChg>
-      <pc:sldChg chg="del">
-        <pc:chgData name="Matthieu De Mari" userId="dfb708c9-d8dc-439f-9a3b-c772bf4a311c" providerId="ADAL" clId="{9F6B3B9D-AADD-4622-81D6-CCF135E845F6}" dt="2023-02-06T02:27:19.649" v="1839" actId="47"/>
-        <pc:sldMkLst>
-          <pc:docMk/>
-          <pc:sldMk cId="3048177291" sldId="395"/>
-        </pc:sldMkLst>
-      </pc:sldChg>
-      <pc:sldChg chg="del">
-        <pc:chgData name="Matthieu De Mari" userId="dfb708c9-d8dc-439f-9a3b-c772bf4a311c" providerId="ADAL" clId="{9F6B3B9D-AADD-4622-81D6-CCF135E845F6}" dt="2023-02-06T02:27:20.221" v="1840" actId="47"/>
-        <pc:sldMkLst>
-          <pc:docMk/>
-          <pc:sldMk cId="1458730680" sldId="396"/>
-        </pc:sldMkLst>
-      </pc:sldChg>
-      <pc:sldChg chg="del">
-        <pc:chgData name="Matthieu De Mari" userId="dfb708c9-d8dc-439f-9a3b-c772bf4a311c" providerId="ADAL" clId="{9F6B3B9D-AADD-4622-81D6-CCF135E845F6}" dt="2023-02-06T02:27:20.844" v="1841" actId="47"/>
-        <pc:sldMkLst>
-          <pc:docMk/>
-          <pc:sldMk cId="1451434589" sldId="397"/>
-        </pc:sldMkLst>
-      </pc:sldChg>
-      <pc:sldChg chg="del">
-        <pc:chgData name="Matthieu De Mari" userId="dfb708c9-d8dc-439f-9a3b-c772bf4a311c" providerId="ADAL" clId="{9F6B3B9D-AADD-4622-81D6-CCF135E845F6}" dt="2023-02-06T02:27:21.366" v="1842" actId="47"/>
-        <pc:sldMkLst>
-          <pc:docMk/>
-          <pc:sldMk cId="2867637474" sldId="398"/>
-        </pc:sldMkLst>
-      </pc:sldChg>
-      <pc:sldChg chg="del">
-        <pc:chgData name="Matthieu De Mari" userId="dfb708c9-d8dc-439f-9a3b-c772bf4a311c" providerId="ADAL" clId="{9F6B3B9D-AADD-4622-81D6-CCF135E845F6}" dt="2023-02-06T02:27:21.903" v="1843" actId="47"/>
-        <pc:sldMkLst>
-          <pc:docMk/>
-          <pc:sldMk cId="122423608" sldId="399"/>
-        </pc:sldMkLst>
-      </pc:sldChg>
-      <pc:sldChg chg="del">
-        <pc:chgData name="Matthieu De Mari" userId="dfb708c9-d8dc-439f-9a3b-c772bf4a311c" providerId="ADAL" clId="{9F6B3B9D-AADD-4622-81D6-CCF135E845F6}" dt="2023-02-06T02:27:22.445" v="1844" actId="47"/>
-        <pc:sldMkLst>
-          <pc:docMk/>
-          <pc:sldMk cId="2642959288" sldId="400"/>
-        </pc:sldMkLst>
-      </pc:sldChg>
-      <pc:sldChg chg="del">
-        <pc:chgData name="Matthieu De Mari" userId="dfb708c9-d8dc-439f-9a3b-c772bf4a311c" providerId="ADAL" clId="{9F6B3B9D-AADD-4622-81D6-CCF135E845F6}" dt="2023-02-06T02:27:22.965" v="1845" actId="47"/>
-        <pc:sldMkLst>
-          <pc:docMk/>
-          <pc:sldMk cId="4039171501" sldId="401"/>
-        </pc:sldMkLst>
-      </pc:sldChg>
-      <pc:sldChg chg="del">
-        <pc:chgData name="Matthieu De Mari" userId="dfb708c9-d8dc-439f-9a3b-c772bf4a311c" providerId="ADAL" clId="{9F6B3B9D-AADD-4622-81D6-CCF135E845F6}" dt="2023-02-06T02:27:23.507" v="1846" actId="47"/>
-        <pc:sldMkLst>
-          <pc:docMk/>
-          <pc:sldMk cId="3163596145" sldId="402"/>
-        </pc:sldMkLst>
-      </pc:sldChg>
-      <pc:sldChg chg="del">
-        <pc:chgData name="Matthieu De Mari" userId="dfb708c9-d8dc-439f-9a3b-c772bf4a311c" providerId="ADAL" clId="{9F6B3B9D-AADD-4622-81D6-CCF135E845F6}" dt="2023-02-06T02:27:24.019" v="1847" actId="47"/>
-        <pc:sldMkLst>
-          <pc:docMk/>
-          <pc:sldMk cId="101927766" sldId="403"/>
-        </pc:sldMkLst>
-      </pc:sldChg>
-      <pc:sldChg chg="modSp mod">
-        <pc:chgData name="Matthieu De Mari" userId="dfb708c9-d8dc-439f-9a3b-c772bf4a311c" providerId="ADAL" clId="{9F6B3B9D-AADD-4622-81D6-CCF135E845F6}" dt="2023-02-06T02:21:45.191" v="676" actId="113"/>
-        <pc:sldMkLst>
-          <pc:docMk/>
-          <pc:sldMk cId="2917324732" sldId="760"/>
-        </pc:sldMkLst>
-      </pc:sldChg>
-      <pc:sldChg chg="del">
-        <pc:chgData name="Matthieu De Mari" userId="dfb708c9-d8dc-439f-9a3b-c772bf4a311c" providerId="ADAL" clId="{9F6B3B9D-AADD-4622-81D6-CCF135E845F6}" dt="2023-02-06T02:27:15.094" v="1832" actId="47"/>
-        <pc:sldMkLst>
-          <pc:docMk/>
-          <pc:sldMk cId="3339699406" sldId="761"/>
-        </pc:sldMkLst>
-      </pc:sldChg>
-      <pc:sldChg chg="del">
-        <pc:chgData name="Matthieu De Mari" userId="dfb708c9-d8dc-439f-9a3b-c772bf4a311c" providerId="ADAL" clId="{9F6B3B9D-AADD-4622-81D6-CCF135E845F6}" dt="2023-02-06T02:27:15.094" v="1832" actId="47"/>
-        <pc:sldMkLst>
-          <pc:docMk/>
-          <pc:sldMk cId="1546007078" sldId="762"/>
-        </pc:sldMkLst>
-      </pc:sldChg>
-      <pc:sldChg chg="del">
-        <pc:chgData name="Matthieu De Mari" userId="dfb708c9-d8dc-439f-9a3b-c772bf4a311c" providerId="ADAL" clId="{9F6B3B9D-AADD-4622-81D6-CCF135E845F6}" dt="2023-02-06T02:27:15.094" v="1832" actId="47"/>
-        <pc:sldMkLst>
-          <pc:docMk/>
-          <pc:sldMk cId="2580175991" sldId="763"/>
-        </pc:sldMkLst>
-      </pc:sldChg>
-      <pc:sldChg chg="del">
-        <pc:chgData name="Matthieu De Mari" userId="dfb708c9-d8dc-439f-9a3b-c772bf4a311c" providerId="ADAL" clId="{9F6B3B9D-AADD-4622-81D6-CCF135E845F6}" dt="2023-02-06T02:27:15.094" v="1832" actId="47"/>
-        <pc:sldMkLst>
-          <pc:docMk/>
-          <pc:sldMk cId="1879463264" sldId="764"/>
-        </pc:sldMkLst>
-      </pc:sldChg>
-      <pc:sldChg chg="del">
-        <pc:chgData name="Matthieu De Mari" userId="dfb708c9-d8dc-439f-9a3b-c772bf4a311c" providerId="ADAL" clId="{9F6B3B9D-AADD-4622-81D6-CCF135E845F6}" dt="2023-02-06T02:27:15.959" v="1833" actId="47"/>
-        <pc:sldMkLst>
-          <pc:docMk/>
-          <pc:sldMk cId="1996337912" sldId="765"/>
-        </pc:sldMkLst>
-      </pc:sldChg>
-      <pc:sldChg chg="del">
-        <pc:chgData name="Matthieu De Mari" userId="dfb708c9-d8dc-439f-9a3b-c772bf4a311c" providerId="ADAL" clId="{9F6B3B9D-AADD-4622-81D6-CCF135E845F6}" dt="2023-02-06T02:27:16.550" v="1834" actId="47"/>
-        <pc:sldMkLst>
-          <pc:docMk/>
-          <pc:sldMk cId="1554669076" sldId="766"/>
-        </pc:sldMkLst>
-      </pc:sldChg>
-      <pc:sldChg chg="del">
-        <pc:chgData name="Matthieu De Mari" userId="dfb708c9-d8dc-439f-9a3b-c772bf4a311c" providerId="ADAL" clId="{9F6B3B9D-AADD-4622-81D6-CCF135E845F6}" dt="2023-02-06T02:27:16.550" v="1834" actId="47"/>
-        <pc:sldMkLst>
-          <pc:docMk/>
-          <pc:sldMk cId="887698529" sldId="767"/>
-        </pc:sldMkLst>
-      </pc:sldChg>
-      <pc:sldChg chg="del">
-        <pc:chgData name="Matthieu De Mari" userId="dfb708c9-d8dc-439f-9a3b-c772bf4a311c" providerId="ADAL" clId="{9F6B3B9D-AADD-4622-81D6-CCF135E845F6}" dt="2023-02-06T02:27:16.550" v="1834" actId="47"/>
-        <pc:sldMkLst>
-          <pc:docMk/>
-          <pc:sldMk cId="3101493777" sldId="768"/>
-        </pc:sldMkLst>
-      </pc:sldChg>
-      <pc:sldChg chg="del">
-        <pc:chgData name="Matthieu De Mari" userId="dfb708c9-d8dc-439f-9a3b-c772bf4a311c" providerId="ADAL" clId="{9F6B3B9D-AADD-4622-81D6-CCF135E845F6}" dt="2023-02-06T02:27:17.182" v="1835" actId="47"/>
-        <pc:sldMkLst>
-          <pc:docMk/>
-          <pc:sldMk cId="2909899754" sldId="769"/>
-        </pc:sldMkLst>
-      </pc:sldChg>
-      <pc:sldChg chg="del">
-        <pc:chgData name="Matthieu De Mari" userId="dfb708c9-d8dc-439f-9a3b-c772bf4a311c" providerId="ADAL" clId="{9F6B3B9D-AADD-4622-81D6-CCF135E845F6}" dt="2023-02-06T02:27:17.182" v="1835" actId="47"/>
-        <pc:sldMkLst>
-          <pc:docMk/>
-          <pc:sldMk cId="581091786" sldId="770"/>
-        </pc:sldMkLst>
-      </pc:sldChg>
-      <pc:sldChg chg="del">
-        <pc:chgData name="Matthieu De Mari" userId="dfb708c9-d8dc-439f-9a3b-c772bf4a311c" providerId="ADAL" clId="{9F6B3B9D-AADD-4622-81D6-CCF135E845F6}" dt="2023-02-06T02:27:17.182" v="1835" actId="47"/>
-        <pc:sldMkLst>
-          <pc:docMk/>
-          <pc:sldMk cId="2768410648" sldId="771"/>
-        </pc:sldMkLst>
-      </pc:sldChg>
-      <pc:sldChg chg="del">
-        <pc:chgData name="Matthieu De Mari" userId="dfb708c9-d8dc-439f-9a3b-c772bf4a311c" providerId="ADAL" clId="{9F6B3B9D-AADD-4622-81D6-CCF135E845F6}" dt="2023-02-06T02:27:17.182" v="1835" actId="47"/>
-        <pc:sldMkLst>
-          <pc:docMk/>
-          <pc:sldMk cId="2791462929" sldId="772"/>
-        </pc:sldMkLst>
-      </pc:sldChg>
-      <pc:sldChg chg="del">
-        <pc:chgData name="Matthieu De Mari" userId="dfb708c9-d8dc-439f-9a3b-c772bf4a311c" providerId="ADAL" clId="{9F6B3B9D-AADD-4622-81D6-CCF135E845F6}" dt="2023-02-06T02:27:17.182" v="1835" actId="47"/>
-        <pc:sldMkLst>
-          <pc:docMk/>
-          <pc:sldMk cId="3544439591" sldId="773"/>
-        </pc:sldMkLst>
-      </pc:sldChg>
-      <pc:sldChg chg="del">
-        <pc:chgData name="Matthieu De Mari" userId="dfb708c9-d8dc-439f-9a3b-c772bf4a311c" providerId="ADAL" clId="{9F6B3B9D-AADD-4622-81D6-CCF135E845F6}" dt="2023-02-06T02:27:17.182" v="1835" actId="47"/>
-        <pc:sldMkLst>
-          <pc:docMk/>
-          <pc:sldMk cId="2831341972" sldId="774"/>
-        </pc:sldMkLst>
-      </pc:sldChg>
-      <pc:sldChg chg="del">
-        <pc:chgData name="Matthieu De Mari" userId="dfb708c9-d8dc-439f-9a3b-c772bf4a311c" providerId="ADAL" clId="{9F6B3B9D-AADD-4622-81D6-CCF135E845F6}" dt="2023-02-06T02:27:17.812" v="1836" actId="47"/>
-        <pc:sldMkLst>
-          <pc:docMk/>
-          <pc:sldMk cId="743119883" sldId="775"/>
-        </pc:sldMkLst>
-      </pc:sldChg>
-      <pc:sldChg chg="del">
-        <pc:chgData name="Matthieu De Mari" userId="dfb708c9-d8dc-439f-9a3b-c772bf4a311c" providerId="ADAL" clId="{9F6B3B9D-AADD-4622-81D6-CCF135E845F6}" dt="2023-02-06T02:27:17.812" v="1836" actId="47"/>
-        <pc:sldMkLst>
-          <pc:docMk/>
-          <pc:sldMk cId="1966383991" sldId="776"/>
-        </pc:sldMkLst>
-      </pc:sldChg>
-      <pc:sldChg chg="del">
-        <pc:chgData name="Matthieu De Mari" userId="dfb708c9-d8dc-439f-9a3b-c772bf4a311c" providerId="ADAL" clId="{9F6B3B9D-AADD-4622-81D6-CCF135E845F6}" dt="2023-02-06T02:27:17.812" v="1836" actId="47"/>
-        <pc:sldMkLst>
-          <pc:docMk/>
-          <pc:sldMk cId="3349972987" sldId="777"/>
-        </pc:sldMkLst>
-      </pc:sldChg>
-      <pc:sldChg chg="del">
-        <pc:chgData name="Matthieu De Mari" userId="dfb708c9-d8dc-439f-9a3b-c772bf4a311c" providerId="ADAL" clId="{9F6B3B9D-AADD-4622-81D6-CCF135E845F6}" dt="2023-02-06T02:27:18.418" v="1837" actId="47"/>
-        <pc:sldMkLst>
-          <pc:docMk/>
-          <pc:sldMk cId="4008937125" sldId="778"/>
-        </pc:sldMkLst>
-      </pc:sldChg>
-      <pc:sldChg chg="del">
-        <pc:chgData name="Matthieu De Mari" userId="dfb708c9-d8dc-439f-9a3b-c772bf4a311c" providerId="ADAL" clId="{9F6B3B9D-AADD-4622-81D6-CCF135E845F6}" dt="2023-02-06T02:27:18.418" v="1837" actId="47"/>
-        <pc:sldMkLst>
-          <pc:docMk/>
-          <pc:sldMk cId="1689794110" sldId="779"/>
-        </pc:sldMkLst>
-      </pc:sldChg>
-      <pc:sldChg chg="del">
-        <pc:chgData name="Matthieu De Mari" userId="dfb708c9-d8dc-439f-9a3b-c772bf4a311c" providerId="ADAL" clId="{9F6B3B9D-AADD-4622-81D6-CCF135E845F6}" dt="2023-02-06T02:27:19.035" v="1838" actId="47"/>
-        <pc:sldMkLst>
-          <pc:docMk/>
-          <pc:sldMk cId="2678238830" sldId="780"/>
-        </pc:sldMkLst>
-      </pc:sldChg>
-      <pc:sldChg chg="del">
-        <pc:chgData name="Matthieu De Mari" userId="dfb708c9-d8dc-439f-9a3b-c772bf4a311c" providerId="ADAL" clId="{9F6B3B9D-AADD-4622-81D6-CCF135E845F6}" dt="2023-02-06T02:27:19.649" v="1839" actId="47"/>
-        <pc:sldMkLst>
-          <pc:docMk/>
-          <pc:sldMk cId="3029045816" sldId="781"/>
-        </pc:sldMkLst>
-      </pc:sldChg>
-      <pc:sldChg chg="del">
-        <pc:chgData name="Matthieu De Mari" userId="dfb708c9-d8dc-439f-9a3b-c772bf4a311c" providerId="ADAL" clId="{9F6B3B9D-AADD-4622-81D6-CCF135E845F6}" dt="2023-02-06T02:27:19.649" v="1839" actId="47"/>
-        <pc:sldMkLst>
-          <pc:docMk/>
-          <pc:sldMk cId="278531271" sldId="782"/>
-        </pc:sldMkLst>
-      </pc:sldChg>
-      <pc:sldChg chg="modSp add mod">
-        <pc:chgData name="Matthieu De Mari" userId="dfb708c9-d8dc-439f-9a3b-c772bf4a311c" providerId="ADAL" clId="{9F6B3B9D-AADD-4622-81D6-CCF135E845F6}" dt="2023-02-06T02:24:41.655" v="1266" actId="113"/>
-        <pc:sldMkLst>
-          <pc:docMk/>
-          <pc:sldMk cId="2670805330" sldId="783"/>
-        </pc:sldMkLst>
-      </pc:sldChg>
-      <pc:sldChg chg="modSp add mod">
-        <pc:chgData name="Matthieu De Mari" userId="dfb708c9-d8dc-439f-9a3b-c772bf4a311c" providerId="ADAL" clId="{9F6B3B9D-AADD-4622-81D6-CCF135E845F6}" dt="2023-02-06T02:27:03.468" v="1831" actId="113"/>
-        <pc:sldMkLst>
-          <pc:docMk/>
-          <pc:sldMk cId="636279122" sldId="784"/>
-        </pc:sldMkLst>
-      </pc:sldChg>
-    </pc:docChg>
-  </pc:docChgLst>
-  <pc:docChgLst>
-    <pc:chgData name="Matthieu De Mari" userId="dfb708c9-d8dc-439f-9a3b-c772bf4a311c" providerId="ADAL" clId="{8EE40018-26BD-4A7B-8D17-70AC8417C2D0}"/>
-    <pc:docChg chg="undo custSel addSld delSld modSld addSection delSection modSection">
-      <pc:chgData name="Matthieu De Mari" userId="dfb708c9-d8dc-439f-9a3b-c772bf4a311c" providerId="ADAL" clId="{8EE40018-26BD-4A7B-8D17-70AC8417C2D0}" dt="2022-11-16T06:55:05.435" v="67" actId="47"/>
-      <pc:docMkLst>
-        <pc:docMk/>
-      </pc:docMkLst>
-      <pc:sldChg chg="modSp mod">
-        <pc:chgData name="Matthieu De Mari" userId="dfb708c9-d8dc-439f-9a3b-c772bf4a311c" providerId="ADAL" clId="{8EE40018-26BD-4A7B-8D17-70AC8417C2D0}" dt="2022-11-16T06:55:04.205" v="66" actId="20577"/>
-        <pc:sldMkLst>
-          <pc:docMk/>
-          <pc:sldMk cId="3442501962" sldId="257"/>
-        </pc:sldMkLst>
-      </pc:sldChg>
-      <pc:sldChg chg="del">
-        <pc:chgData name="Matthieu De Mari" userId="dfb708c9-d8dc-439f-9a3b-c772bf4a311c" providerId="ADAL" clId="{8EE40018-26BD-4A7B-8D17-70AC8417C2D0}" dt="2022-11-16T06:54:01.441" v="17" actId="47"/>
-        <pc:sldMkLst>
-          <pc:docMk/>
-          <pc:sldMk cId="3556835968" sldId="261"/>
-        </pc:sldMkLst>
-      </pc:sldChg>
-      <pc:sldChg chg="modSp mod">
-        <pc:chgData name="Matthieu De Mari" userId="dfb708c9-d8dc-439f-9a3b-c772bf4a311c" providerId="ADAL" clId="{8EE40018-26BD-4A7B-8D17-70AC8417C2D0}" dt="2022-11-16T06:54:47.612" v="47" actId="20577"/>
-        <pc:sldMkLst>
-          <pc:docMk/>
-          <pc:sldMk cId="1893873068" sldId="266"/>
-        </pc:sldMkLst>
-      </pc:sldChg>
-      <pc:sldChg chg="modSp mod">
-        <pc:chgData name="Matthieu De Mari" userId="dfb708c9-d8dc-439f-9a3b-c772bf4a311c" providerId="ADAL" clId="{8EE40018-26BD-4A7B-8D17-70AC8417C2D0}" dt="2022-11-16T06:54:56.797" v="60" actId="20577"/>
-        <pc:sldMkLst>
-          <pc:docMk/>
-          <pc:sldMk cId="3880949074" sldId="267"/>
-        </pc:sldMkLst>
-      </pc:sldChg>
-      <pc:sldChg chg="del">
-        <pc:chgData name="Matthieu De Mari" userId="dfb708c9-d8dc-439f-9a3b-c772bf4a311c" providerId="ADAL" clId="{8EE40018-26BD-4A7B-8D17-70AC8417C2D0}" dt="2022-11-16T06:54:02.421" v="18" actId="47"/>
-        <pc:sldMkLst>
-          <pc:docMk/>
-          <pc:sldMk cId="969289828" sldId="271"/>
-        </pc:sldMkLst>
-      </pc:sldChg>
-      <pc:sldChg chg="del">
-        <pc:chgData name="Matthieu De Mari" userId="dfb708c9-d8dc-439f-9a3b-c772bf4a311c" providerId="ADAL" clId="{8EE40018-26BD-4A7B-8D17-70AC8417C2D0}" dt="2022-11-16T06:54:02.421" v="18" actId="47"/>
-        <pc:sldMkLst>
-          <pc:docMk/>
-          <pc:sldMk cId="543657650" sldId="273"/>
-        </pc:sldMkLst>
-      </pc:sldChg>
-      <pc:sldChg chg="del">
-        <pc:chgData name="Matthieu De Mari" userId="dfb708c9-d8dc-439f-9a3b-c772bf4a311c" providerId="ADAL" clId="{8EE40018-26BD-4A7B-8D17-70AC8417C2D0}" dt="2022-11-16T06:54:01.441" v="17" actId="47"/>
-        <pc:sldMkLst>
-          <pc:docMk/>
-          <pc:sldMk cId="3687792543" sldId="275"/>
-        </pc:sldMkLst>
-      </pc:sldChg>
-      <pc:sldChg chg="del">
-        <pc:chgData name="Matthieu De Mari" userId="dfb708c9-d8dc-439f-9a3b-c772bf4a311c" providerId="ADAL" clId="{8EE40018-26BD-4A7B-8D17-70AC8417C2D0}" dt="2022-11-16T06:54:03.510" v="19" actId="47"/>
-        <pc:sldMkLst>
-          <pc:docMk/>
-          <pc:sldMk cId="1852878019" sldId="276"/>
-        </pc:sldMkLst>
-      </pc:sldChg>
-      <pc:sldChg chg="del">
-        <pc:chgData name="Matthieu De Mari" userId="dfb708c9-d8dc-439f-9a3b-c772bf4a311c" providerId="ADAL" clId="{8EE40018-26BD-4A7B-8D17-70AC8417C2D0}" dt="2022-11-16T06:54:02.421" v="18" actId="47"/>
-        <pc:sldMkLst>
-          <pc:docMk/>
-          <pc:sldMk cId="355509003" sldId="278"/>
-        </pc:sldMkLst>
-      </pc:sldChg>
-      <pc:sldChg chg="del">
-        <pc:chgData name="Matthieu De Mari" userId="dfb708c9-d8dc-439f-9a3b-c772bf4a311c" providerId="ADAL" clId="{8EE40018-26BD-4A7B-8D17-70AC8417C2D0}" dt="2022-11-16T06:54:02.421" v="18" actId="47"/>
-        <pc:sldMkLst>
-          <pc:docMk/>
-          <pc:sldMk cId="3873470932" sldId="280"/>
-        </pc:sldMkLst>
-      </pc:sldChg>
-      <pc:sldChg chg="del">
-        <pc:chgData name="Matthieu De Mari" userId="dfb708c9-d8dc-439f-9a3b-c772bf4a311c" providerId="ADAL" clId="{8EE40018-26BD-4A7B-8D17-70AC8417C2D0}" dt="2022-11-16T06:54:02.421" v="18" actId="47"/>
-        <pc:sldMkLst>
-          <pc:docMk/>
-          <pc:sldMk cId="3477464442" sldId="281"/>
-        </pc:sldMkLst>
-      </pc:sldChg>
-      <pc:sldChg chg="del">
-        <pc:chgData name="Matthieu De Mari" userId="dfb708c9-d8dc-439f-9a3b-c772bf4a311c" providerId="ADAL" clId="{8EE40018-26BD-4A7B-8D17-70AC8417C2D0}" dt="2022-11-16T06:54:02.421" v="18" actId="47"/>
-        <pc:sldMkLst>
-          <pc:docMk/>
-          <pc:sldMk cId="4219540979" sldId="282"/>
-        </pc:sldMkLst>
-      </pc:sldChg>
-      <pc:sldChg chg="modSp del mod">
-        <pc:chgData name="Matthieu De Mari" userId="dfb708c9-d8dc-439f-9a3b-c772bf4a311c" providerId="ADAL" clId="{8EE40018-26BD-4A7B-8D17-70AC8417C2D0}" dt="2022-11-16T06:55:05.435" v="67" actId="47"/>
-        <pc:sldMkLst>
-          <pc:docMk/>
-          <pc:sldMk cId="2071167148" sldId="284"/>
-        </pc:sldMkLst>
-      </pc:sldChg>
-      <pc:sldChg chg="del">
-        <pc:chgData name="Matthieu De Mari" userId="dfb708c9-d8dc-439f-9a3b-c772bf4a311c" providerId="ADAL" clId="{8EE40018-26BD-4A7B-8D17-70AC8417C2D0}" dt="2022-11-16T06:54:14.637" v="28" actId="47"/>
-        <pc:sldMkLst>
-          <pc:docMk/>
-          <pc:sldMk cId="3743280645" sldId="285"/>
-        </pc:sldMkLst>
-      </pc:sldChg>
-      <pc:sldChg chg="del">
-        <pc:chgData name="Matthieu De Mari" userId="dfb708c9-d8dc-439f-9a3b-c772bf4a311c" providerId="ADAL" clId="{8EE40018-26BD-4A7B-8D17-70AC8417C2D0}" dt="2022-11-16T06:54:02.421" v="18" actId="47"/>
-        <pc:sldMkLst>
-          <pc:docMk/>
-          <pc:sldMk cId="2640130553" sldId="286"/>
-        </pc:sldMkLst>
-      </pc:sldChg>
-      <pc:sldChg chg="del">
-        <pc:chgData name="Matthieu De Mari" userId="dfb708c9-d8dc-439f-9a3b-c772bf4a311c" providerId="ADAL" clId="{8EE40018-26BD-4A7B-8D17-70AC8417C2D0}" dt="2022-11-16T06:54:03.510" v="19" actId="47"/>
-        <pc:sldMkLst>
-          <pc:docMk/>
-          <pc:sldMk cId="3356285317" sldId="289"/>
-        </pc:sldMkLst>
-      </pc:sldChg>
-      <pc:sldChg chg="del">
-        <pc:chgData name="Matthieu De Mari" userId="dfb708c9-d8dc-439f-9a3b-c772bf4a311c" providerId="ADAL" clId="{8EE40018-26BD-4A7B-8D17-70AC8417C2D0}" dt="2022-11-16T06:54:03.510" v="19" actId="47"/>
-        <pc:sldMkLst>
-          <pc:docMk/>
-          <pc:sldMk cId="473860244" sldId="290"/>
-        </pc:sldMkLst>
-      </pc:sldChg>
-      <pc:sldChg chg="del">
-        <pc:chgData name="Matthieu De Mari" userId="dfb708c9-d8dc-439f-9a3b-c772bf4a311c" providerId="ADAL" clId="{8EE40018-26BD-4A7B-8D17-70AC8417C2D0}" dt="2022-11-16T06:54:03.510" v="19" actId="47"/>
-        <pc:sldMkLst>
-          <pc:docMk/>
-          <pc:sldMk cId="290213158" sldId="291"/>
-        </pc:sldMkLst>
-      </pc:sldChg>
-      <pc:sldChg chg="del">
-        <pc:chgData name="Matthieu De Mari" userId="dfb708c9-d8dc-439f-9a3b-c772bf4a311c" providerId="ADAL" clId="{8EE40018-26BD-4A7B-8D17-70AC8417C2D0}" dt="2022-11-16T06:54:03.510" v="19" actId="47"/>
-        <pc:sldMkLst>
-          <pc:docMk/>
-          <pc:sldMk cId="3717810270" sldId="292"/>
-        </pc:sldMkLst>
-      </pc:sldChg>
-      <pc:sldChg chg="del">
-        <pc:chgData name="Matthieu De Mari" userId="dfb708c9-d8dc-439f-9a3b-c772bf4a311c" providerId="ADAL" clId="{8EE40018-26BD-4A7B-8D17-70AC8417C2D0}" dt="2022-11-16T06:54:03.510" v="19" actId="47"/>
-        <pc:sldMkLst>
-          <pc:docMk/>
-          <pc:sldMk cId="2783948156" sldId="293"/>
-        </pc:sldMkLst>
-      </pc:sldChg>
-      <pc:sldChg chg="del">
-        <pc:chgData name="Matthieu De Mari" userId="dfb708c9-d8dc-439f-9a3b-c772bf4a311c" providerId="ADAL" clId="{8EE40018-26BD-4A7B-8D17-70AC8417C2D0}" dt="2022-11-16T06:54:04.458" v="20" actId="47"/>
-        <pc:sldMkLst>
-          <pc:docMk/>
-          <pc:sldMk cId="4179829315" sldId="294"/>
-        </pc:sldMkLst>
-      </pc:sldChg>
-      <pc:sldChg chg="del">
-        <pc:chgData name="Matthieu De Mari" userId="dfb708c9-d8dc-439f-9a3b-c772bf4a311c" providerId="ADAL" clId="{8EE40018-26BD-4A7B-8D17-70AC8417C2D0}" dt="2022-11-16T06:54:12.971" v="26" actId="47"/>
-        <pc:sldMkLst>
-          <pc:docMk/>
-          <pc:sldMk cId="709624762" sldId="295"/>
-        </pc:sldMkLst>
-      </pc:sldChg>
-      <pc:sldChg chg="del">
-        <pc:chgData name="Matthieu De Mari" userId="dfb708c9-d8dc-439f-9a3b-c772bf4a311c" providerId="ADAL" clId="{8EE40018-26BD-4A7B-8D17-70AC8417C2D0}" dt="2022-11-16T06:54:11.293" v="25" actId="47"/>
-        <pc:sldMkLst>
-          <pc:docMk/>
-          <pc:sldMk cId="2576857052" sldId="297"/>
-        </pc:sldMkLst>
-      </pc:sldChg>
-      <pc:sldChg chg="del">
-        <pc:chgData name="Matthieu De Mari" userId="dfb708c9-d8dc-439f-9a3b-c772bf4a311c" providerId="ADAL" clId="{8EE40018-26BD-4A7B-8D17-70AC8417C2D0}" dt="2022-11-16T06:54:04.458" v="20" actId="47"/>
-        <pc:sldMkLst>
-          <pc:docMk/>
-          <pc:sldMk cId="1885656403" sldId="298"/>
-        </pc:sldMkLst>
-      </pc:sldChg>
-      <pc:sldChg chg="del">
-        <pc:chgData name="Matthieu De Mari" userId="dfb708c9-d8dc-439f-9a3b-c772bf4a311c" providerId="ADAL" clId="{8EE40018-26BD-4A7B-8D17-70AC8417C2D0}" dt="2022-11-16T06:54:04.458" v="20" actId="47"/>
-        <pc:sldMkLst>
-          <pc:docMk/>
-          <pc:sldMk cId="3768793426" sldId="299"/>
-        </pc:sldMkLst>
-      </pc:sldChg>
-      <pc:sldChg chg="del">
-        <pc:chgData name="Matthieu De Mari" userId="dfb708c9-d8dc-439f-9a3b-c772bf4a311c" providerId="ADAL" clId="{8EE40018-26BD-4A7B-8D17-70AC8417C2D0}" dt="2022-11-16T06:54:07.519" v="22" actId="47"/>
-        <pc:sldMkLst>
-          <pc:docMk/>
-          <pc:sldMk cId="902380433" sldId="300"/>
-        </pc:sldMkLst>
-      </pc:sldChg>
-      <pc:sldChg chg="del">
-        <pc:chgData name="Matthieu De Mari" userId="dfb708c9-d8dc-439f-9a3b-c772bf4a311c" providerId="ADAL" clId="{8EE40018-26BD-4A7B-8D17-70AC8417C2D0}" dt="2022-11-16T06:54:08.404" v="23" actId="47"/>
-        <pc:sldMkLst>
-          <pc:docMk/>
-          <pc:sldMk cId="2202284175" sldId="301"/>
-        </pc:sldMkLst>
-      </pc:sldChg>
-      <pc:sldChg chg="del">
-        <pc:chgData name="Matthieu De Mari" userId="dfb708c9-d8dc-439f-9a3b-c772bf4a311c" providerId="ADAL" clId="{8EE40018-26BD-4A7B-8D17-70AC8417C2D0}" dt="2022-11-16T06:54:09.190" v="24" actId="47"/>
-        <pc:sldMkLst>
-          <pc:docMk/>
-          <pc:sldMk cId="1547433389" sldId="302"/>
-        </pc:sldMkLst>
-      </pc:sldChg>
-      <pc:sldChg chg="del">
-        <pc:chgData name="Matthieu De Mari" userId="dfb708c9-d8dc-439f-9a3b-c772bf4a311c" providerId="ADAL" clId="{8EE40018-26BD-4A7B-8D17-70AC8417C2D0}" dt="2022-11-16T06:54:04.458" v="20" actId="47"/>
-        <pc:sldMkLst>
-          <pc:docMk/>
-          <pc:sldMk cId="3335250243" sldId="303"/>
-        </pc:sldMkLst>
-      </pc:sldChg>
-      <pc:sldChg chg="del">
-        <pc:chgData name="Matthieu De Mari" userId="dfb708c9-d8dc-439f-9a3b-c772bf4a311c" providerId="ADAL" clId="{8EE40018-26BD-4A7B-8D17-70AC8417C2D0}" dt="2022-11-16T06:54:03.510" v="19" actId="47"/>
-        <pc:sldMkLst>
-          <pc:docMk/>
-          <pc:sldMk cId="349456406" sldId="305"/>
-        </pc:sldMkLst>
-      </pc:sldChg>
-      <pc:sldChg chg="del">
-        <pc:chgData name="Matthieu De Mari" userId="dfb708c9-d8dc-439f-9a3b-c772bf4a311c" providerId="ADAL" clId="{8EE40018-26BD-4A7B-8D17-70AC8417C2D0}" dt="2022-11-16T06:54:06.554" v="21" actId="47"/>
-        <pc:sldMkLst>
-          <pc:docMk/>
-          <pc:sldMk cId="1917974936" sldId="307"/>
-        </pc:sldMkLst>
-      </pc:sldChg>
-      <pc:sldChg chg="del">
-        <pc:chgData name="Matthieu De Mari" userId="dfb708c9-d8dc-439f-9a3b-c772bf4a311c" providerId="ADAL" clId="{8EE40018-26BD-4A7B-8D17-70AC8417C2D0}" dt="2022-11-16T06:54:06.554" v="21" actId="47"/>
-        <pc:sldMkLst>
-          <pc:docMk/>
-          <pc:sldMk cId="2278752964" sldId="309"/>
-        </pc:sldMkLst>
-      </pc:sldChg>
-      <pc:sldChg chg="del">
-        <pc:chgData name="Matthieu De Mari" userId="dfb708c9-d8dc-439f-9a3b-c772bf4a311c" providerId="ADAL" clId="{8EE40018-26BD-4A7B-8D17-70AC8417C2D0}" dt="2022-11-16T06:54:06.554" v="21" actId="47"/>
-        <pc:sldMkLst>
-          <pc:docMk/>
-          <pc:sldMk cId="3317882412" sldId="310"/>
-        </pc:sldMkLst>
-      </pc:sldChg>
-      <pc:sldChg chg="del">
-        <pc:chgData name="Matthieu De Mari" userId="dfb708c9-d8dc-439f-9a3b-c772bf4a311c" providerId="ADAL" clId="{8EE40018-26BD-4A7B-8D17-70AC8417C2D0}" dt="2022-11-16T06:54:06.554" v="21" actId="47"/>
-        <pc:sldMkLst>
-          <pc:docMk/>
-          <pc:sldMk cId="3051144984" sldId="311"/>
-        </pc:sldMkLst>
-      </pc:sldChg>
-      <pc:sldChg chg="del">
-        <pc:chgData name="Matthieu De Mari" userId="dfb708c9-d8dc-439f-9a3b-c772bf4a311c" providerId="ADAL" clId="{8EE40018-26BD-4A7B-8D17-70AC8417C2D0}" dt="2022-11-16T06:54:06.554" v="21" actId="47"/>
-        <pc:sldMkLst>
-          <pc:docMk/>
-          <pc:sldMk cId="666448182" sldId="313"/>
-        </pc:sldMkLst>
-      </pc:sldChg>
-      <pc:sldChg chg="del">
-        <pc:chgData name="Matthieu De Mari" userId="dfb708c9-d8dc-439f-9a3b-c772bf4a311c" providerId="ADAL" clId="{8EE40018-26BD-4A7B-8D17-70AC8417C2D0}" dt="2022-11-16T06:54:06.554" v="21" actId="47"/>
-        <pc:sldMkLst>
-          <pc:docMk/>
-          <pc:sldMk cId="1701431758" sldId="314"/>
-        </pc:sldMkLst>
-      </pc:sldChg>
-      <pc:sldChg chg="del">
-        <pc:chgData name="Matthieu De Mari" userId="dfb708c9-d8dc-439f-9a3b-c772bf4a311c" providerId="ADAL" clId="{8EE40018-26BD-4A7B-8D17-70AC8417C2D0}" dt="2022-11-16T06:54:06.554" v="21" actId="47"/>
-        <pc:sldMkLst>
-          <pc:docMk/>
-          <pc:sldMk cId="1813469429" sldId="315"/>
-        </pc:sldMkLst>
-      </pc:sldChg>
-      <pc:sldChg chg="del">
-        <pc:chgData name="Matthieu De Mari" userId="dfb708c9-d8dc-439f-9a3b-c772bf4a311c" providerId="ADAL" clId="{8EE40018-26BD-4A7B-8D17-70AC8417C2D0}" dt="2022-11-16T06:54:07.519" v="22" actId="47"/>
-        <pc:sldMkLst>
-          <pc:docMk/>
-          <pc:sldMk cId="3619476332" sldId="316"/>
-        </pc:sldMkLst>
-      </pc:sldChg>
-      <pc:sldChg chg="del">
-        <pc:chgData name="Matthieu De Mari" userId="dfb708c9-d8dc-439f-9a3b-c772bf4a311c" providerId="ADAL" clId="{8EE40018-26BD-4A7B-8D17-70AC8417C2D0}" dt="2022-11-16T06:54:07.519" v="22" actId="47"/>
-        <pc:sldMkLst>
-          <pc:docMk/>
-          <pc:sldMk cId="3133188960" sldId="317"/>
-        </pc:sldMkLst>
-      </pc:sldChg>
-      <pc:sldChg chg="del">
-        <pc:chgData name="Matthieu De Mari" userId="dfb708c9-d8dc-439f-9a3b-c772bf4a311c" providerId="ADAL" clId="{8EE40018-26BD-4A7B-8D17-70AC8417C2D0}" dt="2022-11-16T06:54:07.519" v="22" actId="47"/>
-        <pc:sldMkLst>
-          <pc:docMk/>
-          <pc:sldMk cId="913491245" sldId="318"/>
-        </pc:sldMkLst>
-      </pc:sldChg>
-      <pc:sldChg chg="del">
-        <pc:chgData name="Matthieu De Mari" userId="dfb708c9-d8dc-439f-9a3b-c772bf4a311c" providerId="ADAL" clId="{8EE40018-26BD-4A7B-8D17-70AC8417C2D0}" dt="2022-11-16T06:54:07.519" v="22" actId="47"/>
-        <pc:sldMkLst>
-          <pc:docMk/>
-          <pc:sldMk cId="369927457" sldId="319"/>
-        </pc:sldMkLst>
-      </pc:sldChg>
-      <pc:sldChg chg="del">
-        <pc:chgData name="Matthieu De Mari" userId="dfb708c9-d8dc-439f-9a3b-c772bf4a311c" providerId="ADAL" clId="{8EE40018-26BD-4A7B-8D17-70AC8417C2D0}" dt="2022-11-16T06:54:07.519" v="22" actId="47"/>
-        <pc:sldMkLst>
-          <pc:docMk/>
-          <pc:sldMk cId="868347224" sldId="320"/>
-        </pc:sldMkLst>
-      </pc:sldChg>
-      <pc:sldChg chg="del">
-        <pc:chgData name="Matthieu De Mari" userId="dfb708c9-d8dc-439f-9a3b-c772bf4a311c" providerId="ADAL" clId="{8EE40018-26BD-4A7B-8D17-70AC8417C2D0}" dt="2022-11-16T06:54:07.519" v="22" actId="47"/>
-        <pc:sldMkLst>
-          <pc:docMk/>
-          <pc:sldMk cId="2901421326" sldId="321"/>
-        </pc:sldMkLst>
-      </pc:sldChg>
-      <pc:sldChg chg="del">
-        <pc:chgData name="Matthieu De Mari" userId="dfb708c9-d8dc-439f-9a3b-c772bf4a311c" providerId="ADAL" clId="{8EE40018-26BD-4A7B-8D17-70AC8417C2D0}" dt="2022-11-16T06:54:07.519" v="22" actId="47"/>
-        <pc:sldMkLst>
-          <pc:docMk/>
-          <pc:sldMk cId="386318379" sldId="322"/>
-        </pc:sldMkLst>
-      </pc:sldChg>
-      <pc:sldChg chg="del">
-        <pc:chgData name="Matthieu De Mari" userId="dfb708c9-d8dc-439f-9a3b-c772bf4a311c" providerId="ADAL" clId="{8EE40018-26BD-4A7B-8D17-70AC8417C2D0}" dt="2022-11-16T06:54:07.519" v="22" actId="47"/>
-        <pc:sldMkLst>
-          <pc:docMk/>
-          <pc:sldMk cId="535785749" sldId="323"/>
-        </pc:sldMkLst>
-      </pc:sldChg>
-      <pc:sldChg chg="del">
-        <pc:chgData name="Matthieu De Mari" userId="dfb708c9-d8dc-439f-9a3b-c772bf4a311c" providerId="ADAL" clId="{8EE40018-26BD-4A7B-8D17-70AC8417C2D0}" dt="2022-11-16T06:54:07.519" v="22" actId="47"/>
-        <pc:sldMkLst>
-          <pc:docMk/>
-          <pc:sldMk cId="573807039" sldId="324"/>
-        </pc:sldMkLst>
-      </pc:sldChg>
-      <pc:sldChg chg="del">
-        <pc:chgData name="Matthieu De Mari" userId="dfb708c9-d8dc-439f-9a3b-c772bf4a311c" providerId="ADAL" clId="{8EE40018-26BD-4A7B-8D17-70AC8417C2D0}" dt="2022-11-16T06:54:07.519" v="22" actId="47"/>
-        <pc:sldMkLst>
-          <pc:docMk/>
-          <pc:sldMk cId="3026304390" sldId="325"/>
-        </pc:sldMkLst>
-      </pc:sldChg>
-      <pc:sldChg chg="del">
-        <pc:chgData name="Matthieu De Mari" userId="dfb708c9-d8dc-439f-9a3b-c772bf4a311c" providerId="ADAL" clId="{8EE40018-26BD-4A7B-8D17-70AC8417C2D0}" dt="2022-11-16T06:54:07.519" v="22" actId="47"/>
-        <pc:sldMkLst>
-          <pc:docMk/>
-          <pc:sldMk cId="4144845603" sldId="326"/>
-        </pc:sldMkLst>
-      </pc:sldChg>
-      <pc:sldChg chg="del">
-        <pc:chgData name="Matthieu De Mari" userId="dfb708c9-d8dc-439f-9a3b-c772bf4a311c" providerId="ADAL" clId="{8EE40018-26BD-4A7B-8D17-70AC8417C2D0}" dt="2022-11-16T06:54:07.519" v="22" actId="47"/>
-        <pc:sldMkLst>
-          <pc:docMk/>
-          <pc:sldMk cId="2128704617" sldId="328"/>
-        </pc:sldMkLst>
-      </pc:sldChg>
-      <pc:sldChg chg="del">
-        <pc:chgData name="Matthieu De Mari" userId="dfb708c9-d8dc-439f-9a3b-c772bf4a311c" providerId="ADAL" clId="{8EE40018-26BD-4A7B-8D17-70AC8417C2D0}" dt="2022-11-16T06:54:07.519" v="22" actId="47"/>
-        <pc:sldMkLst>
-          <pc:docMk/>
-          <pc:sldMk cId="1228181526" sldId="329"/>
-        </pc:sldMkLst>
-      </pc:sldChg>
-      <pc:sldChg chg="del">
-        <pc:chgData name="Matthieu De Mari" userId="dfb708c9-d8dc-439f-9a3b-c772bf4a311c" providerId="ADAL" clId="{8EE40018-26BD-4A7B-8D17-70AC8417C2D0}" dt="2022-11-16T06:54:07.519" v="22" actId="47"/>
-        <pc:sldMkLst>
-          <pc:docMk/>
-          <pc:sldMk cId="1086607777" sldId="331"/>
-        </pc:sldMkLst>
-      </pc:sldChg>
-      <pc:sldChg chg="del">
-        <pc:chgData name="Matthieu De Mari" userId="dfb708c9-d8dc-439f-9a3b-c772bf4a311c" providerId="ADAL" clId="{8EE40018-26BD-4A7B-8D17-70AC8417C2D0}" dt="2022-11-16T06:54:08.404" v="23" actId="47"/>
-        <pc:sldMkLst>
-          <pc:docMk/>
-          <pc:sldMk cId="3744088925" sldId="332"/>
-        </pc:sldMkLst>
-      </pc:sldChg>
-      <pc:sldChg chg="del">
-        <pc:chgData name="Matthieu De Mari" userId="dfb708c9-d8dc-439f-9a3b-c772bf4a311c" providerId="ADAL" clId="{8EE40018-26BD-4A7B-8D17-70AC8417C2D0}" dt="2022-11-16T06:54:08.404" v="23" actId="47"/>
-        <pc:sldMkLst>
-          <pc:docMk/>
-          <pc:sldMk cId="1824898086" sldId="334"/>
-        </pc:sldMkLst>
-      </pc:sldChg>
-      <pc:sldChg chg="del">
-        <pc:chgData name="Matthieu De Mari" userId="dfb708c9-d8dc-439f-9a3b-c772bf4a311c" providerId="ADAL" clId="{8EE40018-26BD-4A7B-8D17-70AC8417C2D0}" dt="2022-11-16T06:54:13.895" v="27" actId="47"/>
-        <pc:sldMkLst>
-          <pc:docMk/>
-          <pc:sldMk cId="3704706604" sldId="335"/>
-        </pc:sldMkLst>
-      </pc:sldChg>
-      <pc:sldChg chg="del">
-        <pc:chgData name="Matthieu De Mari" userId="dfb708c9-d8dc-439f-9a3b-c772bf4a311c" providerId="ADAL" clId="{8EE40018-26BD-4A7B-8D17-70AC8417C2D0}" dt="2022-11-16T06:54:11.293" v="25" actId="47"/>
-        <pc:sldMkLst>
-          <pc:docMk/>
-          <pc:sldMk cId="503014896" sldId="336"/>
-        </pc:sldMkLst>
-      </pc:sldChg>
-      <pc:sldChg chg="del">
-        <pc:chgData name="Matthieu De Mari" userId="dfb708c9-d8dc-439f-9a3b-c772bf4a311c" providerId="ADAL" clId="{8EE40018-26BD-4A7B-8D17-70AC8417C2D0}" dt="2022-11-16T06:54:11.293" v="25" actId="47"/>
-        <pc:sldMkLst>
-          <pc:docMk/>
-          <pc:sldMk cId="1757180629" sldId="338"/>
-        </pc:sldMkLst>
-      </pc:sldChg>
-      <pc:sldChg chg="del">
-        <pc:chgData name="Matthieu De Mari" userId="dfb708c9-d8dc-439f-9a3b-c772bf4a311c" providerId="ADAL" clId="{8EE40018-26BD-4A7B-8D17-70AC8417C2D0}" dt="2022-11-16T06:54:11.293" v="25" actId="47"/>
-        <pc:sldMkLst>
-          <pc:docMk/>
-          <pc:sldMk cId="3251712844" sldId="339"/>
-        </pc:sldMkLst>
-      </pc:sldChg>
-      <pc:sldChg chg="del">
-        <pc:chgData name="Matthieu De Mari" userId="dfb708c9-d8dc-439f-9a3b-c772bf4a311c" providerId="ADAL" clId="{8EE40018-26BD-4A7B-8D17-70AC8417C2D0}" dt="2022-11-16T06:54:11.293" v="25" actId="47"/>
-        <pc:sldMkLst>
-          <pc:docMk/>
-          <pc:sldMk cId="3000047863" sldId="341"/>
-        </pc:sldMkLst>
-      </pc:sldChg>
-      <pc:sldChg chg="del">
-        <pc:chgData name="Matthieu De Mari" userId="dfb708c9-d8dc-439f-9a3b-c772bf4a311c" providerId="ADAL" clId="{8EE40018-26BD-4A7B-8D17-70AC8417C2D0}" dt="2022-11-16T06:54:11.293" v="25" actId="47"/>
-        <pc:sldMkLst>
-          <pc:docMk/>
-          <pc:sldMk cId="3607475250" sldId="342"/>
-        </pc:sldMkLst>
-      </pc:sldChg>
-      <pc:sldChg chg="del">
-        <pc:chgData name="Matthieu De Mari" userId="dfb708c9-d8dc-439f-9a3b-c772bf4a311c" providerId="ADAL" clId="{8EE40018-26BD-4A7B-8D17-70AC8417C2D0}" dt="2022-11-16T06:54:11.293" v="25" actId="47"/>
-        <pc:sldMkLst>
-          <pc:docMk/>
-          <pc:sldMk cId="2202386436" sldId="343"/>
-        </pc:sldMkLst>
-      </pc:sldChg>
-      <pc:sldChg chg="del">
-        <pc:chgData name="Matthieu De Mari" userId="dfb708c9-d8dc-439f-9a3b-c772bf4a311c" providerId="ADAL" clId="{8EE40018-26BD-4A7B-8D17-70AC8417C2D0}" dt="2022-11-16T06:54:14.637" v="28" actId="47"/>
-        <pc:sldMkLst>
-          <pc:docMk/>
-          <pc:sldMk cId="4222503966" sldId="345"/>
-        </pc:sldMkLst>
-      </pc:sldChg>
-      <pc:sldChg chg="modSp add del mod">
-        <pc:chgData name="Matthieu De Mari" userId="dfb708c9-d8dc-439f-9a3b-c772bf4a311c" providerId="ADAL" clId="{8EE40018-26BD-4A7B-8D17-70AC8417C2D0}" dt="2022-11-16T06:54:26.067" v="39" actId="20577"/>
-        <pc:sldMkLst>
-          <pc:docMk/>
-          <pc:sldMk cId="1036081419" sldId="346"/>
-        </pc:sldMkLst>
-      </pc:sldChg>
-      <pc:sldChg chg="del">
-        <pc:chgData name="Matthieu De Mari" userId="dfb708c9-d8dc-439f-9a3b-c772bf4a311c" providerId="ADAL" clId="{8EE40018-26BD-4A7B-8D17-70AC8417C2D0}" dt="2022-11-16T06:54:11.293" v="25" actId="47"/>
-        <pc:sldMkLst>
-          <pc:docMk/>
-          <pc:sldMk cId="2902606749" sldId="350"/>
-        </pc:sldMkLst>
-      </pc:sldChg>
-      <pc:sldChg chg="del">
-        <pc:chgData name="Matthieu De Mari" userId="dfb708c9-d8dc-439f-9a3b-c772bf4a311c" providerId="ADAL" clId="{8EE40018-26BD-4A7B-8D17-70AC8417C2D0}" dt="2022-11-16T06:54:11.293" v="25" actId="47"/>
-        <pc:sldMkLst>
-          <pc:docMk/>
-          <pc:sldMk cId="1008855396" sldId="352"/>
-        </pc:sldMkLst>
-      </pc:sldChg>
-      <pc:sldChg chg="del">
-        <pc:chgData name="Matthieu De Mari" userId="dfb708c9-d8dc-439f-9a3b-c772bf4a311c" providerId="ADAL" clId="{8EE40018-26BD-4A7B-8D17-70AC8417C2D0}" dt="2022-11-16T06:54:11.293" v="25" actId="47"/>
-        <pc:sldMkLst>
-          <pc:docMk/>
-          <pc:sldMk cId="1005123530" sldId="353"/>
-        </pc:sldMkLst>
-      </pc:sldChg>
-      <pc:sldChg chg="del">
-        <pc:chgData name="Matthieu De Mari" userId="dfb708c9-d8dc-439f-9a3b-c772bf4a311c" providerId="ADAL" clId="{8EE40018-26BD-4A7B-8D17-70AC8417C2D0}" dt="2022-11-16T06:54:11.293" v="25" actId="47"/>
-        <pc:sldMkLst>
-          <pc:docMk/>
-          <pc:sldMk cId="304430080" sldId="354"/>
-        </pc:sldMkLst>
-      </pc:sldChg>
-      <pc:sldChg chg="del">
-        <pc:chgData name="Matthieu De Mari" userId="dfb708c9-d8dc-439f-9a3b-c772bf4a311c" providerId="ADAL" clId="{8EE40018-26BD-4A7B-8D17-70AC8417C2D0}" dt="2022-11-16T06:54:11.293" v="25" actId="47"/>
-        <pc:sldMkLst>
-          <pc:docMk/>
-          <pc:sldMk cId="2530765258" sldId="355"/>
-        </pc:sldMkLst>
-      </pc:sldChg>
-      <pc:sldChg chg="del">
-        <pc:chgData name="Matthieu De Mari" userId="dfb708c9-d8dc-439f-9a3b-c772bf4a311c" providerId="ADAL" clId="{8EE40018-26BD-4A7B-8D17-70AC8417C2D0}" dt="2022-11-16T06:54:11.293" v="25" actId="47"/>
-        <pc:sldMkLst>
-          <pc:docMk/>
-          <pc:sldMk cId="2900566505" sldId="356"/>
-        </pc:sldMkLst>
-      </pc:sldChg>
-      <pc:sldChg chg="del">
-        <pc:chgData name="Matthieu De Mari" userId="dfb708c9-d8dc-439f-9a3b-c772bf4a311c" providerId="ADAL" clId="{8EE40018-26BD-4A7B-8D17-70AC8417C2D0}" dt="2022-11-16T06:54:11.293" v="25" actId="47"/>
-        <pc:sldMkLst>
-          <pc:docMk/>
-          <pc:sldMk cId="151041797" sldId="357"/>
-        </pc:sldMkLst>
-      </pc:sldChg>
-      <pc:sldChg chg="del">
-        <pc:chgData name="Matthieu De Mari" userId="dfb708c9-d8dc-439f-9a3b-c772bf4a311c" providerId="ADAL" clId="{8EE40018-26BD-4A7B-8D17-70AC8417C2D0}" dt="2022-11-16T06:54:11.293" v="25" actId="47"/>
-        <pc:sldMkLst>
-          <pc:docMk/>
-          <pc:sldMk cId="2341017383" sldId="358"/>
-        </pc:sldMkLst>
-      </pc:sldChg>
-      <pc:sldChg chg="del">
-        <pc:chgData name="Matthieu De Mari" userId="dfb708c9-d8dc-439f-9a3b-c772bf4a311c" providerId="ADAL" clId="{8EE40018-26BD-4A7B-8D17-70AC8417C2D0}" dt="2022-11-16T06:54:12.971" v="26" actId="47"/>
-        <pc:sldMkLst>
-          <pc:docMk/>
-          <pc:sldMk cId="843036564" sldId="360"/>
-        </pc:sldMkLst>
-      </pc:sldChg>
-      <pc:sldChg chg="del">
-        <pc:chgData name="Matthieu De Mari" userId="dfb708c9-d8dc-439f-9a3b-c772bf4a311c" providerId="ADAL" clId="{8EE40018-26BD-4A7B-8D17-70AC8417C2D0}" dt="2022-11-16T06:54:12.971" v="26" actId="47"/>
-        <pc:sldMkLst>
-          <pc:docMk/>
-          <pc:sldMk cId="1543635220" sldId="363"/>
-        </pc:sldMkLst>
-      </pc:sldChg>
-      <pc:sldChg chg="del">
-        <pc:chgData name="Matthieu De Mari" userId="dfb708c9-d8dc-439f-9a3b-c772bf4a311c" providerId="ADAL" clId="{8EE40018-26BD-4A7B-8D17-70AC8417C2D0}" dt="2022-11-16T06:54:12.971" v="26" actId="47"/>
-        <pc:sldMkLst>
-          <pc:docMk/>
-          <pc:sldMk cId="467323081" sldId="364"/>
-        </pc:sldMkLst>
-      </pc:sldChg>
-      <pc:sldChg chg="del">
-        <pc:chgData name="Matthieu De Mari" userId="dfb708c9-d8dc-439f-9a3b-c772bf4a311c" providerId="ADAL" clId="{8EE40018-26BD-4A7B-8D17-70AC8417C2D0}" dt="2022-11-16T06:54:12.971" v="26" actId="47"/>
-        <pc:sldMkLst>
-          <pc:docMk/>
-          <pc:sldMk cId="2557491043" sldId="365"/>
-        </pc:sldMkLst>
-      </pc:sldChg>
-      <pc:sldChg chg="del">
-        <pc:chgData name="Matthieu De Mari" userId="dfb708c9-d8dc-439f-9a3b-c772bf4a311c" providerId="ADAL" clId="{8EE40018-26BD-4A7B-8D17-70AC8417C2D0}" dt="2022-11-16T06:54:12.971" v="26" actId="47"/>
-        <pc:sldMkLst>
-          <pc:docMk/>
-          <pc:sldMk cId="30137941" sldId="366"/>
-        </pc:sldMkLst>
-      </pc:sldChg>
-      <pc:sldChg chg="del">
-        <pc:chgData name="Matthieu De Mari" userId="dfb708c9-d8dc-439f-9a3b-c772bf4a311c" providerId="ADAL" clId="{8EE40018-26BD-4A7B-8D17-70AC8417C2D0}" dt="2022-11-16T06:54:12.971" v="26" actId="47"/>
-        <pc:sldMkLst>
-          <pc:docMk/>
-          <pc:sldMk cId="2759705435" sldId="367"/>
-        </pc:sldMkLst>
-      </pc:sldChg>
-      <pc:sldChg chg="del">
-        <pc:chgData name="Matthieu De Mari" userId="dfb708c9-d8dc-439f-9a3b-c772bf4a311c" providerId="ADAL" clId="{8EE40018-26BD-4A7B-8D17-70AC8417C2D0}" dt="2022-11-16T06:54:12.971" v="26" actId="47"/>
-        <pc:sldMkLst>
-          <pc:docMk/>
-          <pc:sldMk cId="3578341878" sldId="368"/>
-        </pc:sldMkLst>
-      </pc:sldChg>
-      <pc:sldChg chg="del">
-        <pc:chgData name="Matthieu De Mari" userId="dfb708c9-d8dc-439f-9a3b-c772bf4a311c" providerId="ADAL" clId="{8EE40018-26BD-4A7B-8D17-70AC8417C2D0}" dt="2022-11-16T06:54:12.971" v="26" actId="47"/>
-        <pc:sldMkLst>
-          <pc:docMk/>
-          <pc:sldMk cId="2979488587" sldId="369"/>
-        </pc:sldMkLst>
-      </pc:sldChg>
-      <pc:sldChg chg="del">
-        <pc:chgData name="Matthieu De Mari" userId="dfb708c9-d8dc-439f-9a3b-c772bf4a311c" providerId="ADAL" clId="{8EE40018-26BD-4A7B-8D17-70AC8417C2D0}" dt="2022-11-16T06:54:12.971" v="26" actId="47"/>
-        <pc:sldMkLst>
-          <pc:docMk/>
-          <pc:sldMk cId="954723006" sldId="371"/>
-        </pc:sldMkLst>
-      </pc:sldChg>
-      <pc:sldChg chg="del">
-        <pc:chgData name="Matthieu De Mari" userId="dfb708c9-d8dc-439f-9a3b-c772bf4a311c" providerId="ADAL" clId="{8EE40018-26BD-4A7B-8D17-70AC8417C2D0}" dt="2022-11-16T06:54:12.971" v="26" actId="47"/>
-        <pc:sldMkLst>
-          <pc:docMk/>
-          <pc:sldMk cId="1007393074" sldId="372"/>
-        </pc:sldMkLst>
-      </pc:sldChg>
-      <pc:sldChg chg="del">
-        <pc:chgData name="Matthieu De Mari" userId="dfb708c9-d8dc-439f-9a3b-c772bf4a311c" providerId="ADAL" clId="{8EE40018-26BD-4A7B-8D17-70AC8417C2D0}" dt="2022-11-16T06:54:12.971" v="26" actId="47"/>
-        <pc:sldMkLst>
-          <pc:docMk/>
-          <pc:sldMk cId="4039951211" sldId="373"/>
-        </pc:sldMkLst>
-      </pc:sldChg>
-      <pc:sldChg chg="del">
-        <pc:chgData name="Matthieu De Mari" userId="dfb708c9-d8dc-439f-9a3b-c772bf4a311c" providerId="ADAL" clId="{8EE40018-26BD-4A7B-8D17-70AC8417C2D0}" dt="2022-11-16T06:54:12.971" v="26" actId="47"/>
-        <pc:sldMkLst>
-          <pc:docMk/>
-          <pc:sldMk cId="3074715825" sldId="374"/>
-        </pc:sldMkLst>
-      </pc:sldChg>
-      <pc:sldChg chg="del">
-        <pc:chgData name="Matthieu De Mari" userId="dfb708c9-d8dc-439f-9a3b-c772bf4a311c" providerId="ADAL" clId="{8EE40018-26BD-4A7B-8D17-70AC8417C2D0}" dt="2022-11-16T06:54:13.895" v="27" actId="47"/>
-        <pc:sldMkLst>
-          <pc:docMk/>
-          <pc:sldMk cId="1113800729" sldId="376"/>
-        </pc:sldMkLst>
-      </pc:sldChg>
-      <pc:sldChg chg="modSp mod">
-        <pc:chgData name="Matthieu De Mari" userId="dfb708c9-d8dc-439f-9a3b-c772bf4a311c" providerId="ADAL" clId="{8EE40018-26BD-4A7B-8D17-70AC8417C2D0}" dt="2022-11-16T06:53:49.572" v="12" actId="20577"/>
-        <pc:sldMkLst>
-          <pc:docMk/>
-          <pc:sldMk cId="1040156172" sldId="377"/>
-        </pc:sldMkLst>
-      </pc:sldChg>
-      <pc:sldChg chg="del">
-        <pc:chgData name="Matthieu De Mari" userId="dfb708c9-d8dc-439f-9a3b-c772bf4a311c" providerId="ADAL" clId="{8EE40018-26BD-4A7B-8D17-70AC8417C2D0}" dt="2022-11-16T06:54:08.404" v="23" actId="47"/>
-        <pc:sldMkLst>
-          <pc:docMk/>
-          <pc:sldMk cId="2236780210" sldId="378"/>
-        </pc:sldMkLst>
-      </pc:sldChg>
-      <pc:sldChg chg="del">
-        <pc:chgData name="Matthieu De Mari" userId="dfb708c9-d8dc-439f-9a3b-c772bf4a311c" providerId="ADAL" clId="{8EE40018-26BD-4A7B-8D17-70AC8417C2D0}" dt="2022-11-16T06:54:09.190" v="24" actId="47"/>
-        <pc:sldMkLst>
-          <pc:docMk/>
-          <pc:sldMk cId="3686470996" sldId="379"/>
-        </pc:sldMkLst>
-      </pc:sldChg>
-      <pc:sldChg chg="del">
-        <pc:chgData name="Matthieu De Mari" userId="dfb708c9-d8dc-439f-9a3b-c772bf4a311c" providerId="ADAL" clId="{8EE40018-26BD-4A7B-8D17-70AC8417C2D0}" dt="2022-11-16T06:54:13.895" v="27" actId="47"/>
-        <pc:sldMkLst>
-          <pc:docMk/>
-          <pc:sldMk cId="2665897880" sldId="380"/>
-        </pc:sldMkLst>
-      </pc:sldChg>
-      <pc:sldChg chg="del">
-        <pc:chgData name="Matthieu De Mari" userId="dfb708c9-d8dc-439f-9a3b-c772bf4a311c" providerId="ADAL" clId="{8EE40018-26BD-4A7B-8D17-70AC8417C2D0}" dt="2022-11-16T06:54:42.327" v="41" actId="47"/>
-        <pc:sldMkLst>
-          <pc:docMk/>
-          <pc:sldMk cId="1174542860" sldId="381"/>
-        </pc:sldMkLst>
-      </pc:sldChg>
-      <pc:sldChg chg="del">
-        <pc:chgData name="Matthieu De Mari" userId="dfb708c9-d8dc-439f-9a3b-c772bf4a311c" providerId="ADAL" clId="{8EE40018-26BD-4A7B-8D17-70AC8417C2D0}" dt="2022-11-16T06:54:07.519" v="22" actId="47"/>
-        <pc:sldMkLst>
-          <pc:docMk/>
-          <pc:sldMk cId="370210852" sldId="382"/>
-        </pc:sldMkLst>
-      </pc:sldChg>
-      <pc:sldChg chg="del">
-        <pc:chgData name="Matthieu De Mari" userId="dfb708c9-d8dc-439f-9a3b-c772bf4a311c" providerId="ADAL" clId="{8EE40018-26BD-4A7B-8D17-70AC8417C2D0}" dt="2022-11-16T06:54:06.554" v="21" actId="47"/>
-        <pc:sldMkLst>
-          <pc:docMk/>
-          <pc:sldMk cId="3654187078" sldId="383"/>
-        </pc:sldMkLst>
-      </pc:sldChg>
-      <pc:sldChg chg="del">
-        <pc:chgData name="Matthieu De Mari" userId="dfb708c9-d8dc-439f-9a3b-c772bf4a311c" providerId="ADAL" clId="{8EE40018-26BD-4A7B-8D17-70AC8417C2D0}" dt="2022-11-16T06:54:11.293" v="25" actId="47"/>
-        <pc:sldMkLst>
-          <pc:docMk/>
-          <pc:sldMk cId="1145882535" sldId="384"/>
-        </pc:sldMkLst>
-      </pc:sldChg>
-      <pc:sldChg chg="del">
-        <pc:chgData name="Matthieu De Mari" userId="dfb708c9-d8dc-439f-9a3b-c772bf4a311c" providerId="ADAL" clId="{8EE40018-26BD-4A7B-8D17-70AC8417C2D0}" dt="2022-11-16T06:54:12.971" v="26" actId="47"/>
-        <pc:sldMkLst>
-          <pc:docMk/>
-          <pc:sldMk cId="2609241577" sldId="385"/>
-        </pc:sldMkLst>
-      </pc:sldChg>
-      <pc:sldChg chg="del">
-        <pc:chgData name="Matthieu De Mari" userId="dfb708c9-d8dc-439f-9a3b-c772bf4a311c" providerId="ADAL" clId="{8EE40018-26BD-4A7B-8D17-70AC8417C2D0}" dt="2022-11-16T06:54:13.895" v="27" actId="47"/>
-        <pc:sldMkLst>
-          <pc:docMk/>
-          <pc:sldMk cId="2448415676" sldId="387"/>
-        </pc:sldMkLst>
-      </pc:sldChg>
-      <pc:sldChg chg="del">
-        <pc:chgData name="Matthieu De Mari" userId="dfb708c9-d8dc-439f-9a3b-c772bf4a311c" providerId="ADAL" clId="{8EE40018-26BD-4A7B-8D17-70AC8417C2D0}" dt="2022-11-16T06:54:13.895" v="27" actId="47"/>
-        <pc:sldMkLst>
-          <pc:docMk/>
-          <pc:sldMk cId="993695443" sldId="388"/>
-        </pc:sldMkLst>
-      </pc:sldChg>
-      <pc:sldChg chg="del">
-        <pc:chgData name="Matthieu De Mari" userId="dfb708c9-d8dc-439f-9a3b-c772bf4a311c" providerId="ADAL" clId="{8EE40018-26BD-4A7B-8D17-70AC8417C2D0}" dt="2022-11-16T06:54:13.895" v="27" actId="47"/>
-        <pc:sldMkLst>
-          <pc:docMk/>
-          <pc:sldMk cId="3051477034" sldId="389"/>
-        </pc:sldMkLst>
-      </pc:sldChg>
-      <pc:sldChg chg="del">
-        <pc:chgData name="Matthieu De Mari" userId="dfb708c9-d8dc-439f-9a3b-c772bf4a311c" providerId="ADAL" clId="{8EE40018-26BD-4A7B-8D17-70AC8417C2D0}" dt="2022-11-16T06:54:13.895" v="27" actId="47"/>
-        <pc:sldMkLst>
-          <pc:docMk/>
-          <pc:sldMk cId="2663658166" sldId="390"/>
-        </pc:sldMkLst>
-      </pc:sldChg>
-      <pc:sldChg chg="del">
-        <pc:chgData name="Matthieu De Mari" userId="dfb708c9-d8dc-439f-9a3b-c772bf4a311c" providerId="ADAL" clId="{8EE40018-26BD-4A7B-8D17-70AC8417C2D0}" dt="2022-11-16T06:54:39.791" v="40" actId="47"/>
-        <pc:sldMkLst>
-          <pc:docMk/>
-          <pc:sldMk cId="1682911312" sldId="391"/>
-        </pc:sldMkLst>
-      </pc:sldChg>
-    </pc:docChg>
-  </pc:docChgLst>
-  <pc:docChgLst>
-    <pc:chgData name="Matthieu De Mari" userId="dfb708c9-d8dc-439f-9a3b-c772bf4a311c" providerId="ADAL" clId="{1002CE28-12E1-453F-8E06-90F32FAF9697}"/>
-    <pc:docChg chg="mod delSld modSld sldOrd modMainMaster delSection modSection">
-      <pc:chgData name="Matthieu De Mari" userId="dfb708c9-d8dc-439f-9a3b-c772bf4a311c" providerId="ADAL" clId="{1002CE28-12E1-453F-8E06-90F32FAF9697}" dt="2022-10-19T06:32:13.307" v="17" actId="20577"/>
-      <pc:docMkLst>
-        <pc:docMk/>
-      </pc:docMkLst>
-      <pc:sldChg chg="modSp del mod">
-        <pc:chgData name="Matthieu De Mari" userId="dfb708c9-d8dc-439f-9a3b-c772bf4a311c" providerId="ADAL" clId="{1002CE28-12E1-453F-8E06-90F32FAF9697}" dt="2022-10-19T06:32:10.067" v="8" actId="47"/>
-        <pc:sldMkLst>
-          <pc:docMk/>
-          <pc:sldMk cId="4221035150" sldId="256"/>
-        </pc:sldMkLst>
-      </pc:sldChg>
-      <pc:sldChg chg="del">
-        <pc:chgData name="Matthieu De Mari" userId="dfb708c9-d8dc-439f-9a3b-c772bf4a311c" providerId="ADAL" clId="{1002CE28-12E1-453F-8E06-90F32FAF9697}" dt="2022-10-19T06:32:06.571" v="5" actId="47"/>
-        <pc:sldMkLst>
-          <pc:docMk/>
-          <pc:sldMk cId="2169851104" sldId="258"/>
-        </pc:sldMkLst>
-      </pc:sldChg>
-      <pc:sldChg chg="del">
-        <pc:chgData name="Matthieu De Mari" userId="dfb708c9-d8dc-439f-9a3b-c772bf4a311c" providerId="ADAL" clId="{1002CE28-12E1-453F-8E06-90F32FAF9697}" dt="2022-10-19T06:32:06.571" v="5" actId="47"/>
-        <pc:sldMkLst>
-          <pc:docMk/>
-          <pc:sldMk cId="1814682152" sldId="259"/>
-        </pc:sldMkLst>
-      </pc:sldChg>
-      <pc:sldChg chg="del">
-        <pc:chgData name="Matthieu De Mari" userId="dfb708c9-d8dc-439f-9a3b-c772bf4a311c" providerId="ADAL" clId="{1002CE28-12E1-453F-8E06-90F32FAF9697}" dt="2022-10-19T06:32:06.571" v="5" actId="47"/>
-        <pc:sldMkLst>
-          <pc:docMk/>
-          <pc:sldMk cId="753975277" sldId="260"/>
-        </pc:sldMkLst>
-      </pc:sldChg>
-      <pc:sldChg chg="del">
-        <pc:chgData name="Matthieu De Mari" userId="dfb708c9-d8dc-439f-9a3b-c772bf4a311c" providerId="ADAL" clId="{1002CE28-12E1-453F-8E06-90F32FAF9697}" dt="2022-10-19T06:32:06.571" v="5" actId="47"/>
-        <pc:sldMkLst>
-          <pc:docMk/>
-          <pc:sldMk cId="968033501" sldId="268"/>
-        </pc:sldMkLst>
-      </pc:sldChg>
-      <pc:sldChg chg="modSp mod ord">
-        <pc:chgData name="Matthieu De Mari" userId="dfb708c9-d8dc-439f-9a3b-c772bf4a311c" providerId="ADAL" clId="{1002CE28-12E1-453F-8E06-90F32FAF9697}" dt="2022-10-19T06:32:13.307" v="17" actId="20577"/>
-        <pc:sldMkLst>
-          <pc:docMk/>
-          <pc:sldMk cId="1040156172" sldId="377"/>
-        </pc:sldMkLst>
-      </pc:sldChg>
-      <pc:sldMasterChg chg="addSp mod">
-        <pc:chgData name="Matthieu De Mari" userId="dfb708c9-d8dc-439f-9a3b-c772bf4a311c" providerId="ADAL" clId="{1002CE28-12E1-453F-8E06-90F32FAF9697}" dt="2022-10-19T06:30:58.618" v="0" actId="33475"/>
-        <pc:sldMasterMkLst>
-          <pc:docMk/>
-          <pc:sldMasterMk cId="2168708284" sldId="2147483648"/>
-        </pc:sldMasterMkLst>
-      </pc:sldMasterChg>
-    </pc:docChg>
-  </pc:docChgLst>
-  <pc:docChgLst>
-    <pc:chgData name="Matthieu De Mari" userId="dfb708c9-d8dc-439f-9a3b-c772bf4a311c" providerId="ADAL" clId="{9130EED9-EBEA-4A94-A045-33A4BBD98118}"/>
-    <pc:docChg chg="modSld">
-      <pc:chgData name="Matthieu De Mari" userId="dfb708c9-d8dc-439f-9a3b-c772bf4a311c" providerId="ADAL" clId="{9130EED9-EBEA-4A94-A045-33A4BBD98118}" dt="2024-12-16T01:30:16.444" v="5" actId="14100"/>
-      <pc:docMkLst>
-        <pc:docMk/>
-      </pc:docMkLst>
-      <pc:sldChg chg="modSp mod">
-        <pc:chgData name="Matthieu De Mari" userId="dfb708c9-d8dc-439f-9a3b-c772bf4a311c" providerId="ADAL" clId="{9130EED9-EBEA-4A94-A045-33A4BBD98118}" dt="2024-12-16T01:30:16.444" v="5" actId="14100"/>
-        <pc:sldMkLst>
-          <pc:docMk/>
-          <pc:sldMk cId="2710721176" sldId="651"/>
-        </pc:sldMkLst>
         <pc:spChg chg="mod">
-          <ac:chgData name="Matthieu De Mari" userId="dfb708c9-d8dc-439f-9a3b-c772bf4a311c" providerId="ADAL" clId="{9130EED9-EBEA-4A94-A045-33A4BBD98118}" dt="2024-12-16T01:30:16.444" v="5" actId="14100"/>
+          <ac:chgData name="Matthieu De Mari" userId="dfb708c9-d8dc-439f-9a3b-c772bf4a311c" providerId="ADAL" clId="{81E9B007-0C2C-493E-9B93-55A62C9C1F12}" dt="2025-12-18T22:19:40.157" v="1" actId="207"/>
           <ac:spMkLst>
             <pc:docMk/>
-            <pc:sldMk cId="2710721176" sldId="651"/>
-            <ac:spMk id="3" creationId="{B616E96C-A3A7-C270-6E1D-F90C9FE6BDDB}"/>
+            <pc:sldMk cId="1146881653" sldId="649"/>
+            <ac:spMk id="3" creationId="{DC9D8363-826B-D189-78FB-CCD945BC5477}"/>
           </ac:spMkLst>
         </pc:spChg>
       </pc:sldChg>
-    </pc:docChg>
-  </pc:docChgLst>
-  <pc:docChgLst>
-    <pc:chgData name="Matthieu De Mari" userId="dfb708c9-d8dc-439f-9a3b-c772bf4a311c" providerId="ADAL" clId="{44ABFB41-BEA6-4DBA-BBB4-11FE1C0F0B9A}"/>
-    <pc:docChg chg="custSel addSld delSld modSld sldOrd delSection modSection">
-      <pc:chgData name="Matthieu De Mari" userId="dfb708c9-d8dc-439f-9a3b-c772bf4a311c" providerId="ADAL" clId="{44ABFB41-BEA6-4DBA-BBB4-11FE1C0F0B9A}" dt="2023-07-06T02:56:04.856" v="671" actId="20577"/>
-      <pc:docMkLst>
-        <pc:docMk/>
-      </pc:docMkLst>
-      <pc:sldChg chg="delSp modSp mod modClrScheme chgLayout">
-        <pc:chgData name="Matthieu De Mari" userId="dfb708c9-d8dc-439f-9a3b-c772bf4a311c" providerId="ADAL" clId="{44ABFB41-BEA6-4DBA-BBB4-11FE1C0F0B9A}" dt="2023-06-16T07:10:47.411" v="15" actId="14100"/>
-        <pc:sldMkLst>
-          <pc:docMk/>
-          <pc:sldMk cId="380766058" sldId="378"/>
-        </pc:sldMkLst>
-      </pc:sldChg>
       <pc:sldChg chg="modSp mod">
-        <pc:chgData name="Matthieu De Mari" userId="dfb708c9-d8dc-439f-9a3b-c772bf4a311c" providerId="ADAL" clId="{44ABFB41-BEA6-4DBA-BBB4-11FE1C0F0B9A}" dt="2023-06-22T04:21:57.417" v="55" actId="113"/>
-        <pc:sldMkLst>
-          <pc:docMk/>
-          <pc:sldMk cId="3251402422" sldId="381"/>
-        </pc:sldMkLst>
-      </pc:sldChg>
-      <pc:sldChg chg="modSp mod">
-        <pc:chgData name="Matthieu De Mari" userId="dfb708c9-d8dc-439f-9a3b-c772bf4a311c" providerId="ADAL" clId="{44ABFB41-BEA6-4DBA-BBB4-11FE1C0F0B9A}" dt="2023-07-06T02:53:13.881" v="653" actId="113"/>
-        <pc:sldMkLst>
-          <pc:docMk/>
-          <pc:sldMk cId="1921397945" sldId="383"/>
-        </pc:sldMkLst>
-      </pc:sldChg>
-      <pc:sldChg chg="modSp mod">
-        <pc:chgData name="Matthieu De Mari" userId="dfb708c9-d8dc-439f-9a3b-c772bf4a311c" providerId="ADAL" clId="{44ABFB41-BEA6-4DBA-BBB4-11FE1C0F0B9A}" dt="2023-06-22T04:23:23.153" v="83" actId="20577"/>
-        <pc:sldMkLst>
-          <pc:docMk/>
-          <pc:sldMk cId="1420298135" sldId="384"/>
-        </pc:sldMkLst>
-      </pc:sldChg>
-      <pc:sldChg chg="modSp mod">
-        <pc:chgData name="Matthieu De Mari" userId="dfb708c9-d8dc-439f-9a3b-c772bf4a311c" providerId="ADAL" clId="{44ABFB41-BEA6-4DBA-BBB4-11FE1C0F0B9A}" dt="2023-06-22T04:23:28.994" v="84" actId="5793"/>
-        <pc:sldMkLst>
-          <pc:docMk/>
-          <pc:sldMk cId="2560511070" sldId="385"/>
-        </pc:sldMkLst>
-      </pc:sldChg>
-      <pc:sldChg chg="modSp mod">
-        <pc:chgData name="Matthieu De Mari" userId="dfb708c9-d8dc-439f-9a3b-c772bf4a311c" providerId="ADAL" clId="{44ABFB41-BEA6-4DBA-BBB4-11FE1C0F0B9A}" dt="2023-06-22T04:24:52.798" v="132" actId="1076"/>
-        <pc:sldMkLst>
-          <pc:docMk/>
-          <pc:sldMk cId="1116470923" sldId="386"/>
-        </pc:sldMkLst>
-      </pc:sldChg>
-      <pc:sldChg chg="modSp mod ord">
-        <pc:chgData name="Matthieu De Mari" userId="dfb708c9-d8dc-439f-9a3b-c772bf4a311c" providerId="ADAL" clId="{44ABFB41-BEA6-4DBA-BBB4-11FE1C0F0B9A}" dt="2023-06-22T05:13:32.876" v="585" actId="20577"/>
-        <pc:sldMkLst>
-          <pc:docMk/>
-          <pc:sldMk cId="3140288791" sldId="404"/>
-        </pc:sldMkLst>
-      </pc:sldChg>
-      <pc:sldChg chg="modSp mod">
-        <pc:chgData name="Matthieu De Mari" userId="dfb708c9-d8dc-439f-9a3b-c772bf4a311c" providerId="ADAL" clId="{44ABFB41-BEA6-4DBA-BBB4-11FE1C0F0B9A}" dt="2023-06-16T07:11:42.352" v="44" actId="20577"/>
-        <pc:sldMkLst>
-          <pc:docMk/>
-          <pc:sldMk cId="1178350440" sldId="410"/>
-        </pc:sldMkLst>
-      </pc:sldChg>
-      <pc:sldChg chg="modSp mod">
-        <pc:chgData name="Matthieu De Mari" userId="dfb708c9-d8dc-439f-9a3b-c772bf4a311c" providerId="ADAL" clId="{44ABFB41-BEA6-4DBA-BBB4-11FE1C0F0B9A}" dt="2023-06-16T07:11:40.732" v="43" actId="20577"/>
-        <pc:sldMkLst>
-          <pc:docMk/>
-          <pc:sldMk cId="2149409242" sldId="411"/>
-        </pc:sldMkLst>
-      </pc:sldChg>
-      <pc:sldChg chg="modSp mod">
-        <pc:chgData name="Matthieu De Mari" userId="dfb708c9-d8dc-439f-9a3b-c772bf4a311c" providerId="ADAL" clId="{44ABFB41-BEA6-4DBA-BBB4-11FE1C0F0B9A}" dt="2023-07-06T02:51:45.547" v="600" actId="20577"/>
-        <pc:sldMkLst>
-          <pc:docMk/>
-          <pc:sldMk cId="4145254973" sldId="423"/>
-        </pc:sldMkLst>
-      </pc:sldChg>
-      <pc:sldChg chg="modSp mod">
-        <pc:chgData name="Matthieu De Mari" userId="dfb708c9-d8dc-439f-9a3b-c772bf4a311c" providerId="ADAL" clId="{44ABFB41-BEA6-4DBA-BBB4-11FE1C0F0B9A}" dt="2023-07-06T02:51:27.282" v="592" actId="20577"/>
-        <pc:sldMkLst>
-          <pc:docMk/>
-          <pc:sldMk cId="1513778887" sldId="424"/>
-        </pc:sldMkLst>
-      </pc:sldChg>
-      <pc:sldChg chg="modSp mod">
-        <pc:chgData name="Matthieu De Mari" userId="dfb708c9-d8dc-439f-9a3b-c772bf4a311c" providerId="ADAL" clId="{44ABFB41-BEA6-4DBA-BBB4-11FE1C0F0B9A}" dt="2023-07-06T02:51:39.838" v="596" actId="20577"/>
-        <pc:sldMkLst>
-          <pc:docMk/>
-          <pc:sldMk cId="548772636" sldId="425"/>
-        </pc:sldMkLst>
-      </pc:sldChg>
-      <pc:sldChg chg="modSp mod">
-        <pc:chgData name="Matthieu De Mari" userId="dfb708c9-d8dc-439f-9a3b-c772bf4a311c" providerId="ADAL" clId="{44ABFB41-BEA6-4DBA-BBB4-11FE1C0F0B9A}" dt="2023-07-06T02:52:04.084" v="618" actId="20577"/>
-        <pc:sldMkLst>
-          <pc:docMk/>
-          <pc:sldMk cId="995336806" sldId="426"/>
-        </pc:sldMkLst>
-      </pc:sldChg>
-      <pc:sldChg chg="del">
-        <pc:chgData name="Matthieu De Mari" userId="dfb708c9-d8dc-439f-9a3b-c772bf4a311c" providerId="ADAL" clId="{44ABFB41-BEA6-4DBA-BBB4-11FE1C0F0B9A}" dt="2023-06-16T07:10:04.549" v="0" actId="47"/>
-        <pc:sldMkLst>
-          <pc:docMk/>
-          <pc:sldMk cId="1567954153" sldId="608"/>
-        </pc:sldMkLst>
-      </pc:sldChg>
-      <pc:sldChg chg="modSp mod">
-        <pc:chgData name="Matthieu De Mari" userId="dfb708c9-d8dc-439f-9a3b-c772bf4a311c" providerId="ADAL" clId="{44ABFB41-BEA6-4DBA-BBB4-11FE1C0F0B9A}" dt="2023-06-22T04:23:11.719" v="81" actId="20577"/>
-        <pc:sldMkLst>
-          <pc:docMk/>
-          <pc:sldMk cId="1146881653" sldId="649"/>
-        </pc:sldMkLst>
-      </pc:sldChg>
-      <pc:sldChg chg="modSp mod">
-        <pc:chgData name="Matthieu De Mari" userId="dfb708c9-d8dc-439f-9a3b-c772bf4a311c" providerId="ADAL" clId="{44ABFB41-BEA6-4DBA-BBB4-11FE1C0F0B9A}" dt="2023-06-22T04:23:47.334" v="92" actId="120"/>
-        <pc:sldMkLst>
-          <pc:docMk/>
-          <pc:sldMk cId="2710721176" sldId="651"/>
-        </pc:sldMkLst>
-      </pc:sldChg>
-      <pc:sldChg chg="del">
-        <pc:chgData name="Matthieu De Mari" userId="dfb708c9-d8dc-439f-9a3b-c772bf4a311c" providerId="ADAL" clId="{44ABFB41-BEA6-4DBA-BBB4-11FE1C0F0B9A}" dt="2023-06-16T07:10:04.549" v="0" actId="47"/>
-        <pc:sldMkLst>
-          <pc:docMk/>
-          <pc:sldMk cId="2525469962" sldId="757"/>
-        </pc:sldMkLst>
-      </pc:sldChg>
-      <pc:sldChg chg="del">
-        <pc:chgData name="Matthieu De Mari" userId="dfb708c9-d8dc-439f-9a3b-c772bf4a311c" providerId="ADAL" clId="{44ABFB41-BEA6-4DBA-BBB4-11FE1C0F0B9A}" dt="2023-06-16T07:10:04.549" v="0" actId="47"/>
-        <pc:sldMkLst>
-          <pc:docMk/>
-          <pc:sldMk cId="571242276" sldId="758"/>
-        </pc:sldMkLst>
-      </pc:sldChg>
-      <pc:sldChg chg="del">
-        <pc:chgData name="Matthieu De Mari" userId="dfb708c9-d8dc-439f-9a3b-c772bf4a311c" providerId="ADAL" clId="{44ABFB41-BEA6-4DBA-BBB4-11FE1C0F0B9A}" dt="2023-06-16T07:10:04.549" v="0" actId="47"/>
-        <pc:sldMkLst>
-          <pc:docMk/>
-          <pc:sldMk cId="1598131875" sldId="759"/>
-        </pc:sldMkLst>
-      </pc:sldChg>
-      <pc:sldChg chg="delSp modSp add mod modClrScheme chgLayout">
-        <pc:chgData name="Matthieu De Mari" userId="dfb708c9-d8dc-439f-9a3b-c772bf4a311c" providerId="ADAL" clId="{44ABFB41-BEA6-4DBA-BBB4-11FE1C0F0B9A}" dt="2023-06-16T07:11:14.835" v="42" actId="20577"/>
-        <pc:sldMkLst>
-          <pc:docMk/>
-          <pc:sldMk cId="557429466" sldId="785"/>
-        </pc:sldMkLst>
-      </pc:sldChg>
-      <pc:sldChg chg="modSp add mod">
-        <pc:chgData name="Matthieu De Mari" userId="dfb708c9-d8dc-439f-9a3b-c772bf4a311c" providerId="ADAL" clId="{44ABFB41-BEA6-4DBA-BBB4-11FE1C0F0B9A}" dt="2023-07-06T02:56:04.856" v="671" actId="20577"/>
-        <pc:sldMkLst>
-          <pc:docMk/>
-          <pc:sldMk cId="2509505199" sldId="786"/>
-        </pc:sldMkLst>
-      </pc:sldChg>
-    </pc:docChg>
-  </pc:docChgLst>
-  <pc:docChgLst>
-    <pc:chgData name="Matthieu De Mari" userId="dfb708c9-d8dc-439f-9a3b-c772bf4a311c" providerId="ADAL" clId="{247D1BAE-CADF-480A-BB5E-27902C69550B}"/>
-    <pc:docChg chg="undo custSel modSld">
-      <pc:chgData name="Matthieu De Mari" userId="dfb708c9-d8dc-439f-9a3b-c772bf4a311c" providerId="ADAL" clId="{247D1BAE-CADF-480A-BB5E-27902C69550B}" dt="2024-02-05T00:16:00.404" v="274" actId="20577"/>
-      <pc:docMkLst>
-        <pc:docMk/>
-      </pc:docMkLst>
-      <pc:sldChg chg="modSp mod">
-        <pc:chgData name="Matthieu De Mari" userId="dfb708c9-d8dc-439f-9a3b-c772bf4a311c" providerId="ADAL" clId="{247D1BAE-CADF-480A-BB5E-27902C69550B}" dt="2024-01-21T10:00:56.720" v="4" actId="20577"/>
-        <pc:sldMkLst>
-          <pc:docMk/>
-          <pc:sldMk cId="1970187575" sldId="379"/>
-        </pc:sldMkLst>
-      </pc:sldChg>
-      <pc:sldChg chg="addSp delSp modSp mod">
-        <pc:chgData name="Matthieu De Mari" userId="dfb708c9-d8dc-439f-9a3b-c772bf4a311c" providerId="ADAL" clId="{247D1BAE-CADF-480A-BB5E-27902C69550B}" dt="2024-01-21T10:04:29.079" v="174" actId="20577"/>
-        <pc:sldMkLst>
-          <pc:docMk/>
-          <pc:sldMk cId="2100436947" sldId="380"/>
-        </pc:sldMkLst>
-      </pc:sldChg>
-      <pc:sldChg chg="modSp mod">
-        <pc:chgData name="Matthieu De Mari" userId="dfb708c9-d8dc-439f-9a3b-c772bf4a311c" providerId="ADAL" clId="{247D1BAE-CADF-480A-BB5E-27902C69550B}" dt="2024-02-02T09:05:10.759" v="225" actId="20577"/>
-        <pc:sldMkLst>
-          <pc:docMk/>
-          <pc:sldMk cId="1420298135" sldId="384"/>
-        </pc:sldMkLst>
-      </pc:sldChg>
-      <pc:sldChg chg="modSp mod">
-        <pc:chgData name="Matthieu De Mari" userId="dfb708c9-d8dc-439f-9a3b-c772bf4a311c" providerId="ADAL" clId="{247D1BAE-CADF-480A-BB5E-27902C69550B}" dt="2024-02-02T09:06:20.966" v="230" actId="5793"/>
-        <pc:sldMkLst>
-          <pc:docMk/>
-          <pc:sldMk cId="1116470923" sldId="386"/>
-        </pc:sldMkLst>
-      </pc:sldChg>
-      <pc:sldChg chg="modSp mod">
-        <pc:chgData name="Matthieu De Mari" userId="dfb708c9-d8dc-439f-9a3b-c772bf4a311c" providerId="ADAL" clId="{247D1BAE-CADF-480A-BB5E-27902C69550B}" dt="2024-02-05T00:12:40.043" v="234" actId="20577"/>
-        <pc:sldMkLst>
-          <pc:docMk/>
-          <pc:sldMk cId="3358927626" sldId="406"/>
-        </pc:sldMkLst>
-      </pc:sldChg>
-      <pc:sldChg chg="modSp mod">
-        <pc:chgData name="Matthieu De Mari" userId="dfb708c9-d8dc-439f-9a3b-c772bf4a311c" providerId="ADAL" clId="{247D1BAE-CADF-480A-BB5E-27902C69550B}" dt="2024-01-21T10:01:54.988" v="85" actId="5793"/>
-        <pc:sldMkLst>
-          <pc:docMk/>
-          <pc:sldMk cId="3179138343" sldId="413"/>
-        </pc:sldMkLst>
-      </pc:sldChg>
-      <pc:sldChg chg="modSp mod">
-        <pc:chgData name="Matthieu De Mari" userId="dfb708c9-d8dc-439f-9a3b-c772bf4a311c" providerId="ADAL" clId="{247D1BAE-CADF-480A-BB5E-27902C69550B}" dt="2024-01-21T10:02:29.240" v="96"/>
-        <pc:sldMkLst>
-          <pc:docMk/>
-          <pc:sldMk cId="1324969895" sldId="414"/>
-        </pc:sldMkLst>
-      </pc:sldChg>
-      <pc:sldChg chg="modSp mod">
-        <pc:chgData name="Matthieu De Mari" userId="dfb708c9-d8dc-439f-9a3b-c772bf4a311c" providerId="ADAL" clId="{247D1BAE-CADF-480A-BB5E-27902C69550B}" dt="2024-01-21T10:02:25.292" v="95" actId="20577"/>
-        <pc:sldMkLst>
-          <pc:docMk/>
-          <pc:sldMk cId="481166971" sldId="415"/>
-        </pc:sldMkLst>
-      </pc:sldChg>
-      <pc:sldChg chg="modSp mod">
-        <pc:chgData name="Matthieu De Mari" userId="dfb708c9-d8dc-439f-9a3b-c772bf4a311c" providerId="ADAL" clId="{247D1BAE-CADF-480A-BB5E-27902C69550B}" dt="2024-01-21T10:02:33.099" v="97"/>
-        <pc:sldMkLst>
-          <pc:docMk/>
-          <pc:sldMk cId="4050702309" sldId="416"/>
-        </pc:sldMkLst>
-      </pc:sldChg>
-      <pc:sldChg chg="modSp mod">
-        <pc:chgData name="Matthieu De Mari" userId="dfb708c9-d8dc-439f-9a3b-c772bf4a311c" providerId="ADAL" clId="{247D1BAE-CADF-480A-BB5E-27902C69550B}" dt="2024-01-21T10:02:37.066" v="98"/>
-        <pc:sldMkLst>
-          <pc:docMk/>
-          <pc:sldMk cId="4249457938" sldId="417"/>
-        </pc:sldMkLst>
-      </pc:sldChg>
-      <pc:sldChg chg="addSp delSp modSp mod">
-        <pc:chgData name="Matthieu De Mari" userId="dfb708c9-d8dc-439f-9a3b-c772bf4a311c" providerId="ADAL" clId="{247D1BAE-CADF-480A-BB5E-27902C69550B}" dt="2024-01-21T10:04:19.807" v="170" actId="20577"/>
-        <pc:sldMkLst>
-          <pc:docMk/>
-          <pc:sldMk cId="3310153579" sldId="418"/>
-        </pc:sldMkLst>
-      </pc:sldChg>
-      <pc:sldChg chg="addSp delSp modSp mod">
-        <pc:chgData name="Matthieu De Mari" userId="dfb708c9-d8dc-439f-9a3b-c772bf4a311c" providerId="ADAL" clId="{247D1BAE-CADF-480A-BB5E-27902C69550B}" dt="2024-01-21T10:04:03.136" v="160" actId="20577"/>
-        <pc:sldMkLst>
-          <pc:docMk/>
-          <pc:sldMk cId="1163891923" sldId="419"/>
-        </pc:sldMkLst>
-      </pc:sldChg>
-      <pc:sldChg chg="modSp mod">
-        <pc:chgData name="Matthieu De Mari" userId="dfb708c9-d8dc-439f-9a3b-c772bf4a311c" providerId="ADAL" clId="{247D1BAE-CADF-480A-BB5E-27902C69550B}" dt="2024-01-21T10:04:42.295" v="194" actId="20577"/>
-        <pc:sldMkLst>
-          <pc:docMk/>
-          <pc:sldMk cId="1773283043" sldId="420"/>
-        </pc:sldMkLst>
-      </pc:sldChg>
-      <pc:sldChg chg="modSp mod">
-        <pc:chgData name="Matthieu De Mari" userId="dfb708c9-d8dc-439f-9a3b-c772bf4a311c" providerId="ADAL" clId="{247D1BAE-CADF-480A-BB5E-27902C69550B}" dt="2024-02-05T00:16:00.404" v="274" actId="20577"/>
-        <pc:sldMkLst>
-          <pc:docMk/>
-          <pc:sldMk cId="1146881653" sldId="649"/>
-        </pc:sldMkLst>
-      </pc:sldChg>
-    </pc:docChg>
-  </pc:docChgLst>
-  <pc:docChgLst>
-    <pc:chgData name="Matthieu De Mari" userId="dfb708c9-d8dc-439f-9a3b-c772bf4a311c" providerId="ADAL" clId="{6A0148FC-2914-4FD1-A37F-A0E704A4DFFC}"/>
-    <pc:docChg chg="custSel addSld modSld sldOrd modSection">
-      <pc:chgData name="Matthieu De Mari" userId="dfb708c9-d8dc-439f-9a3b-c772bf4a311c" providerId="ADAL" clId="{6A0148FC-2914-4FD1-A37F-A0E704A4DFFC}" dt="2025-02-10T03:42:56.968" v="403" actId="27636"/>
-      <pc:docMkLst>
-        <pc:docMk/>
-      </pc:docMkLst>
-      <pc:sldChg chg="addSp delSp modSp add mod ord modClrScheme chgLayout">
-        <pc:chgData name="Matthieu De Mari" userId="dfb708c9-d8dc-439f-9a3b-c772bf4a311c" providerId="ADAL" clId="{6A0148FC-2914-4FD1-A37F-A0E704A4DFFC}" dt="2025-02-10T03:42:56.968" v="403" actId="27636"/>
+        <pc:chgData name="Matthieu De Mari" userId="dfb708c9-d8dc-439f-9a3b-c772bf4a311c" providerId="ADAL" clId="{81E9B007-0C2C-493E-9B93-55A62C9C1F12}" dt="2025-12-18T22:20:21.245" v="2" actId="20577"/>
         <pc:sldMkLst>
           <pc:docMk/>
           <pc:sldMk cId="4225424130" sldId="787"/>
         </pc:sldMkLst>
-        <pc:spChg chg="mod ord">
-          <ac:chgData name="Matthieu De Mari" userId="dfb708c9-d8dc-439f-9a3b-c772bf4a311c" providerId="ADAL" clId="{6A0148FC-2914-4FD1-A37F-A0E704A4DFFC}" dt="2025-02-10T03:41:40.018" v="146" actId="700"/>
-          <ac:spMkLst>
-            <pc:docMk/>
-            <pc:sldMk cId="4225424130" sldId="787"/>
-            <ac:spMk id="2" creationId="{3D270156-A29B-F996-8AA8-5C78B66D5810}"/>
-          </ac:spMkLst>
-        </pc:spChg>
-        <pc:spChg chg="mod ord">
-          <ac:chgData name="Matthieu De Mari" userId="dfb708c9-d8dc-439f-9a3b-c772bf4a311c" providerId="ADAL" clId="{6A0148FC-2914-4FD1-A37F-A0E704A4DFFC}" dt="2025-02-10T03:42:56.968" v="403" actId="27636"/>
+        <pc:spChg chg="mod">
+          <ac:chgData name="Matthieu De Mari" userId="dfb708c9-d8dc-439f-9a3b-c772bf4a311c" providerId="ADAL" clId="{81E9B007-0C2C-493E-9B93-55A62C9C1F12}" dt="2025-12-18T22:20:21.245" v="2" actId="20577"/>
           <ac:spMkLst>
             <pc:docMk/>
             <pc:sldMk cId="4225424130" sldId="787"/>
             <ac:spMk id="3" creationId="{811BFAB2-CE03-4B19-15B7-5D788C13B2FA}"/>
           </ac:spMkLst>
         </pc:spChg>
-        <pc:spChg chg="add del mod ord">
-          <ac:chgData name="Matthieu De Mari" userId="dfb708c9-d8dc-439f-9a3b-c772bf4a311c" providerId="ADAL" clId="{6A0148FC-2914-4FD1-A37F-A0E704A4DFFC}" dt="2025-02-10T03:41:41.993" v="148" actId="478"/>
-          <ac:spMkLst>
-            <pc:docMk/>
-            <pc:sldMk cId="4225424130" sldId="787"/>
-            <ac:spMk id="4" creationId="{3EB2BA6E-CDF3-10FA-A2F4-2C1B526D01E9}"/>
-          </ac:spMkLst>
-        </pc:spChg>
-        <pc:picChg chg="add mod">
-          <ac:chgData name="Matthieu De Mari" userId="dfb708c9-d8dc-439f-9a3b-c772bf4a311c" providerId="ADAL" clId="{6A0148FC-2914-4FD1-A37F-A0E704A4DFFC}" dt="2025-02-10T03:41:57.567" v="160" actId="14100"/>
-          <ac:picMkLst>
-            <pc:docMk/>
-            <pc:sldMk cId="4225424130" sldId="787"/>
-            <ac:picMk id="6" creationId="{F6FB43C8-3C29-BA06-BBF8-541C3A943BFF}"/>
-          </ac:picMkLst>
-        </pc:picChg>
-        <pc:picChg chg="del">
-          <ac:chgData name="Matthieu De Mari" userId="dfb708c9-d8dc-439f-9a3b-c772bf4a311c" providerId="ADAL" clId="{6A0148FC-2914-4FD1-A37F-A0E704A4DFFC}" dt="2025-02-10T03:41:41.139" v="147" actId="478"/>
-          <ac:picMkLst>
-            <pc:docMk/>
-            <pc:sldMk cId="4225424130" sldId="787"/>
-            <ac:picMk id="7" creationId="{49549816-7C20-FDC1-1407-4FA787A7305D}"/>
-          </ac:picMkLst>
-        </pc:picChg>
       </pc:sldChg>
     </pc:docChg>
   </pc:docChgLst>
@@ -2383,7 +399,7 @@
           <a:p>
             <a:fld id="{61478373-EB31-4867-8CF0-FA31364748A5}" type="datetimeFigureOut">
               <a:rPr lang="en-GB" smtClean="0"/>
-              <a:t>10/02/2025</a:t>
+              <a:t>18/12/2025</a:t>
             </a:fld>
             <a:endParaRPr lang="en-GB"/>
           </a:p>
@@ -2800,7 +816,7 @@
           <a:p>
             <a:fld id="{E85DF616-B21E-4EF6-A6A5-95E2FB3EB1A1}" type="datetimeFigureOut">
               <a:rPr lang="en-GB" smtClean="0"/>
-              <a:t>10/02/2025</a:t>
+              <a:t>18/12/2025</a:t>
             </a:fld>
             <a:endParaRPr lang="en-GB"/>
           </a:p>
@@ -3000,7 +1016,7 @@
           <a:p>
             <a:fld id="{E85DF616-B21E-4EF6-A6A5-95E2FB3EB1A1}" type="datetimeFigureOut">
               <a:rPr lang="en-GB" smtClean="0"/>
-              <a:t>10/02/2025</a:t>
+              <a:t>18/12/2025</a:t>
             </a:fld>
             <a:endParaRPr lang="en-GB"/>
           </a:p>
@@ -3210,7 +1226,7 @@
           <a:p>
             <a:fld id="{E85DF616-B21E-4EF6-A6A5-95E2FB3EB1A1}" type="datetimeFigureOut">
               <a:rPr lang="en-GB" smtClean="0"/>
-              <a:t>10/02/2025</a:t>
+              <a:t>18/12/2025</a:t>
             </a:fld>
             <a:endParaRPr lang="en-GB"/>
           </a:p>
@@ -3410,7 +1426,7 @@
           <a:p>
             <a:fld id="{E85DF616-B21E-4EF6-A6A5-95E2FB3EB1A1}" type="datetimeFigureOut">
               <a:rPr lang="en-GB" smtClean="0"/>
-              <a:t>10/02/2025</a:t>
+              <a:t>18/12/2025</a:t>
             </a:fld>
             <a:endParaRPr lang="en-GB"/>
           </a:p>
@@ -3686,7 +1702,7 @@
           <a:p>
             <a:fld id="{E85DF616-B21E-4EF6-A6A5-95E2FB3EB1A1}" type="datetimeFigureOut">
               <a:rPr lang="en-GB" smtClean="0"/>
-              <a:t>10/02/2025</a:t>
+              <a:t>18/12/2025</a:t>
             </a:fld>
             <a:endParaRPr lang="en-GB"/>
           </a:p>
@@ -3954,7 +1970,7 @@
           <a:p>
             <a:fld id="{E85DF616-B21E-4EF6-A6A5-95E2FB3EB1A1}" type="datetimeFigureOut">
               <a:rPr lang="en-GB" smtClean="0"/>
-              <a:t>10/02/2025</a:t>
+              <a:t>18/12/2025</a:t>
             </a:fld>
             <a:endParaRPr lang="en-GB"/>
           </a:p>
@@ -4369,7 +2385,7 @@
           <a:p>
             <a:fld id="{E85DF616-B21E-4EF6-A6A5-95E2FB3EB1A1}" type="datetimeFigureOut">
               <a:rPr lang="en-GB" smtClean="0"/>
-              <a:t>10/02/2025</a:t>
+              <a:t>18/12/2025</a:t>
             </a:fld>
             <a:endParaRPr lang="en-GB"/>
           </a:p>
@@ -4511,7 +2527,7 @@
           <a:p>
             <a:fld id="{E85DF616-B21E-4EF6-A6A5-95E2FB3EB1A1}" type="datetimeFigureOut">
               <a:rPr lang="en-GB" smtClean="0"/>
-              <a:t>10/02/2025</a:t>
+              <a:t>18/12/2025</a:t>
             </a:fld>
             <a:endParaRPr lang="en-GB"/>
           </a:p>
@@ -4624,7 +2640,7 @@
           <a:p>
             <a:fld id="{E85DF616-B21E-4EF6-A6A5-95E2FB3EB1A1}" type="datetimeFigureOut">
               <a:rPr lang="en-GB" smtClean="0"/>
-              <a:t>10/02/2025</a:t>
+              <a:t>18/12/2025</a:t>
             </a:fld>
             <a:endParaRPr lang="en-GB"/>
           </a:p>
@@ -4937,7 +2953,7 @@
           <a:p>
             <a:fld id="{E85DF616-B21E-4EF6-A6A5-95E2FB3EB1A1}" type="datetimeFigureOut">
               <a:rPr lang="en-GB" smtClean="0"/>
-              <a:t>10/02/2025</a:t>
+              <a:t>18/12/2025</a:t>
             </a:fld>
             <a:endParaRPr lang="en-GB"/>
           </a:p>
@@ -5226,7 +3242,7 @@
           <a:p>
             <a:fld id="{E85DF616-B21E-4EF6-A6A5-95E2FB3EB1A1}" type="datetimeFigureOut">
               <a:rPr lang="en-GB" smtClean="0"/>
-              <a:t>10/02/2025</a:t>
+              <a:t>18/12/2025</a:t>
             </a:fld>
             <a:endParaRPr lang="en-GB"/>
           </a:p>
@@ -5469,7 +3485,7 @@
           <a:p>
             <a:fld id="{E85DF616-B21E-4EF6-A6A5-95E2FB3EB1A1}" type="datetimeFigureOut">
               <a:rPr lang="en-GB" smtClean="0"/>
-              <a:t>10/02/2025</a:t>
+              <a:t>18/12/2025</a:t>
             </a:fld>
             <a:endParaRPr lang="en-GB"/>
           </a:p>
@@ -13109,26 +11125,50 @@
               <a:buNone/>
             </a:pPr>
             <a:r>
-              <a:rPr lang="en-GB" b="1" dirty="0"/>
+              <a:rPr lang="en-GB" b="1" dirty="0">
+                <a:solidFill>
+                  <a:srgbClr val="FF0000"/>
+                </a:solidFill>
+              </a:rPr>
               <a:t>To keep it simple: Trainable parameters</a:t>
             </a:r>
             <a:r>
-              <a:rPr lang="en-GB" dirty="0"/>
+              <a:rPr lang="en-GB" dirty="0">
+                <a:solidFill>
+                  <a:srgbClr val="FF0000"/>
+                </a:solidFill>
+              </a:rPr>
               <a:t> </a:t>
             </a:r>
             <a:r>
-              <a:rPr lang="en-GB" b="1" dirty="0"/>
+              <a:rPr lang="en-GB" b="1" dirty="0">
+                <a:solidFill>
+                  <a:srgbClr val="FF0000"/>
+                </a:solidFill>
+              </a:rPr>
               <a:t>should</a:t>
             </a:r>
             <a:r>
-              <a:rPr lang="en-GB" dirty="0"/>
+              <a:rPr lang="en-GB" dirty="0">
+                <a:solidFill>
+                  <a:srgbClr val="FF0000"/>
+                </a:solidFill>
+              </a:rPr>
               <a:t> </a:t>
             </a:r>
             <a:r>
-              <a:rPr lang="en-GB" b="1" dirty="0"/>
+              <a:rPr lang="en-GB" b="1" dirty="0">
+                <a:solidFill>
+                  <a:srgbClr val="FF0000"/>
+                </a:solidFill>
+              </a:rPr>
               <a:t>allow for gradients to be retained for backpropagation.</a:t>
             </a:r>
-            <a:endParaRPr lang="en-GB" dirty="0"/>
+            <a:endParaRPr lang="en-GB" dirty="0">
+              <a:solidFill>
+                <a:srgbClr val="FF0000"/>
+              </a:solidFill>
+            </a:endParaRPr>
           </a:p>
         </p:txBody>
       </p:sp>
@@ -14382,7 +12422,7 @@
             </a:r>
             <a:r>
               <a:rPr lang="en-GB" dirty="0"/>
-              <a:t>, but remember to select GPUs are runtime hardware (by default CPU).</a:t>
+              <a:t> but remember to select GPUs are runtime hardware (by default CPU).</a:t>
             </a:r>
             <a:endParaRPr lang="en-GB" i="1" dirty="0"/>
           </a:p>
@@ -14403,15 +12443,7 @@
             </a:br>
             <a:r>
               <a:rPr lang="en-GB" b="1" i="1" dirty="0"/>
-              <a:t>(but </a:t>
-            </a:r>
-            <a:r>
-              <a:rPr lang="en-GB" b="1" i="1"/>
-              <a:t>you have </a:t>
-            </a:r>
-            <a:r>
-              <a:rPr lang="en-GB" b="1" i="1" dirty="0"/>
-              <a:t>to figure it out!)</a:t>
+              <a:t>(but you have to figure it out!)</a:t>
             </a:r>
           </a:p>
           <a:p>
@@ -15166,7 +13198,7 @@
             </a:r>
             <a:r>
               <a:rPr lang="en-GB" dirty="0"/>
-              <a:t> is specifically designed with deep learning, and provides a more natural and convenient interface.</a:t>
+              <a:t> is specifically designed with deep learning and provides a more natural and convenient interface.</a:t>
             </a:r>
           </a:p>
           <a:p>

</xml_diff>

<commit_message>
Minor changes to W2 and W3 materials.
</commit_message>
<xml_diff>
--- a/W3/1. W3S1 final/W3S1.pptx
+++ b/W3/1. W3S1 final/W3S1.pptx
@@ -258,12 +258,20 @@
 </p:presentation>
 </file>
 
+<file path=ppt/revisionInfo.xml><?xml version="1.0" encoding="utf-8"?>
+<p1510:revInfo xmlns:a="http://schemas.openxmlformats.org/drawingml/2006/main" xmlns:r="http://schemas.openxmlformats.org/officeDocument/2006/relationships" xmlns:p1510="http://schemas.microsoft.com/office/powerpoint/2015/10/main">
+  <p1510:revLst>
+    <p1510:client id="{DD225343-4154-4EC3-8453-B93582813BD1}" v="2" dt="2026-01-12T06:13:44.670"/>
+  </p1510:revLst>
+</p1510:revInfo>
+</file>
+
 <file path=ppt/changesInfos/changesInfo1.xml><?xml version="1.0" encoding="utf-8"?>
 <pc:chgInfo xmlns:a="http://schemas.openxmlformats.org/drawingml/2006/main" xmlns:r="http://schemas.openxmlformats.org/officeDocument/2006/relationships" xmlns:ac="http://schemas.microsoft.com/office/drawing/2013/main/command" xmlns:pc="http://schemas.microsoft.com/office/powerpoint/2013/main/command">
   <pc:docChgLst>
     <pc:chgData name="Matthieu De Mari" userId="dfb708c9-d8dc-439f-9a3b-c772bf4a311c" providerId="ADAL" clId="{81E9B007-0C2C-493E-9B93-55A62C9C1F12}"/>
     <pc:docChg chg="modSld">
-      <pc:chgData name="Matthieu De Mari" userId="dfb708c9-d8dc-439f-9a3b-c772bf4a311c" providerId="ADAL" clId="{81E9B007-0C2C-493E-9B93-55A62C9C1F12}" dt="2025-12-18T22:20:21.245" v="2" actId="20577"/>
+      <pc:chgData name="Matthieu De Mari" userId="dfb708c9-d8dc-439f-9a3b-c772bf4a311c" providerId="ADAL" clId="{81E9B007-0C2C-493E-9B93-55A62C9C1F12}" dt="2026-01-12T06:13:44.670" v="4"/>
       <pc:docMkLst>
         <pc:docMk/>
       </pc:docMkLst>
@@ -282,14 +290,29 @@
           </ac:spMkLst>
         </pc:spChg>
       </pc:sldChg>
+      <pc:sldChg chg="addSp modSp">
+        <pc:chgData name="Matthieu De Mari" userId="dfb708c9-d8dc-439f-9a3b-c772bf4a311c" providerId="ADAL" clId="{81E9B007-0C2C-493E-9B93-55A62C9C1F12}" dt="2026-01-12T06:13:22.383" v="3"/>
+        <pc:sldMkLst>
+          <pc:docMk/>
+          <pc:sldMk cId="1172112343" sldId="648"/>
+        </pc:sldMkLst>
+        <pc:spChg chg="add mod">
+          <ac:chgData name="Matthieu De Mari" userId="dfb708c9-d8dc-439f-9a3b-c772bf4a311c" providerId="ADAL" clId="{81E9B007-0C2C-493E-9B93-55A62C9C1F12}" dt="2026-01-12T06:13:22.383" v="3"/>
+          <ac:spMkLst>
+            <pc:docMk/>
+            <pc:sldMk cId="1172112343" sldId="648"/>
+            <ac:spMk id="3" creationId="{A5A47B96-2DBF-902D-F1DB-5A5C00D7DCF1}"/>
+          </ac:spMkLst>
+        </pc:spChg>
+      </pc:sldChg>
       <pc:sldChg chg="modSp mod">
-        <pc:chgData name="Matthieu De Mari" userId="dfb708c9-d8dc-439f-9a3b-c772bf4a311c" providerId="ADAL" clId="{81E9B007-0C2C-493E-9B93-55A62C9C1F12}" dt="2025-12-18T22:19:40.157" v="1" actId="207"/>
+        <pc:chgData name="Matthieu De Mari" userId="dfb708c9-d8dc-439f-9a3b-c772bf4a311c" providerId="ADAL" clId="{81E9B007-0C2C-493E-9B93-55A62C9C1F12}" dt="2026-01-12T06:13:44.670" v="4"/>
         <pc:sldMkLst>
           <pc:docMk/>
           <pc:sldMk cId="1146881653" sldId="649"/>
         </pc:sldMkLst>
         <pc:spChg chg="mod">
-          <ac:chgData name="Matthieu De Mari" userId="dfb708c9-d8dc-439f-9a3b-c772bf4a311c" providerId="ADAL" clId="{81E9B007-0C2C-493E-9B93-55A62C9C1F12}" dt="2025-12-18T22:19:40.157" v="1" actId="207"/>
+          <ac:chgData name="Matthieu De Mari" userId="dfb708c9-d8dc-439f-9a3b-c772bf4a311c" providerId="ADAL" clId="{81E9B007-0C2C-493E-9B93-55A62C9C1F12}" dt="2026-01-12T06:13:44.670" v="4"/>
           <ac:spMkLst>
             <pc:docMk/>
             <pc:sldMk cId="1146881653" sldId="649"/>
@@ -399,7 +422,7 @@
           <a:p>
             <a:fld id="{61478373-EB31-4867-8CF0-FA31364748A5}" type="datetimeFigureOut">
               <a:rPr lang="en-GB" smtClean="0"/>
-              <a:t>18/12/2025</a:t>
+              <a:t>12/01/2026</a:t>
             </a:fld>
             <a:endParaRPr lang="en-GB"/>
           </a:p>
@@ -816,7 +839,7 @@
           <a:p>
             <a:fld id="{E85DF616-B21E-4EF6-A6A5-95E2FB3EB1A1}" type="datetimeFigureOut">
               <a:rPr lang="en-GB" smtClean="0"/>
-              <a:t>18/12/2025</a:t>
+              <a:t>12/01/2026</a:t>
             </a:fld>
             <a:endParaRPr lang="en-GB"/>
           </a:p>
@@ -1016,7 +1039,7 @@
           <a:p>
             <a:fld id="{E85DF616-B21E-4EF6-A6A5-95E2FB3EB1A1}" type="datetimeFigureOut">
               <a:rPr lang="en-GB" smtClean="0"/>
-              <a:t>18/12/2025</a:t>
+              <a:t>12/01/2026</a:t>
             </a:fld>
             <a:endParaRPr lang="en-GB"/>
           </a:p>
@@ -1226,7 +1249,7 @@
           <a:p>
             <a:fld id="{E85DF616-B21E-4EF6-A6A5-95E2FB3EB1A1}" type="datetimeFigureOut">
               <a:rPr lang="en-GB" smtClean="0"/>
-              <a:t>18/12/2025</a:t>
+              <a:t>12/01/2026</a:t>
             </a:fld>
             <a:endParaRPr lang="en-GB"/>
           </a:p>
@@ -1426,7 +1449,7 @@
           <a:p>
             <a:fld id="{E85DF616-B21E-4EF6-A6A5-95E2FB3EB1A1}" type="datetimeFigureOut">
               <a:rPr lang="en-GB" smtClean="0"/>
-              <a:t>18/12/2025</a:t>
+              <a:t>12/01/2026</a:t>
             </a:fld>
             <a:endParaRPr lang="en-GB"/>
           </a:p>
@@ -1702,7 +1725,7 @@
           <a:p>
             <a:fld id="{E85DF616-B21E-4EF6-A6A5-95E2FB3EB1A1}" type="datetimeFigureOut">
               <a:rPr lang="en-GB" smtClean="0"/>
-              <a:t>18/12/2025</a:t>
+              <a:t>12/01/2026</a:t>
             </a:fld>
             <a:endParaRPr lang="en-GB"/>
           </a:p>
@@ -1970,7 +1993,7 @@
           <a:p>
             <a:fld id="{E85DF616-B21E-4EF6-A6A5-95E2FB3EB1A1}" type="datetimeFigureOut">
               <a:rPr lang="en-GB" smtClean="0"/>
-              <a:t>18/12/2025</a:t>
+              <a:t>12/01/2026</a:t>
             </a:fld>
             <a:endParaRPr lang="en-GB"/>
           </a:p>
@@ -2385,7 +2408,7 @@
           <a:p>
             <a:fld id="{E85DF616-B21E-4EF6-A6A5-95E2FB3EB1A1}" type="datetimeFigureOut">
               <a:rPr lang="en-GB" smtClean="0"/>
-              <a:t>18/12/2025</a:t>
+              <a:t>12/01/2026</a:t>
             </a:fld>
             <a:endParaRPr lang="en-GB"/>
           </a:p>
@@ -2527,7 +2550,7 @@
           <a:p>
             <a:fld id="{E85DF616-B21E-4EF6-A6A5-95E2FB3EB1A1}" type="datetimeFigureOut">
               <a:rPr lang="en-GB" smtClean="0"/>
-              <a:t>18/12/2025</a:t>
+              <a:t>12/01/2026</a:t>
             </a:fld>
             <a:endParaRPr lang="en-GB"/>
           </a:p>
@@ -2640,7 +2663,7 @@
           <a:p>
             <a:fld id="{E85DF616-B21E-4EF6-A6A5-95E2FB3EB1A1}" type="datetimeFigureOut">
               <a:rPr lang="en-GB" smtClean="0"/>
-              <a:t>18/12/2025</a:t>
+              <a:t>12/01/2026</a:t>
             </a:fld>
             <a:endParaRPr lang="en-GB"/>
           </a:p>
@@ -2953,7 +2976,7 @@
           <a:p>
             <a:fld id="{E85DF616-B21E-4EF6-A6A5-95E2FB3EB1A1}" type="datetimeFigureOut">
               <a:rPr lang="en-GB" smtClean="0"/>
-              <a:t>18/12/2025</a:t>
+              <a:t>12/01/2026</a:t>
             </a:fld>
             <a:endParaRPr lang="en-GB"/>
           </a:p>
@@ -3242,7 +3265,7 @@
           <a:p>
             <a:fld id="{E85DF616-B21E-4EF6-A6A5-95E2FB3EB1A1}" type="datetimeFigureOut">
               <a:rPr lang="en-GB" smtClean="0"/>
-              <a:t>18/12/2025</a:t>
+              <a:t>12/01/2026</a:t>
             </a:fld>
             <a:endParaRPr lang="en-GB"/>
           </a:p>
@@ -3485,7 +3508,7 @@
           <a:p>
             <a:fld id="{E85DF616-B21E-4EF6-A6A5-95E2FB3EB1A1}" type="datetimeFigureOut">
               <a:rPr lang="en-GB" smtClean="0"/>
-              <a:t>18/12/2025</a:t>
+              <a:t>12/01/2026</a:t>
             </a:fld>
             <a:endParaRPr lang="en-GB"/>
           </a:p>
@@ -10913,6 +10936,77 @@
           </a:p>
         </p:txBody>
       </p:sp>
+      <p:sp>
+        <p:nvSpPr>
+          <p:cNvPr id="3" name="TextBox 2">
+            <a:extLst>
+              <a:ext uri="{FF2B5EF4-FFF2-40B4-BE49-F238E27FC236}">
+                <a16:creationId xmlns:a16="http://schemas.microsoft.com/office/drawing/2014/main" id="{A5A47B96-2DBF-902D-F1DB-5A5C00D7DCF1}"/>
+              </a:ext>
+            </a:extLst>
+          </p:cNvPr>
+          <p:cNvSpPr txBox="1"/>
+          <p:nvPr/>
+        </p:nvSpPr>
+        <p:spPr>
+          <a:xfrm>
+            <a:off x="6079932" y="1284051"/>
+            <a:ext cx="4688732" cy="1569660"/>
+          </a:xfrm>
+          <a:prstGeom prst="rect">
+            <a:avLst/>
+          </a:prstGeom>
+          <a:noFill/>
+        </p:spPr>
+        <p:txBody>
+          <a:bodyPr wrap="square" rtlCol="0">
+            <a:spAutoFit/>
+          </a:bodyPr>
+          <a:lstStyle/>
+          <a:p>
+            <a:r>
+              <a:rPr lang="en-GB" sz="2400" b="1" dirty="0">
+                <a:solidFill>
+                  <a:schemeClr val="accent2"/>
+                </a:solidFill>
+              </a:rPr>
+              <a:t>Explicitly indicate that the </a:t>
+            </a:r>
+            <a:r>
+              <a:rPr lang="en-GB" sz="2400" b="1" dirty="0" err="1">
+                <a:solidFill>
+                  <a:schemeClr val="accent2"/>
+                </a:solidFill>
+              </a:rPr>
+              <a:t>Wx</a:t>
+            </a:r>
+            <a:r>
+              <a:rPr lang="en-GB" sz="2400" b="1" dirty="0">
+                <a:solidFill>
+                  <a:schemeClr val="accent2"/>
+                </a:solidFill>
+              </a:rPr>
+              <a:t> and </a:t>
+            </a:r>
+            <a:r>
+              <a:rPr lang="en-GB" sz="2400" b="1" dirty="0" err="1">
+                <a:solidFill>
+                  <a:schemeClr val="accent2"/>
+                </a:solidFill>
+              </a:rPr>
+              <a:t>bx</a:t>
+            </a:r>
+            <a:r>
+              <a:rPr lang="en-GB" sz="2400" b="1" dirty="0">
+                <a:solidFill>
+                  <a:schemeClr val="accent2"/>
+                </a:solidFill>
+              </a:rPr>
+              <a:t> matrices are now tensors, playing the roles of parameters in a Neural Network of some sort.</a:t>
+            </a:r>
+          </a:p>
+        </p:txBody>
+      </p:sp>
     </p:spTree>
     <p:extLst>
       <p:ext uri="{BB962C8B-B14F-4D97-AF65-F5344CB8AC3E}">
@@ -11037,7 +11131,7 @@
             </a:r>
             <a:r>
               <a:rPr lang="en-GB" b="1" dirty="0"/>
-              <a:t>allows the gradients to be accumulated for a particular tensor</a:t>
+              <a:t>allows the gradients to be calculated for a particular tensor</a:t>
             </a:r>
             <a:r>
               <a:rPr lang="en-GB" dirty="0"/>

</xml_diff>

<commit_message>
Preparing to teach W2 and W3 content.
</commit_message>
<xml_diff>
--- a/W3/1. W3S1 final/W3S1.pptx
+++ b/W3/1. W3S1 final/W3S1.pptx
@@ -258,35 +258,42 @@
 </p:presentation>
 </file>
 
-<file path=ppt/revisionInfo.xml><?xml version="1.0" encoding="utf-8"?>
-<p1510:revInfo xmlns:a="http://schemas.openxmlformats.org/drawingml/2006/main" xmlns:r="http://schemas.openxmlformats.org/officeDocument/2006/relationships" xmlns:p1510="http://schemas.microsoft.com/office/powerpoint/2015/10/main">
-  <p1510:revLst>
-    <p1510:client id="{DD225343-4154-4EC3-8453-B93582813BD1}" v="2" dt="2026-01-12T06:13:44.670"/>
-  </p1510:revLst>
-</p1510:revInfo>
-</file>
-
 <file path=ppt/changesInfos/changesInfo1.xml><?xml version="1.0" encoding="utf-8"?>
 <pc:chgInfo xmlns:a="http://schemas.openxmlformats.org/drawingml/2006/main" xmlns:r="http://schemas.openxmlformats.org/officeDocument/2006/relationships" xmlns:ac="http://schemas.microsoft.com/office/drawing/2013/main/command" xmlns:pc="http://schemas.microsoft.com/office/powerpoint/2013/main/command">
   <pc:docChgLst>
     <pc:chgData name="Matthieu De Mari" userId="dfb708c9-d8dc-439f-9a3b-c772bf4a311c" providerId="ADAL" clId="{81E9B007-0C2C-493E-9B93-55A62C9C1F12}"/>
     <pc:docChg chg="modSld">
-      <pc:chgData name="Matthieu De Mari" userId="dfb708c9-d8dc-439f-9a3b-c772bf4a311c" providerId="ADAL" clId="{81E9B007-0C2C-493E-9B93-55A62C9C1F12}" dt="2026-01-12T06:13:44.670" v="4"/>
+      <pc:chgData name="Matthieu De Mari" userId="dfb708c9-d8dc-439f-9a3b-c772bf4a311c" providerId="ADAL" clId="{81E9B007-0C2C-493E-9B93-55A62C9C1F12}" dt="2026-01-29T05:32:27.088" v="99" actId="20577"/>
       <pc:docMkLst>
         <pc:docMk/>
       </pc:docMkLst>
       <pc:sldChg chg="modSp mod">
-        <pc:chgData name="Matthieu De Mari" userId="dfb708c9-d8dc-439f-9a3b-c772bf4a311c" providerId="ADAL" clId="{81E9B007-0C2C-493E-9B93-55A62C9C1F12}" dt="2025-12-18T22:17:52.423" v="0" actId="20577"/>
+        <pc:chgData name="Matthieu De Mari" userId="dfb708c9-d8dc-439f-9a3b-c772bf4a311c" providerId="ADAL" clId="{81E9B007-0C2C-493E-9B93-55A62C9C1F12}" dt="2026-01-29T05:30:38.342" v="58" actId="20577"/>
         <pc:sldMkLst>
           <pc:docMk/>
           <pc:sldMk cId="380766058" sldId="378"/>
         </pc:sldMkLst>
         <pc:spChg chg="mod">
-          <ac:chgData name="Matthieu De Mari" userId="dfb708c9-d8dc-439f-9a3b-c772bf4a311c" providerId="ADAL" clId="{81E9B007-0C2C-493E-9B93-55A62C9C1F12}" dt="2025-12-18T22:17:52.423" v="0" actId="20577"/>
+          <ac:chgData name="Matthieu De Mari" userId="dfb708c9-d8dc-439f-9a3b-c772bf4a311c" providerId="ADAL" clId="{81E9B007-0C2C-493E-9B93-55A62C9C1F12}" dt="2026-01-29T05:30:38.342" v="58" actId="20577"/>
           <ac:spMkLst>
             <pc:docMk/>
             <pc:sldMk cId="380766058" sldId="378"/>
             <ac:spMk id="3" creationId="{65399E50-9E84-8D67-B55F-073C06C3D10E}"/>
+          </ac:spMkLst>
+        </pc:spChg>
+      </pc:sldChg>
+      <pc:sldChg chg="modSp mod">
+        <pc:chgData name="Matthieu De Mari" userId="dfb708c9-d8dc-439f-9a3b-c772bf4a311c" providerId="ADAL" clId="{81E9B007-0C2C-493E-9B93-55A62C9C1F12}" dt="2026-01-29T05:31:03.332" v="60" actId="20577"/>
+        <pc:sldMkLst>
+          <pc:docMk/>
+          <pc:sldMk cId="1970187575" sldId="379"/>
+        </pc:sldMkLst>
+        <pc:spChg chg="mod">
+          <ac:chgData name="Matthieu De Mari" userId="dfb708c9-d8dc-439f-9a3b-c772bf4a311c" providerId="ADAL" clId="{81E9B007-0C2C-493E-9B93-55A62C9C1F12}" dt="2026-01-29T05:31:03.332" v="60" actId="20577"/>
+          <ac:spMkLst>
+            <pc:docMk/>
+            <pc:sldMk cId="1970187575" sldId="379"/>
+            <ac:spMk id="5" creationId="{DF664FFA-9452-2803-1619-F2562904679D}"/>
           </ac:spMkLst>
         </pc:spChg>
       </pc:sldChg>
@@ -306,32 +313,17 @@
         </pc:spChg>
       </pc:sldChg>
       <pc:sldChg chg="modSp mod">
-        <pc:chgData name="Matthieu De Mari" userId="dfb708c9-d8dc-439f-9a3b-c772bf4a311c" providerId="ADAL" clId="{81E9B007-0C2C-493E-9B93-55A62C9C1F12}" dt="2026-01-12T06:13:44.670" v="4"/>
+        <pc:chgData name="Matthieu De Mari" userId="dfb708c9-d8dc-439f-9a3b-c772bf4a311c" providerId="ADAL" clId="{81E9B007-0C2C-493E-9B93-55A62C9C1F12}" dt="2026-01-29T05:32:27.088" v="99" actId="20577"/>
         <pc:sldMkLst>
           <pc:docMk/>
           <pc:sldMk cId="1146881653" sldId="649"/>
         </pc:sldMkLst>
         <pc:spChg chg="mod">
-          <ac:chgData name="Matthieu De Mari" userId="dfb708c9-d8dc-439f-9a3b-c772bf4a311c" providerId="ADAL" clId="{81E9B007-0C2C-493E-9B93-55A62C9C1F12}" dt="2026-01-12T06:13:44.670" v="4"/>
+          <ac:chgData name="Matthieu De Mari" userId="dfb708c9-d8dc-439f-9a3b-c772bf4a311c" providerId="ADAL" clId="{81E9B007-0C2C-493E-9B93-55A62C9C1F12}" dt="2026-01-29T05:32:27.088" v="99" actId="20577"/>
           <ac:spMkLst>
             <pc:docMk/>
             <pc:sldMk cId="1146881653" sldId="649"/>
             <ac:spMk id="3" creationId="{DC9D8363-826B-D189-78FB-CCD945BC5477}"/>
-          </ac:spMkLst>
-        </pc:spChg>
-      </pc:sldChg>
-      <pc:sldChg chg="modSp mod">
-        <pc:chgData name="Matthieu De Mari" userId="dfb708c9-d8dc-439f-9a3b-c772bf4a311c" providerId="ADAL" clId="{81E9B007-0C2C-493E-9B93-55A62C9C1F12}" dt="2025-12-18T22:20:21.245" v="2" actId="20577"/>
-        <pc:sldMkLst>
-          <pc:docMk/>
-          <pc:sldMk cId="4225424130" sldId="787"/>
-        </pc:sldMkLst>
-        <pc:spChg chg="mod">
-          <ac:chgData name="Matthieu De Mari" userId="dfb708c9-d8dc-439f-9a3b-c772bf4a311c" providerId="ADAL" clId="{81E9B007-0C2C-493E-9B93-55A62C9C1F12}" dt="2025-12-18T22:20:21.245" v="2" actId="20577"/>
-          <ac:spMkLst>
-            <pc:docMk/>
-            <pc:sldMk cId="4225424130" sldId="787"/>
-            <ac:spMk id="3" creationId="{811BFAB2-CE03-4B19-15B7-5D788C13B2FA}"/>
           </ac:spMkLst>
         </pc:spChg>
       </pc:sldChg>
@@ -422,7 +414,7 @@
           <a:p>
             <a:fld id="{61478373-EB31-4867-8CF0-FA31364748A5}" type="datetimeFigureOut">
               <a:rPr lang="en-GB" smtClean="0"/>
-              <a:t>12/01/2026</a:t>
+              <a:t>29/01/2026</a:t>
             </a:fld>
             <a:endParaRPr lang="en-GB"/>
           </a:p>
@@ -839,7 +831,7 @@
           <a:p>
             <a:fld id="{E85DF616-B21E-4EF6-A6A5-95E2FB3EB1A1}" type="datetimeFigureOut">
               <a:rPr lang="en-GB" smtClean="0"/>
-              <a:t>12/01/2026</a:t>
+              <a:t>29/01/2026</a:t>
             </a:fld>
             <a:endParaRPr lang="en-GB"/>
           </a:p>
@@ -1039,7 +1031,7 @@
           <a:p>
             <a:fld id="{E85DF616-B21E-4EF6-A6A5-95E2FB3EB1A1}" type="datetimeFigureOut">
               <a:rPr lang="en-GB" smtClean="0"/>
-              <a:t>12/01/2026</a:t>
+              <a:t>29/01/2026</a:t>
             </a:fld>
             <a:endParaRPr lang="en-GB"/>
           </a:p>
@@ -1249,7 +1241,7 @@
           <a:p>
             <a:fld id="{E85DF616-B21E-4EF6-A6A5-95E2FB3EB1A1}" type="datetimeFigureOut">
               <a:rPr lang="en-GB" smtClean="0"/>
-              <a:t>12/01/2026</a:t>
+              <a:t>29/01/2026</a:t>
             </a:fld>
             <a:endParaRPr lang="en-GB"/>
           </a:p>
@@ -1449,7 +1441,7 @@
           <a:p>
             <a:fld id="{E85DF616-B21E-4EF6-A6A5-95E2FB3EB1A1}" type="datetimeFigureOut">
               <a:rPr lang="en-GB" smtClean="0"/>
-              <a:t>12/01/2026</a:t>
+              <a:t>29/01/2026</a:t>
             </a:fld>
             <a:endParaRPr lang="en-GB"/>
           </a:p>
@@ -1725,7 +1717,7 @@
           <a:p>
             <a:fld id="{E85DF616-B21E-4EF6-A6A5-95E2FB3EB1A1}" type="datetimeFigureOut">
               <a:rPr lang="en-GB" smtClean="0"/>
-              <a:t>12/01/2026</a:t>
+              <a:t>29/01/2026</a:t>
             </a:fld>
             <a:endParaRPr lang="en-GB"/>
           </a:p>
@@ -1993,7 +1985,7 @@
           <a:p>
             <a:fld id="{E85DF616-B21E-4EF6-A6A5-95E2FB3EB1A1}" type="datetimeFigureOut">
               <a:rPr lang="en-GB" smtClean="0"/>
-              <a:t>12/01/2026</a:t>
+              <a:t>29/01/2026</a:t>
             </a:fld>
             <a:endParaRPr lang="en-GB"/>
           </a:p>
@@ -2408,7 +2400,7 @@
           <a:p>
             <a:fld id="{E85DF616-B21E-4EF6-A6A5-95E2FB3EB1A1}" type="datetimeFigureOut">
               <a:rPr lang="en-GB" smtClean="0"/>
-              <a:t>12/01/2026</a:t>
+              <a:t>29/01/2026</a:t>
             </a:fld>
             <a:endParaRPr lang="en-GB"/>
           </a:p>
@@ -2550,7 +2542,7 @@
           <a:p>
             <a:fld id="{E85DF616-B21E-4EF6-A6A5-95E2FB3EB1A1}" type="datetimeFigureOut">
               <a:rPr lang="en-GB" smtClean="0"/>
-              <a:t>12/01/2026</a:t>
+              <a:t>29/01/2026</a:t>
             </a:fld>
             <a:endParaRPr lang="en-GB"/>
           </a:p>
@@ -2663,7 +2655,7 @@
           <a:p>
             <a:fld id="{E85DF616-B21E-4EF6-A6A5-95E2FB3EB1A1}" type="datetimeFigureOut">
               <a:rPr lang="en-GB" smtClean="0"/>
-              <a:t>12/01/2026</a:t>
+              <a:t>29/01/2026</a:t>
             </a:fld>
             <a:endParaRPr lang="en-GB"/>
           </a:p>
@@ -2976,7 +2968,7 @@
           <a:p>
             <a:fld id="{E85DF616-B21E-4EF6-A6A5-95E2FB3EB1A1}" type="datetimeFigureOut">
               <a:rPr lang="en-GB" smtClean="0"/>
-              <a:t>12/01/2026</a:t>
+              <a:t>29/01/2026</a:t>
             </a:fld>
             <a:endParaRPr lang="en-GB"/>
           </a:p>
@@ -3265,7 +3257,7 @@
           <a:p>
             <a:fld id="{E85DF616-B21E-4EF6-A6A5-95E2FB3EB1A1}" type="datetimeFigureOut">
               <a:rPr lang="en-GB" smtClean="0"/>
-              <a:t>12/01/2026</a:t>
+              <a:t>29/01/2026</a:t>
             </a:fld>
             <a:endParaRPr lang="en-GB"/>
           </a:p>
@@ -3508,7 +3500,7 @@
           <a:p>
             <a:fld id="{E85DF616-B21E-4EF6-A6A5-95E2FB3EB1A1}" type="datetimeFigureOut">
               <a:rPr lang="en-GB" smtClean="0"/>
-              <a:t>12/01/2026</a:t>
+              <a:t>29/01/2026</a:t>
             </a:fld>
             <a:endParaRPr lang="en-GB"/>
           </a:p>
@@ -11224,7 +11216,39 @@
                   <a:srgbClr val="FF0000"/>
                 </a:solidFill>
               </a:rPr>
-              <a:t>To keep it simple: Trainable parameters</a:t>
+              <a:t>For now (more on </a:t>
+            </a:r>
+            <a:r>
+              <a:rPr lang="en-GB" b="1">
+                <a:solidFill>
+                  <a:srgbClr val="FF0000"/>
+                </a:solidFill>
+              </a:rPr>
+              <a:t>this later!), </a:t>
+            </a:r>
+            <a:r>
+              <a:rPr lang="en-GB" b="1" dirty="0">
+                <a:solidFill>
+                  <a:srgbClr val="FF0000"/>
+                </a:solidFill>
+              </a:rPr>
+              <a:t>t</a:t>
+            </a:r>
+            <a:r>
+              <a:rPr lang="en-GB" b="1">
+                <a:solidFill>
+                  <a:srgbClr val="FF0000"/>
+                </a:solidFill>
+              </a:rPr>
+              <a:t>o </a:t>
+            </a:r>
+            <a:r>
+              <a:rPr lang="en-GB" b="1" dirty="0">
+                <a:solidFill>
+                  <a:srgbClr val="FF0000"/>
+                </a:solidFill>
+              </a:rPr>
+              <a:t>keep it simple: Trainable parameters</a:t>
             </a:r>
             <a:r>
               <a:rPr lang="en-GB" dirty="0">
@@ -13274,7 +13298,15 @@
             </a:r>
             <a:r>
               <a:rPr lang="en-GB" dirty="0"/>
-              <a:t> for working with tensors and neural networks.</a:t>
+              <a:t> for working with tensors, tensor operations (such as matrix </a:t>
+            </a:r>
+            <a:r>
+              <a:rPr lang="en-GB" dirty="0" err="1"/>
+              <a:t>multiplations</a:t>
+            </a:r>
+            <a:r>
+              <a:rPr lang="en-GB" dirty="0"/>
+              <a:t>) and neural networks.</a:t>
             </a:r>
           </a:p>
           <a:p>
@@ -13983,7 +14015,7 @@
             </a:pPr>
             <a:r>
               <a:rPr lang="en-GB" dirty="0"/>
-              <a:t>This is why most of the concepts and methods will look similar</a:t>
+              <a:t>This is why most of the concepts and methods will look similar.</a:t>
             </a:r>
           </a:p>
           <a:p>
@@ -13992,7 +14024,7 @@
             </a:pPr>
             <a:r>
               <a:rPr lang="en-GB" dirty="0"/>
-              <a:t> However, these come with additional features, which will be useful later on when building Neural Networks with these tensors.</a:t>
+              <a:t>However, these come with additional features, which will be useful later on when building Neural Networks with these tensors.</a:t>
             </a:r>
             <a:endParaRPr lang="en-SG" dirty="0"/>
           </a:p>

</xml_diff>

<commit_message>
Done teaching W3 and W4.
</commit_message>
<xml_diff>
--- a/W3/1. W3S1 final/W3S1.pptx
+++ b/W3/1. W3S1 final/W3S1.pptx
@@ -414,7 +414,7 @@
           <a:p>
             <a:fld id="{61478373-EB31-4867-8CF0-FA31364748A5}" type="datetimeFigureOut">
               <a:rPr lang="en-GB" smtClean="0"/>
-              <a:t>29/01/2026</a:t>
+              <a:t>09/02/2026</a:t>
             </a:fld>
             <a:endParaRPr lang="en-GB"/>
           </a:p>
@@ -831,7 +831,7 @@
           <a:p>
             <a:fld id="{E85DF616-B21E-4EF6-A6A5-95E2FB3EB1A1}" type="datetimeFigureOut">
               <a:rPr lang="en-GB" smtClean="0"/>
-              <a:t>29/01/2026</a:t>
+              <a:t>09/02/2026</a:t>
             </a:fld>
             <a:endParaRPr lang="en-GB"/>
           </a:p>
@@ -1031,7 +1031,7 @@
           <a:p>
             <a:fld id="{E85DF616-B21E-4EF6-A6A5-95E2FB3EB1A1}" type="datetimeFigureOut">
               <a:rPr lang="en-GB" smtClean="0"/>
-              <a:t>29/01/2026</a:t>
+              <a:t>09/02/2026</a:t>
             </a:fld>
             <a:endParaRPr lang="en-GB"/>
           </a:p>
@@ -1241,7 +1241,7 @@
           <a:p>
             <a:fld id="{E85DF616-B21E-4EF6-A6A5-95E2FB3EB1A1}" type="datetimeFigureOut">
               <a:rPr lang="en-GB" smtClean="0"/>
-              <a:t>29/01/2026</a:t>
+              <a:t>09/02/2026</a:t>
             </a:fld>
             <a:endParaRPr lang="en-GB"/>
           </a:p>
@@ -1441,7 +1441,7 @@
           <a:p>
             <a:fld id="{E85DF616-B21E-4EF6-A6A5-95E2FB3EB1A1}" type="datetimeFigureOut">
               <a:rPr lang="en-GB" smtClean="0"/>
-              <a:t>29/01/2026</a:t>
+              <a:t>09/02/2026</a:t>
             </a:fld>
             <a:endParaRPr lang="en-GB"/>
           </a:p>
@@ -1717,7 +1717,7 @@
           <a:p>
             <a:fld id="{E85DF616-B21E-4EF6-A6A5-95E2FB3EB1A1}" type="datetimeFigureOut">
               <a:rPr lang="en-GB" smtClean="0"/>
-              <a:t>29/01/2026</a:t>
+              <a:t>09/02/2026</a:t>
             </a:fld>
             <a:endParaRPr lang="en-GB"/>
           </a:p>
@@ -1985,7 +1985,7 @@
           <a:p>
             <a:fld id="{E85DF616-B21E-4EF6-A6A5-95E2FB3EB1A1}" type="datetimeFigureOut">
               <a:rPr lang="en-GB" smtClean="0"/>
-              <a:t>29/01/2026</a:t>
+              <a:t>09/02/2026</a:t>
             </a:fld>
             <a:endParaRPr lang="en-GB"/>
           </a:p>
@@ -2400,7 +2400,7 @@
           <a:p>
             <a:fld id="{E85DF616-B21E-4EF6-A6A5-95E2FB3EB1A1}" type="datetimeFigureOut">
               <a:rPr lang="en-GB" smtClean="0"/>
-              <a:t>29/01/2026</a:t>
+              <a:t>09/02/2026</a:t>
             </a:fld>
             <a:endParaRPr lang="en-GB"/>
           </a:p>
@@ -2542,7 +2542,7 @@
           <a:p>
             <a:fld id="{E85DF616-B21E-4EF6-A6A5-95E2FB3EB1A1}" type="datetimeFigureOut">
               <a:rPr lang="en-GB" smtClean="0"/>
-              <a:t>29/01/2026</a:t>
+              <a:t>09/02/2026</a:t>
             </a:fld>
             <a:endParaRPr lang="en-GB"/>
           </a:p>
@@ -2655,7 +2655,7 @@
           <a:p>
             <a:fld id="{E85DF616-B21E-4EF6-A6A5-95E2FB3EB1A1}" type="datetimeFigureOut">
               <a:rPr lang="en-GB" smtClean="0"/>
-              <a:t>29/01/2026</a:t>
+              <a:t>09/02/2026</a:t>
             </a:fld>
             <a:endParaRPr lang="en-GB"/>
           </a:p>
@@ -2968,7 +2968,7 @@
           <a:p>
             <a:fld id="{E85DF616-B21E-4EF6-A6A5-95E2FB3EB1A1}" type="datetimeFigureOut">
               <a:rPr lang="en-GB" smtClean="0"/>
-              <a:t>29/01/2026</a:t>
+              <a:t>09/02/2026</a:t>
             </a:fld>
             <a:endParaRPr lang="en-GB"/>
           </a:p>
@@ -3257,7 +3257,7 @@
           <a:p>
             <a:fld id="{E85DF616-B21E-4EF6-A6A5-95E2FB3EB1A1}" type="datetimeFigureOut">
               <a:rPr lang="en-GB" smtClean="0"/>
-              <a:t>29/01/2026</a:t>
+              <a:t>09/02/2026</a:t>
             </a:fld>
             <a:endParaRPr lang="en-GB"/>
           </a:p>
@@ -3500,7 +3500,7 @@
           <a:p>
             <a:fld id="{E85DF616-B21E-4EF6-A6A5-95E2FB3EB1A1}" type="datetimeFigureOut">
               <a:rPr lang="en-GB" smtClean="0"/>
-              <a:t>29/01/2026</a:t>
+              <a:t>09/02/2026</a:t>
             </a:fld>
             <a:endParaRPr lang="en-GB"/>
           </a:p>
@@ -12550,11 +12550,15 @@
             </a:pPr>
             <a:r>
               <a:rPr lang="en-GB" b="1" i="1" dirty="0"/>
-              <a:t>Also the option of using </a:t>
+              <a:t>Also, you have the option of using </a:t>
             </a:r>
             <a:r>
               <a:rPr lang="en-GB" b="1" i="1" u="sng" dirty="0"/>
               <a:t>MPS</a:t>
+            </a:r>
+            <a:r>
+              <a:rPr lang="en-GB" b="1" i="1" dirty="0"/>
+              <a:t> instead of Nvidia CUDA.</a:t>
             </a:r>
             <a:br>
               <a:rPr lang="en-GB" b="1" i="1" u="sng" dirty="0"/>
@@ -12570,18 +12574,8 @@
             </a:pPr>
             <a:r>
               <a:rPr lang="en-GB" b="1" i="1" dirty="0"/>
-              <a:t>Careful, as of Feb 2025, float64 is not a valid datatype in MPS, might need to use float32 in notebooks instead.</a:t>
-            </a:r>
-          </a:p>
-          <a:p>
-            <a:pPr marL="0" indent="0">
-              <a:buNone/>
-            </a:pPr>
-            <a:r>
-              <a:rPr lang="en-GB" b="1" i="1" dirty="0"/>
-              <a:t>Possibly more adjustments needed…</a:t>
-            </a:r>
-            <a:endParaRPr lang="en-SG" b="1" i="1" dirty="0"/>
+              <a:t>Careful, as of Feb 2025, float64 is not a valid datatype in MPS, might need to use float32 in notebooks instead for both dataset tensors and NN parameters tensors…</a:t>
+            </a:r>
           </a:p>
         </p:txBody>
       </p:sp>
@@ -12607,8 +12601,38 @@
         </p:blipFill>
         <p:spPr>
           <a:xfrm>
-            <a:off x="6096000" y="1773380"/>
-            <a:ext cx="5856514" cy="4356085"/>
+            <a:off x="7265669" y="1490351"/>
+            <a:ext cx="4593771" cy="3416855"/>
+          </a:xfrm>
+          <a:prstGeom prst="rect">
+            <a:avLst/>
+          </a:prstGeom>
+        </p:spPr>
+      </p:pic>
+      <p:pic>
+        <p:nvPicPr>
+          <p:cNvPr id="5" name="Picture 4">
+            <a:extLst>
+              <a:ext uri="{FF2B5EF4-FFF2-40B4-BE49-F238E27FC236}">
+                <a16:creationId xmlns:a16="http://schemas.microsoft.com/office/drawing/2014/main" id="{E48213F1-73C2-7DD1-776B-482E90DC8092}"/>
+              </a:ext>
+            </a:extLst>
+          </p:cNvPr>
+          <p:cNvPicPr>
+            <a:picLocks noChangeAspect="1"/>
+          </p:cNvPicPr>
+          <p:nvPr/>
+        </p:nvPicPr>
+        <p:blipFill>
+          <a:blip r:embed="rId3"/>
+          <a:stretch>
+            <a:fillRect/>
+          </a:stretch>
+        </p:blipFill>
+        <p:spPr>
+          <a:xfrm>
+            <a:off x="6019800" y="5042142"/>
+            <a:ext cx="5839640" cy="1476581"/>
           </a:xfrm>
           <a:prstGeom prst="rect">
             <a:avLst/>

</xml_diff>